<commit_message>
database sql 추가, python ppt 실습 추가
</commit_message>
<xml_diff>
--- a/material/DB/08_파이썬과함께쓰기.pptx
+++ b/material/DB/08_파이썬과함께쓰기.pptx
@@ -5,7 +5,7 @@
     <p:sldMasterId id="2147483660" r:id="rId1"/>
   </p:sldMasterIdLst>
   <p:notesMasterIdLst>
-    <p:notesMasterId r:id="rId63"/>
+    <p:notesMasterId r:id="rId65"/>
   </p:notesMasterIdLst>
   <p:sldIdLst>
     <p:sldId id="790" r:id="rId2"/>
@@ -21,54 +21,56 @@
     <p:sldId id="999" r:id="rId12"/>
     <p:sldId id="1000" r:id="rId13"/>
     <p:sldId id="1001" r:id="rId14"/>
-    <p:sldId id="990" r:id="rId15"/>
-    <p:sldId id="1002" r:id="rId16"/>
-    <p:sldId id="1007" r:id="rId17"/>
-    <p:sldId id="1012" r:id="rId18"/>
-    <p:sldId id="1013" r:id="rId19"/>
-    <p:sldId id="1014" r:id="rId20"/>
-    <p:sldId id="1015" r:id="rId21"/>
-    <p:sldId id="1021" r:id="rId22"/>
-    <p:sldId id="1008" r:id="rId23"/>
-    <p:sldId id="1009" r:id="rId24"/>
-    <p:sldId id="1010" r:id="rId25"/>
-    <p:sldId id="1047" r:id="rId26"/>
-    <p:sldId id="1011" r:id="rId27"/>
-    <p:sldId id="1016" r:id="rId28"/>
-    <p:sldId id="1017" r:id="rId29"/>
-    <p:sldId id="1018" r:id="rId30"/>
-    <p:sldId id="1019" r:id="rId31"/>
-    <p:sldId id="1020" r:id="rId32"/>
-    <p:sldId id="1031" r:id="rId33"/>
-    <p:sldId id="1003" r:id="rId34"/>
-    <p:sldId id="1004" r:id="rId35"/>
-    <p:sldId id="1005" r:id="rId36"/>
-    <p:sldId id="1006" r:id="rId37"/>
-    <p:sldId id="1022" r:id="rId38"/>
-    <p:sldId id="1023" r:id="rId39"/>
-    <p:sldId id="1024" r:id="rId40"/>
-    <p:sldId id="1025" r:id="rId41"/>
-    <p:sldId id="1026" r:id="rId42"/>
-    <p:sldId id="1027" r:id="rId43"/>
-    <p:sldId id="1028" r:id="rId44"/>
-    <p:sldId id="1029" r:id="rId45"/>
-    <p:sldId id="1030" r:id="rId46"/>
-    <p:sldId id="1032" r:id="rId47"/>
-    <p:sldId id="1041" r:id="rId48"/>
-    <p:sldId id="1033" r:id="rId49"/>
-    <p:sldId id="1035" r:id="rId50"/>
-    <p:sldId id="1034" r:id="rId51"/>
-    <p:sldId id="1036" r:id="rId52"/>
-    <p:sldId id="1037" r:id="rId53"/>
-    <p:sldId id="1038" r:id="rId54"/>
-    <p:sldId id="1039" r:id="rId55"/>
-    <p:sldId id="1040" r:id="rId56"/>
-    <p:sldId id="1042" r:id="rId57"/>
-    <p:sldId id="1046" r:id="rId58"/>
-    <p:sldId id="1043" r:id="rId59"/>
-    <p:sldId id="1044" r:id="rId60"/>
-    <p:sldId id="1045" r:id="rId61"/>
-    <p:sldId id="813" r:id="rId62"/>
+    <p:sldId id="1048" r:id="rId15"/>
+    <p:sldId id="1049" r:id="rId16"/>
+    <p:sldId id="990" r:id="rId17"/>
+    <p:sldId id="1002" r:id="rId18"/>
+    <p:sldId id="1007" r:id="rId19"/>
+    <p:sldId id="1012" r:id="rId20"/>
+    <p:sldId id="1013" r:id="rId21"/>
+    <p:sldId id="1014" r:id="rId22"/>
+    <p:sldId id="1015" r:id="rId23"/>
+    <p:sldId id="1021" r:id="rId24"/>
+    <p:sldId id="1008" r:id="rId25"/>
+    <p:sldId id="1009" r:id="rId26"/>
+    <p:sldId id="1010" r:id="rId27"/>
+    <p:sldId id="1047" r:id="rId28"/>
+    <p:sldId id="1011" r:id="rId29"/>
+    <p:sldId id="1016" r:id="rId30"/>
+    <p:sldId id="1017" r:id="rId31"/>
+    <p:sldId id="1018" r:id="rId32"/>
+    <p:sldId id="1019" r:id="rId33"/>
+    <p:sldId id="1020" r:id="rId34"/>
+    <p:sldId id="1031" r:id="rId35"/>
+    <p:sldId id="1003" r:id="rId36"/>
+    <p:sldId id="1004" r:id="rId37"/>
+    <p:sldId id="1005" r:id="rId38"/>
+    <p:sldId id="1006" r:id="rId39"/>
+    <p:sldId id="1022" r:id="rId40"/>
+    <p:sldId id="1023" r:id="rId41"/>
+    <p:sldId id="1024" r:id="rId42"/>
+    <p:sldId id="1025" r:id="rId43"/>
+    <p:sldId id="1026" r:id="rId44"/>
+    <p:sldId id="1027" r:id="rId45"/>
+    <p:sldId id="1028" r:id="rId46"/>
+    <p:sldId id="1029" r:id="rId47"/>
+    <p:sldId id="1030" r:id="rId48"/>
+    <p:sldId id="1032" r:id="rId49"/>
+    <p:sldId id="1041" r:id="rId50"/>
+    <p:sldId id="1033" r:id="rId51"/>
+    <p:sldId id="1035" r:id="rId52"/>
+    <p:sldId id="1034" r:id="rId53"/>
+    <p:sldId id="1036" r:id="rId54"/>
+    <p:sldId id="1037" r:id="rId55"/>
+    <p:sldId id="1038" r:id="rId56"/>
+    <p:sldId id="1039" r:id="rId57"/>
+    <p:sldId id="1040" r:id="rId58"/>
+    <p:sldId id="1042" r:id="rId59"/>
+    <p:sldId id="1046" r:id="rId60"/>
+    <p:sldId id="1043" r:id="rId61"/>
+    <p:sldId id="1044" r:id="rId62"/>
+    <p:sldId id="1045" r:id="rId63"/>
+    <p:sldId id="813" r:id="rId64"/>
   </p:sldIdLst>
   <p:sldSz cx="12192000" cy="6858000"/>
   <p:notesSz cx="6858000" cy="9144000"/>
@@ -278,7 +280,7 @@
             <a:fld id="{A13A867C-D490-40C2-AB8D-A60FA70A9BF5}" type="datetimeFigureOut">
               <a:rPr lang="ko-KR" altLang="en-US" smtClean="0"/>
               <a:pPr/>
-              <a:t>2025-10-28</a:t>
+              <a:t>2025-10-29</a:t>
             </a:fld>
             <a:endParaRPr lang="ko-KR" altLang="en-US" dirty="0"/>
           </a:p>
@@ -952,7 +954,7 @@
             <a:fld id="{3E35EA20-6519-4513-9EDC-C89C5369BAEC}" type="slidenum">
               <a:rPr lang="ko-KR" altLang="en-US" smtClean="0"/>
               <a:pPr/>
-              <a:t>15</a:t>
+              <a:t>17</a:t>
             </a:fld>
             <a:endParaRPr lang="ko-KR" altLang="en-US" dirty="0"/>
           </a:p>
@@ -1060,7 +1062,7 @@
           <a:p>
             <a:fld id="{3E35EA20-6519-4513-9EDC-C89C5369BAEC}" type="slidenum">
               <a:rPr lang="ko-KR" altLang="en-US" smtClean="0"/>
-              <a:t>22</a:t>
+              <a:t>24</a:t>
             </a:fld>
             <a:endParaRPr lang="ko-KR" altLang="en-US"/>
           </a:p>
@@ -1168,7 +1170,7 @@
           <a:p>
             <a:fld id="{3E35EA20-6519-4513-9EDC-C89C5369BAEC}" type="slidenum">
               <a:rPr lang="ko-KR" altLang="en-US" smtClean="0"/>
-              <a:t>23</a:t>
+              <a:t>25</a:t>
             </a:fld>
             <a:endParaRPr lang="ko-KR" altLang="en-US"/>
           </a:p>
@@ -1296,7 +1298,7 @@
           <a:p>
             <a:fld id="{3E35EA20-6519-4513-9EDC-C89C5369BAEC}" type="slidenum">
               <a:rPr lang="ko-KR" altLang="en-US" smtClean="0"/>
-              <a:t>24</a:t>
+              <a:t>26</a:t>
             </a:fld>
             <a:endParaRPr lang="ko-KR" altLang="en-US"/>
           </a:p>
@@ -1465,7 +1467,7 @@
           <a:p>
             <a:fld id="{3E35EA20-6519-4513-9EDC-C89C5369BAEC}" type="slidenum">
               <a:rPr lang="ko-KR" altLang="en-US" smtClean="0"/>
-              <a:t>25</a:t>
+              <a:t>27</a:t>
             </a:fld>
             <a:endParaRPr lang="ko-KR" altLang="en-US"/>
           </a:p>
@@ -1573,7 +1575,7 @@
           <a:p>
             <a:fld id="{3E35EA20-6519-4513-9EDC-C89C5369BAEC}" type="slidenum">
               <a:rPr lang="ko-KR" altLang="en-US" smtClean="0"/>
-              <a:t>26</a:t>
+              <a:t>28</a:t>
             </a:fld>
             <a:endParaRPr lang="ko-KR" altLang="en-US"/>
           </a:p>
@@ -1681,7 +1683,7 @@
           <a:p>
             <a:fld id="{3E35EA20-6519-4513-9EDC-C89C5369BAEC}" type="slidenum">
               <a:rPr lang="ko-KR" altLang="en-US" smtClean="0"/>
-              <a:t>27</a:t>
+              <a:t>29</a:t>
             </a:fld>
             <a:endParaRPr lang="ko-KR" altLang="en-US"/>
           </a:p>
@@ -1797,7 +1799,7 @@
           <a:p>
             <a:fld id="{3E35EA20-6519-4513-9EDC-C89C5369BAEC}" type="slidenum">
               <a:rPr lang="ko-KR" altLang="en-US" smtClean="0"/>
-              <a:t>28</a:t>
+              <a:t>30</a:t>
             </a:fld>
             <a:endParaRPr lang="ko-KR" altLang="en-US"/>
           </a:p>
@@ -2043,7 +2045,7 @@
           <a:p>
             <a:fld id="{3E35EA20-6519-4513-9EDC-C89C5369BAEC}" type="slidenum">
               <a:rPr lang="ko-KR" altLang="en-US" smtClean="0"/>
-              <a:t>29</a:t>
+              <a:t>31</a:t>
             </a:fld>
             <a:endParaRPr lang="ko-KR" altLang="en-US"/>
           </a:p>
@@ -2151,7 +2153,7 @@
           <a:p>
             <a:fld id="{3E35EA20-6519-4513-9EDC-C89C5369BAEC}" type="slidenum">
               <a:rPr lang="ko-KR" altLang="en-US" smtClean="0"/>
-              <a:t>30</a:t>
+              <a:t>32</a:t>
             </a:fld>
             <a:endParaRPr lang="ko-KR" altLang="en-US"/>
           </a:p>
@@ -2259,7 +2261,7 @@
           <a:p>
             <a:fld id="{3E35EA20-6519-4513-9EDC-C89C5369BAEC}" type="slidenum">
               <a:rPr lang="ko-KR" altLang="en-US" smtClean="0"/>
-              <a:t>31</a:t>
+              <a:t>33</a:t>
             </a:fld>
             <a:endParaRPr lang="ko-KR" altLang="en-US"/>
           </a:p>
@@ -2367,7 +2369,7 @@
           <a:p>
             <a:fld id="{3E35EA20-6519-4513-9EDC-C89C5369BAEC}" type="slidenum">
               <a:rPr lang="ko-KR" altLang="en-US" smtClean="0"/>
-              <a:t>34</a:t>
+              <a:t>36</a:t>
             </a:fld>
             <a:endParaRPr lang="ko-KR" altLang="en-US"/>
           </a:p>
@@ -2475,7 +2477,7 @@
           <a:p>
             <a:fld id="{3E35EA20-6519-4513-9EDC-C89C5369BAEC}" type="slidenum">
               <a:rPr lang="ko-KR" altLang="en-US" smtClean="0"/>
-              <a:t>35</a:t>
+              <a:t>37</a:t>
             </a:fld>
             <a:endParaRPr lang="ko-KR" altLang="en-US"/>
           </a:p>
@@ -2583,7 +2585,7 @@
           <a:p>
             <a:fld id="{3E35EA20-6519-4513-9EDC-C89C5369BAEC}" type="slidenum">
               <a:rPr lang="ko-KR" altLang="en-US" smtClean="0"/>
-              <a:t>36</a:t>
+              <a:t>38</a:t>
             </a:fld>
             <a:endParaRPr lang="ko-KR" altLang="en-US"/>
           </a:p>
@@ -2691,7 +2693,7 @@
           <a:p>
             <a:fld id="{3E35EA20-6519-4513-9EDC-C89C5369BAEC}" type="slidenum">
               <a:rPr lang="ko-KR" altLang="en-US" smtClean="0"/>
-              <a:t>37</a:t>
+              <a:t>39</a:t>
             </a:fld>
             <a:endParaRPr lang="ko-KR" altLang="en-US"/>
           </a:p>
@@ -2799,7 +2801,7 @@
           <a:p>
             <a:fld id="{3E35EA20-6519-4513-9EDC-C89C5369BAEC}" type="slidenum">
               <a:rPr lang="ko-KR" altLang="en-US" smtClean="0"/>
-              <a:t>38</a:t>
+              <a:t>40</a:t>
             </a:fld>
             <a:endParaRPr lang="ko-KR" altLang="en-US"/>
           </a:p>
@@ -2907,7 +2909,7 @@
           <a:p>
             <a:fld id="{3E35EA20-6519-4513-9EDC-C89C5369BAEC}" type="slidenum">
               <a:rPr lang="ko-KR" altLang="en-US" smtClean="0"/>
-              <a:t>39</a:t>
+              <a:t>41</a:t>
             </a:fld>
             <a:endParaRPr lang="ko-KR" altLang="en-US"/>
           </a:p>
@@ -3015,7 +3017,7 @@
           <a:p>
             <a:fld id="{3E35EA20-6519-4513-9EDC-C89C5369BAEC}" type="slidenum">
               <a:rPr lang="ko-KR" altLang="en-US" smtClean="0"/>
-              <a:t>40</a:t>
+              <a:t>42</a:t>
             </a:fld>
             <a:endParaRPr lang="ko-KR" altLang="en-US"/>
           </a:p>
@@ -3235,7 +3237,7 @@
           <a:p>
             <a:fld id="{3E35EA20-6519-4513-9EDC-C89C5369BAEC}" type="slidenum">
               <a:rPr lang="ko-KR" altLang="en-US" smtClean="0"/>
-              <a:t>41</a:t>
+              <a:t>43</a:t>
             </a:fld>
             <a:endParaRPr lang="ko-KR" altLang="en-US"/>
           </a:p>
@@ -3343,7 +3345,7 @@
           <a:p>
             <a:fld id="{3E35EA20-6519-4513-9EDC-C89C5369BAEC}" type="slidenum">
               <a:rPr lang="ko-KR" altLang="en-US" smtClean="0"/>
-              <a:t>42</a:t>
+              <a:t>44</a:t>
             </a:fld>
             <a:endParaRPr lang="ko-KR" altLang="en-US"/>
           </a:p>
@@ -3451,7 +3453,7 @@
           <a:p>
             <a:fld id="{3E35EA20-6519-4513-9EDC-C89C5369BAEC}" type="slidenum">
               <a:rPr lang="ko-KR" altLang="en-US" smtClean="0"/>
-              <a:t>43</a:t>
+              <a:t>45</a:t>
             </a:fld>
             <a:endParaRPr lang="ko-KR" altLang="en-US"/>
           </a:p>
@@ -3559,7 +3561,7 @@
           <a:p>
             <a:fld id="{3E35EA20-6519-4513-9EDC-C89C5369BAEC}" type="slidenum">
               <a:rPr lang="ko-KR" altLang="en-US" smtClean="0"/>
-              <a:t>44</a:t>
+              <a:t>46</a:t>
             </a:fld>
             <a:endParaRPr lang="ko-KR" altLang="en-US"/>
           </a:p>
@@ -3667,7 +3669,7 @@
           <a:p>
             <a:fld id="{3E35EA20-6519-4513-9EDC-C89C5369BAEC}" type="slidenum">
               <a:rPr lang="ko-KR" altLang="en-US" smtClean="0"/>
-              <a:t>45</a:t>
+              <a:t>47</a:t>
             </a:fld>
             <a:endParaRPr lang="ko-KR" altLang="en-US"/>
           </a:p>
@@ -3775,7 +3777,7 @@
           <a:p>
             <a:fld id="{A0085365-8376-4996-BDD6-F39608FADAF3}" type="slidenum">
               <a:rPr lang="ko-KR" altLang="en-US" smtClean="0"/>
-              <a:t>61</a:t>
+              <a:t>63</a:t>
             </a:fld>
             <a:endParaRPr lang="ko-KR" altLang="en-US"/>
           </a:p>
@@ -4612,7 +4614,7 @@
           <a:p>
             <a:fld id="{442BEE3F-2E9A-4FD8-8B8A-8619F3E161C0}" type="datetime1">
               <a:rPr lang="ko-KR" altLang="en-US" smtClean="0"/>
-              <a:t>2025-10-28</a:t>
+              <a:t>2025-10-29</a:t>
             </a:fld>
             <a:endParaRPr lang="ko-KR" altLang="en-US"/>
           </a:p>
@@ -4899,7 +4901,7 @@
           <a:p>
             <a:fld id="{0F78D9C4-20C1-4B15-A116-16DC77AD9A1E}" type="datetime1">
               <a:rPr lang="ko-KR" altLang="en-US" smtClean="0"/>
-              <a:t>2025-10-28</a:t>
+              <a:t>2025-10-29</a:t>
             </a:fld>
             <a:endParaRPr lang="ko-KR" altLang="en-US"/>
           </a:p>
@@ -5074,7 +5076,7 @@
           <a:p>
             <a:fld id="{7F5E23C3-0E3D-4E4E-8486-D7FB4C073DC1}" type="datetime1">
               <a:rPr lang="ko-KR" altLang="en-US" smtClean="0"/>
-              <a:t>2025-10-28</a:t>
+              <a:t>2025-10-29</a:t>
             </a:fld>
             <a:endParaRPr lang="ko-KR" altLang="en-US"/>
           </a:p>
@@ -5403,7 +5405,7 @@
           <a:p>
             <a:fld id="{7F5E23C3-0E3D-4E4E-8486-D7FB4C073DC1}" type="datetime1">
               <a:rPr lang="ko-KR" altLang="en-US" smtClean="0"/>
-              <a:t>2025-10-28</a:t>
+              <a:t>2025-10-29</a:t>
             </a:fld>
             <a:endParaRPr lang="ko-KR" altLang="en-US"/>
           </a:p>
@@ -6967,6 +6969,352 @@
   <p:cSld>
     <p:spTree>
       <p:nvGrpSpPr>
+        <p:cNvPr id="1" name=""/>
+        <p:cNvGrpSpPr/>
+        <p:nvPr/>
+      </p:nvGrpSpPr>
+      <p:grpSpPr>
+        <a:xfrm>
+          <a:off x="0" y="0"/>
+          <a:ext cx="0" cy="0"/>
+          <a:chOff x="0" y="0"/>
+          <a:chExt cx="0" cy="0"/>
+        </a:xfrm>
+      </p:grpSpPr>
+      <p:sp>
+        <p:nvSpPr>
+          <p:cNvPr id="2" name="제목 1">
+            <a:extLst>
+              <a:ext uri="{FF2B5EF4-FFF2-40B4-BE49-F238E27FC236}">
+                <a16:creationId xmlns:a16="http://schemas.microsoft.com/office/drawing/2014/main" id="{DF8B4554-274A-DD20-0D99-D32B473B260E}"/>
+              </a:ext>
+            </a:extLst>
+          </p:cNvPr>
+          <p:cNvSpPr>
+            <a:spLocks noGrp="1"/>
+          </p:cNvSpPr>
+          <p:nvPr>
+            <p:ph type="title"/>
+          </p:nvPr>
+        </p:nvSpPr>
+        <p:spPr/>
+        <p:txBody>
+          <a:bodyPr/>
+          <a:lstStyle/>
+          <a:p>
+            <a:r>
+              <a:rPr lang="en-US" altLang="ko-KR" dirty="0">
+                <a:solidFill>
+                  <a:schemeClr val="accent2"/>
+                </a:solidFill>
+              </a:rPr>
+              <a:t>CRUD</a:t>
+            </a:r>
+            <a:r>
+              <a:rPr lang="ko-KR" altLang="en-US" dirty="0">
+                <a:solidFill>
+                  <a:schemeClr val="accent2"/>
+                </a:solidFill>
+              </a:rPr>
+              <a:t> 실습</a:t>
+            </a:r>
+          </a:p>
+        </p:txBody>
+      </p:sp>
+      <p:sp>
+        <p:nvSpPr>
+          <p:cNvPr id="3" name="내용 개체 틀 2">
+            <a:extLst>
+              <a:ext uri="{FF2B5EF4-FFF2-40B4-BE49-F238E27FC236}">
+                <a16:creationId xmlns:a16="http://schemas.microsoft.com/office/drawing/2014/main" id="{7B82156E-97C7-68FA-63F4-B708AFBB6AC2}"/>
+              </a:ext>
+            </a:extLst>
+          </p:cNvPr>
+          <p:cNvSpPr>
+            <a:spLocks noGrp="1"/>
+          </p:cNvSpPr>
+          <p:nvPr>
+            <p:ph idx="1"/>
+          </p:nvPr>
+        </p:nvSpPr>
+        <p:spPr/>
+        <p:txBody>
+          <a:bodyPr/>
+          <a:lstStyle/>
+          <a:p>
+            <a:r>
+              <a:rPr lang="ko-KR" altLang="en-US" dirty="0"/>
+              <a:t>테이블명</a:t>
+            </a:r>
+            <a:r>
+              <a:rPr lang="en-US" altLang="ko-KR" dirty="0"/>
+              <a:t>: posts</a:t>
+            </a:r>
+          </a:p>
+          <a:p>
+            <a:r>
+              <a:rPr lang="ko-KR" altLang="en-US" dirty="0"/>
+              <a:t>컬럼</a:t>
+            </a:r>
+            <a:br>
+              <a:rPr lang="en-US" altLang="ko-KR" dirty="0"/>
+            </a:br>
+            <a:r>
+              <a:rPr lang="en-US" altLang="ko-KR" dirty="0"/>
+              <a:t>id: </a:t>
+            </a:r>
+            <a:r>
+              <a:rPr lang="ko-KR" altLang="en-US" dirty="0"/>
+              <a:t>글 고유번호 </a:t>
+            </a:r>
+            <a:r>
+              <a:rPr lang="en-US" altLang="ko-KR" dirty="0"/>
+              <a:t>(INT, PRIMARY KEY, AUTO_INCREMENT)</a:t>
+            </a:r>
+            <a:br>
+              <a:rPr lang="en-US" altLang="ko-KR" dirty="0"/>
+            </a:br>
+            <a:r>
+              <a:rPr lang="en-US" altLang="ko-KR" dirty="0"/>
+              <a:t>author: </a:t>
+            </a:r>
+            <a:r>
+              <a:rPr lang="ko-KR" altLang="en-US" dirty="0"/>
+              <a:t>작성자 이름 </a:t>
+            </a:r>
+            <a:r>
+              <a:rPr lang="en-US" altLang="ko-KR" dirty="0"/>
+              <a:t>(VARCHAR(50))</a:t>
+            </a:r>
+            <a:br>
+              <a:rPr lang="en-US" altLang="ko-KR" dirty="0"/>
+            </a:br>
+            <a:r>
+              <a:rPr lang="en-US" altLang="ko-KR" dirty="0"/>
+              <a:t>content: </a:t>
+            </a:r>
+            <a:r>
+              <a:rPr lang="ko-KR" altLang="en-US" dirty="0"/>
+              <a:t>글 내용 </a:t>
+            </a:r>
+            <a:r>
+              <a:rPr lang="en-US" altLang="ko-KR" dirty="0"/>
+              <a:t>(TEXT)</a:t>
+            </a:r>
+            <a:br>
+              <a:rPr lang="en-US" altLang="ko-KR" dirty="0"/>
+            </a:br>
+            <a:r>
+              <a:rPr lang="en-US" altLang="ko-KR" dirty="0" err="1"/>
+              <a:t>created_at</a:t>
+            </a:r>
+            <a:r>
+              <a:rPr lang="en-US" altLang="ko-KR" dirty="0"/>
+              <a:t>: </a:t>
+            </a:r>
+            <a:r>
+              <a:rPr lang="ko-KR" altLang="en-US" dirty="0"/>
+              <a:t>작성 시간 </a:t>
+            </a:r>
+            <a:r>
+              <a:rPr lang="en-US" altLang="ko-KR" dirty="0"/>
+              <a:t>(TIMESTAMP, DEFAULT CURRENT_TIMESTAMP)</a:t>
+            </a:r>
+            <a:endParaRPr lang="ko-KR" altLang="en-US" dirty="0"/>
+          </a:p>
+        </p:txBody>
+      </p:sp>
+    </p:spTree>
+    <p:extLst>
+      <p:ext uri="{BB962C8B-B14F-4D97-AF65-F5344CB8AC3E}">
+        <p14:creationId xmlns:p14="http://schemas.microsoft.com/office/powerpoint/2010/main" val="1235474462"/>
+      </p:ext>
+    </p:extLst>
+  </p:cSld>
+  <p:clrMapOvr>
+    <a:masterClrMapping/>
+  </p:clrMapOvr>
+</p:sld>
+</file>
+
+<file path=ppt/slides/slide15.xml><?xml version="1.0" encoding="utf-8"?>
+<p:sld xmlns:a="http://schemas.openxmlformats.org/drawingml/2006/main" xmlns:r="http://schemas.openxmlformats.org/officeDocument/2006/relationships" xmlns:p="http://schemas.openxmlformats.org/presentationml/2006/main">
+  <p:cSld>
+    <p:spTree>
+      <p:nvGrpSpPr>
+        <p:cNvPr id="1" name="">
+          <a:extLst>
+            <a:ext uri="{FF2B5EF4-FFF2-40B4-BE49-F238E27FC236}">
+              <a16:creationId xmlns:a16="http://schemas.microsoft.com/office/drawing/2014/main" id="{348A79FB-17D3-27F5-9C79-8FB72BDD6258}"/>
+            </a:ext>
+          </a:extLst>
+        </p:cNvPr>
+        <p:cNvGrpSpPr/>
+        <p:nvPr/>
+      </p:nvGrpSpPr>
+      <p:grpSpPr>
+        <a:xfrm>
+          <a:off x="0" y="0"/>
+          <a:ext cx="0" cy="0"/>
+          <a:chOff x="0" y="0"/>
+          <a:chExt cx="0" cy="0"/>
+        </a:xfrm>
+      </p:grpSpPr>
+      <p:sp>
+        <p:nvSpPr>
+          <p:cNvPr id="2" name="제목 1">
+            <a:extLst>
+              <a:ext uri="{FF2B5EF4-FFF2-40B4-BE49-F238E27FC236}">
+                <a16:creationId xmlns:a16="http://schemas.microsoft.com/office/drawing/2014/main" id="{FC0D3CA7-B9A2-8E7F-7FD2-D5996F56F305}"/>
+              </a:ext>
+            </a:extLst>
+          </p:cNvPr>
+          <p:cNvSpPr>
+            <a:spLocks noGrp="1"/>
+          </p:cNvSpPr>
+          <p:nvPr>
+            <p:ph type="title"/>
+          </p:nvPr>
+        </p:nvSpPr>
+        <p:spPr/>
+        <p:txBody>
+          <a:bodyPr/>
+          <a:lstStyle/>
+          <a:p>
+            <a:r>
+              <a:rPr lang="en-US" altLang="ko-KR" dirty="0">
+                <a:solidFill>
+                  <a:schemeClr val="accent2"/>
+                </a:solidFill>
+              </a:rPr>
+              <a:t>CRUD</a:t>
+            </a:r>
+            <a:r>
+              <a:rPr lang="ko-KR" altLang="en-US" dirty="0">
+                <a:solidFill>
+                  <a:schemeClr val="accent2"/>
+                </a:solidFill>
+              </a:rPr>
+              <a:t> 실습</a:t>
+            </a:r>
+          </a:p>
+        </p:txBody>
+      </p:sp>
+      <p:sp>
+        <p:nvSpPr>
+          <p:cNvPr id="3" name="내용 개체 틀 2">
+            <a:extLst>
+              <a:ext uri="{FF2B5EF4-FFF2-40B4-BE49-F238E27FC236}">
+                <a16:creationId xmlns:a16="http://schemas.microsoft.com/office/drawing/2014/main" id="{B6D04368-2E47-063D-6980-298F86B6C10B}"/>
+              </a:ext>
+            </a:extLst>
+          </p:cNvPr>
+          <p:cNvSpPr>
+            <a:spLocks noGrp="1"/>
+          </p:cNvSpPr>
+          <p:nvPr>
+            <p:ph idx="1"/>
+          </p:nvPr>
+        </p:nvSpPr>
+        <p:spPr/>
+        <p:txBody>
+          <a:bodyPr/>
+          <a:lstStyle/>
+          <a:p>
+            <a:pPr marL="514350" indent="-514350">
+              <a:buFont typeface="+mj-lt"/>
+              <a:buAutoNum type="arabicPeriod"/>
+            </a:pPr>
+            <a:r>
+              <a:rPr lang="en-US" altLang="ko-KR" dirty="0"/>
+              <a:t>CREATE – </a:t>
+            </a:r>
+            <a:r>
+              <a:rPr lang="ko-KR" altLang="en-US" dirty="0"/>
+              <a:t>새 글 작성</a:t>
+            </a:r>
+            <a:endParaRPr lang="en-US" altLang="ko-KR" dirty="0"/>
+          </a:p>
+          <a:p>
+            <a:pPr marL="514350" indent="-514350">
+              <a:buFont typeface="+mj-lt"/>
+              <a:buAutoNum type="arabicPeriod"/>
+            </a:pPr>
+            <a:r>
+              <a:rPr lang="en-US" altLang="ko-KR" dirty="0"/>
+              <a:t>READ – 1) </a:t>
+            </a:r>
+            <a:r>
+              <a:rPr lang="ko-KR" altLang="en-US" dirty="0"/>
+              <a:t>최신순으로 불러오기 </a:t>
+            </a:r>
+            <a:r>
+              <a:rPr lang="en-US" altLang="ko-KR" dirty="0"/>
+              <a:t>2) </a:t>
+            </a:r>
+            <a:r>
+              <a:rPr lang="ko-KR" altLang="en-US" dirty="0"/>
+              <a:t>특정 작성자의 글만 불러오기</a:t>
+            </a:r>
+            <a:endParaRPr lang="en-US" altLang="ko-KR" dirty="0"/>
+          </a:p>
+          <a:p>
+            <a:pPr marL="514350" indent="-514350">
+              <a:buFont typeface="+mj-lt"/>
+              <a:buAutoNum type="arabicPeriod"/>
+            </a:pPr>
+            <a:r>
+              <a:rPr lang="en-US" altLang="ko-KR" dirty="0"/>
+              <a:t>UPDATE – </a:t>
+            </a:r>
+            <a:r>
+              <a:rPr lang="ko-KR" altLang="en-US" dirty="0"/>
+              <a:t>기존 글 수정하기</a:t>
+            </a:r>
+            <a:endParaRPr lang="en-US" altLang="ko-KR" dirty="0"/>
+          </a:p>
+          <a:p>
+            <a:pPr marL="514350" indent="-514350">
+              <a:buFont typeface="+mj-lt"/>
+              <a:buAutoNum type="arabicPeriod"/>
+            </a:pPr>
+            <a:r>
+              <a:rPr lang="en-US" altLang="ko-KR" dirty="0"/>
+              <a:t>DELETE – </a:t>
+            </a:r>
+            <a:r>
+              <a:rPr lang="ko-KR" altLang="en-US" dirty="0"/>
+              <a:t>특정 글 삭제하기</a:t>
+            </a:r>
+            <a:endParaRPr lang="en-US" altLang="ko-KR" dirty="0"/>
+          </a:p>
+          <a:p>
+            <a:pPr marL="514350" indent="-514350">
+              <a:buFont typeface="+mj-lt"/>
+              <a:buAutoNum type="arabicPeriod"/>
+            </a:pPr>
+            <a:endParaRPr lang="ko-KR" altLang="en-US" dirty="0"/>
+          </a:p>
+        </p:txBody>
+      </p:sp>
+    </p:spTree>
+    <p:extLst>
+      <p:ext uri="{BB962C8B-B14F-4D97-AF65-F5344CB8AC3E}">
+        <p14:creationId xmlns:p14="http://schemas.microsoft.com/office/powerpoint/2010/main" val="1603704445"/>
+      </p:ext>
+    </p:extLst>
+  </p:cSld>
+  <p:clrMapOvr>
+    <a:masterClrMapping/>
+  </p:clrMapOvr>
+</p:sld>
+</file>
+
+<file path=ppt/slides/slide16.xml><?xml version="1.0" encoding="utf-8"?>
+<p:sld xmlns:a="http://schemas.openxmlformats.org/drawingml/2006/main" xmlns:r="http://schemas.openxmlformats.org/officeDocument/2006/relationships" xmlns:p="http://schemas.openxmlformats.org/presentationml/2006/main">
+  <p:cSld>
+    <p:spTree>
+      <p:nvGrpSpPr>
         <p:cNvPr id="1" name="">
           <a:extLst>
             <a:ext uri="{FF2B5EF4-FFF2-40B4-BE49-F238E27FC236}">
@@ -7057,7 +7405,7 @@
 </p:sld>
 </file>
 
-<file path=ppt/slides/slide15.xml><?xml version="1.0" encoding="utf-8"?>
+<file path=ppt/slides/slide17.xml><?xml version="1.0" encoding="utf-8"?>
 <p:sld xmlns:a="http://schemas.openxmlformats.org/drawingml/2006/main" xmlns:r="http://schemas.openxmlformats.org/officeDocument/2006/relationships" xmlns:p="http://schemas.openxmlformats.org/presentationml/2006/main">
   <p:cSld>
     <p:spTree>
@@ -7287,7 +7635,7 @@
 </p:sld>
 </file>
 
-<file path=ppt/slides/slide16.xml><?xml version="1.0" encoding="utf-8"?>
+<file path=ppt/slides/slide18.xml><?xml version="1.0" encoding="utf-8"?>
 <p:sld xmlns:a="http://schemas.openxmlformats.org/drawingml/2006/main" xmlns:r="http://schemas.openxmlformats.org/officeDocument/2006/relationships" xmlns:p="http://schemas.openxmlformats.org/presentationml/2006/main">
   <p:cSld>
     <p:spTree>
@@ -7549,7 +7897,7 @@
 </p:sld>
 </file>
 
-<file path=ppt/slides/slide17.xml><?xml version="1.0" encoding="utf-8"?>
+<file path=ppt/slides/slide19.xml><?xml version="1.0" encoding="utf-8"?>
 <p:sld xmlns:a="http://schemas.openxmlformats.org/drawingml/2006/main" xmlns:r="http://schemas.openxmlformats.org/officeDocument/2006/relationships" xmlns:p="http://schemas.openxmlformats.org/presentationml/2006/main">
   <p:cSld>
     <p:spTree>
@@ -7816,7 +8164,106 @@
 </p:sld>
 </file>
 
-<file path=ppt/slides/slide18.xml><?xml version="1.0" encoding="utf-8"?>
+<file path=ppt/slides/slide2.xml><?xml version="1.0" encoding="utf-8"?>
+<p:sld xmlns:a="http://schemas.openxmlformats.org/drawingml/2006/main" xmlns:r="http://schemas.openxmlformats.org/officeDocument/2006/relationships" xmlns:p="http://schemas.openxmlformats.org/presentationml/2006/main">
+  <p:cSld>
+    <p:spTree>
+      <p:nvGrpSpPr>
+        <p:cNvPr id="1" name=""/>
+        <p:cNvGrpSpPr/>
+        <p:nvPr/>
+      </p:nvGrpSpPr>
+      <p:grpSpPr>
+        <a:xfrm>
+          <a:off x="0" y="0"/>
+          <a:ext cx="0" cy="0"/>
+          <a:chOff x="0" y="0"/>
+          <a:chExt cx="0" cy="0"/>
+        </a:xfrm>
+      </p:grpSpPr>
+      <p:sp>
+        <p:nvSpPr>
+          <p:cNvPr id="4" name="TextBox 3">
+            <a:extLst>
+              <a:ext uri="{FF2B5EF4-FFF2-40B4-BE49-F238E27FC236}">
+                <a16:creationId xmlns:a16="http://schemas.microsoft.com/office/drawing/2014/main" id="{A603584D-0366-9795-1051-9A1D2B700605}"/>
+              </a:ext>
+            </a:extLst>
+          </p:cNvPr>
+          <p:cNvSpPr txBox="1"/>
+          <p:nvPr/>
+        </p:nvSpPr>
+        <p:spPr>
+          <a:xfrm>
+            <a:off x="2344824" y="2600493"/>
+            <a:ext cx="7502375" cy="1015663"/>
+          </a:xfrm>
+          <a:prstGeom prst="rect">
+            <a:avLst/>
+          </a:prstGeom>
+          <a:noFill/>
+        </p:spPr>
+        <p:txBody>
+          <a:bodyPr wrap="none" rtlCol="0">
+            <a:spAutoFit/>
+          </a:bodyPr>
+          <a:lstStyle/>
+          <a:p>
+            <a:pPr algn="ctr"/>
+            <a:r>
+              <a:rPr lang="en-US" altLang="ko-KR" sz="6000" dirty="0">
+                <a:solidFill>
+                  <a:schemeClr val="accent2"/>
+                </a:solidFill>
+                <a:latin typeface="G마켓 산스 TTF Bold" panose="02000000000000000000" pitchFamily="2" charset="-127"/>
+                <a:ea typeface="G마켓 산스 TTF Bold" panose="02000000000000000000" pitchFamily="2" charset="-127"/>
+              </a:rPr>
+              <a:t>8. </a:t>
+            </a:r>
+            <a:r>
+              <a:rPr lang="ko-KR" altLang="en-US" sz="6000" dirty="0" err="1">
+                <a:solidFill>
+                  <a:schemeClr val="accent2"/>
+                </a:solidFill>
+                <a:latin typeface="G마켓 산스 TTF Bold" panose="02000000000000000000" pitchFamily="2" charset="-127"/>
+                <a:ea typeface="G마켓 산스 TTF Bold" panose="02000000000000000000" pitchFamily="2" charset="-127"/>
+              </a:rPr>
+              <a:t>파이썬과</a:t>
+            </a:r>
+            <a:r>
+              <a:rPr lang="ko-KR" altLang="en-US" sz="6000" dirty="0">
+                <a:solidFill>
+                  <a:schemeClr val="accent2"/>
+                </a:solidFill>
+                <a:latin typeface="G마켓 산스 TTF Bold" panose="02000000000000000000" pitchFamily="2" charset="-127"/>
+                <a:ea typeface="G마켓 산스 TTF Bold" panose="02000000000000000000" pitchFamily="2" charset="-127"/>
+              </a:rPr>
+              <a:t> 함께 쓰기</a:t>
+            </a:r>
+            <a:endParaRPr lang="en-US" altLang="ko-KR" sz="6000" dirty="0">
+              <a:solidFill>
+                <a:schemeClr val="accent2"/>
+              </a:solidFill>
+              <a:latin typeface="G마켓 산스 TTF Bold" panose="02000000000000000000" pitchFamily="2" charset="-127"/>
+              <a:ea typeface="G마켓 산스 TTF Bold" panose="02000000000000000000" pitchFamily="2" charset="-127"/>
+            </a:endParaRPr>
+          </a:p>
+        </p:txBody>
+      </p:sp>
+    </p:spTree>
+    <p:extLst>
+      <p:ext uri="{BB962C8B-B14F-4D97-AF65-F5344CB8AC3E}">
+        <p14:creationId xmlns:p14="http://schemas.microsoft.com/office/powerpoint/2010/main" val="1233170634"/>
+      </p:ext>
+    </p:extLst>
+  </p:cSld>
+  <p:clrMapOvr>
+    <a:masterClrMapping/>
+  </p:clrMapOvr>
+</p:sld>
+</file>
+
+<file path=ppt/slides/slide20.xml><?xml version="1.0" encoding="utf-8"?>
 <p:sld xmlns:a="http://schemas.openxmlformats.org/drawingml/2006/main" xmlns:r="http://schemas.openxmlformats.org/officeDocument/2006/relationships" xmlns:p="http://schemas.openxmlformats.org/presentationml/2006/main">
   <p:cSld>
     <p:spTree>
@@ -8897,7 +9344,7 @@
 </p:sld>
 </file>
 
-<file path=ppt/slides/slide19.xml><?xml version="1.0" encoding="utf-8"?>
+<file path=ppt/slides/slide21.xml><?xml version="1.0" encoding="utf-8"?>
 <p:sld xmlns:a="http://schemas.openxmlformats.org/drawingml/2006/main" xmlns:r="http://schemas.openxmlformats.org/officeDocument/2006/relationships" xmlns:p="http://schemas.openxmlformats.org/presentationml/2006/main">
   <p:cSld>
     <p:spTree>
@@ -9829,106 +10276,7 @@
 </p:sld>
 </file>
 
-<file path=ppt/slides/slide2.xml><?xml version="1.0" encoding="utf-8"?>
-<p:sld xmlns:a="http://schemas.openxmlformats.org/drawingml/2006/main" xmlns:r="http://schemas.openxmlformats.org/officeDocument/2006/relationships" xmlns:p="http://schemas.openxmlformats.org/presentationml/2006/main">
-  <p:cSld>
-    <p:spTree>
-      <p:nvGrpSpPr>
-        <p:cNvPr id="1" name=""/>
-        <p:cNvGrpSpPr/>
-        <p:nvPr/>
-      </p:nvGrpSpPr>
-      <p:grpSpPr>
-        <a:xfrm>
-          <a:off x="0" y="0"/>
-          <a:ext cx="0" cy="0"/>
-          <a:chOff x="0" y="0"/>
-          <a:chExt cx="0" cy="0"/>
-        </a:xfrm>
-      </p:grpSpPr>
-      <p:sp>
-        <p:nvSpPr>
-          <p:cNvPr id="4" name="TextBox 3">
-            <a:extLst>
-              <a:ext uri="{FF2B5EF4-FFF2-40B4-BE49-F238E27FC236}">
-                <a16:creationId xmlns:a16="http://schemas.microsoft.com/office/drawing/2014/main" id="{A603584D-0366-9795-1051-9A1D2B700605}"/>
-              </a:ext>
-            </a:extLst>
-          </p:cNvPr>
-          <p:cNvSpPr txBox="1"/>
-          <p:nvPr/>
-        </p:nvSpPr>
-        <p:spPr>
-          <a:xfrm>
-            <a:off x="2344824" y="2600493"/>
-            <a:ext cx="7502375" cy="1015663"/>
-          </a:xfrm>
-          <a:prstGeom prst="rect">
-            <a:avLst/>
-          </a:prstGeom>
-          <a:noFill/>
-        </p:spPr>
-        <p:txBody>
-          <a:bodyPr wrap="none" rtlCol="0">
-            <a:spAutoFit/>
-          </a:bodyPr>
-          <a:lstStyle/>
-          <a:p>
-            <a:pPr algn="ctr"/>
-            <a:r>
-              <a:rPr lang="en-US" altLang="ko-KR" sz="6000" dirty="0">
-                <a:solidFill>
-                  <a:schemeClr val="accent2"/>
-                </a:solidFill>
-                <a:latin typeface="G마켓 산스 TTF Bold" panose="02000000000000000000" pitchFamily="2" charset="-127"/>
-                <a:ea typeface="G마켓 산스 TTF Bold" panose="02000000000000000000" pitchFamily="2" charset="-127"/>
-              </a:rPr>
-              <a:t>8. </a:t>
-            </a:r>
-            <a:r>
-              <a:rPr lang="ko-KR" altLang="en-US" sz="6000" dirty="0" err="1">
-                <a:solidFill>
-                  <a:schemeClr val="accent2"/>
-                </a:solidFill>
-                <a:latin typeface="G마켓 산스 TTF Bold" panose="02000000000000000000" pitchFamily="2" charset="-127"/>
-                <a:ea typeface="G마켓 산스 TTF Bold" panose="02000000000000000000" pitchFamily="2" charset="-127"/>
-              </a:rPr>
-              <a:t>파이썬과</a:t>
-            </a:r>
-            <a:r>
-              <a:rPr lang="ko-KR" altLang="en-US" sz="6000" dirty="0">
-                <a:solidFill>
-                  <a:schemeClr val="accent2"/>
-                </a:solidFill>
-                <a:latin typeface="G마켓 산스 TTF Bold" panose="02000000000000000000" pitchFamily="2" charset="-127"/>
-                <a:ea typeface="G마켓 산스 TTF Bold" panose="02000000000000000000" pitchFamily="2" charset="-127"/>
-              </a:rPr>
-              <a:t> 함께 쓰기</a:t>
-            </a:r>
-            <a:endParaRPr lang="en-US" altLang="ko-KR" sz="6000" dirty="0">
-              <a:solidFill>
-                <a:schemeClr val="accent2"/>
-              </a:solidFill>
-              <a:latin typeface="G마켓 산스 TTF Bold" panose="02000000000000000000" pitchFamily="2" charset="-127"/>
-              <a:ea typeface="G마켓 산스 TTF Bold" panose="02000000000000000000" pitchFamily="2" charset="-127"/>
-            </a:endParaRPr>
-          </a:p>
-        </p:txBody>
-      </p:sp>
-    </p:spTree>
-    <p:extLst>
-      <p:ext uri="{BB962C8B-B14F-4D97-AF65-F5344CB8AC3E}">
-        <p14:creationId xmlns:p14="http://schemas.microsoft.com/office/powerpoint/2010/main" val="1233170634"/>
-      </p:ext>
-    </p:extLst>
-  </p:cSld>
-  <p:clrMapOvr>
-    <a:masterClrMapping/>
-  </p:clrMapOvr>
-</p:sld>
-</file>
-
-<file path=ppt/slides/slide20.xml><?xml version="1.0" encoding="utf-8"?>
+<file path=ppt/slides/slide22.xml><?xml version="1.0" encoding="utf-8"?>
 <p:sld xmlns:a="http://schemas.openxmlformats.org/drawingml/2006/main" xmlns:r="http://schemas.openxmlformats.org/officeDocument/2006/relationships" xmlns:p="http://schemas.openxmlformats.org/presentationml/2006/main">
   <p:cSld>
     <p:spTree>
@@ -10864,7 +11212,7 @@
 </p:sld>
 </file>
 
-<file path=ppt/slides/slide21.xml><?xml version="1.0" encoding="utf-8"?>
+<file path=ppt/slides/slide23.xml><?xml version="1.0" encoding="utf-8"?>
 <p:sld xmlns:a="http://schemas.openxmlformats.org/drawingml/2006/main" xmlns:r="http://schemas.openxmlformats.org/officeDocument/2006/relationships" xmlns:p="http://schemas.openxmlformats.org/presentationml/2006/main">
   <p:cSld>
     <p:spTree>
@@ -11106,7 +11454,7 @@
 </p:sld>
 </file>
 
-<file path=ppt/slides/slide22.xml><?xml version="1.0" encoding="utf-8"?>
+<file path=ppt/slides/slide24.xml><?xml version="1.0" encoding="utf-8"?>
 <p:sld xmlns:a="http://schemas.openxmlformats.org/drawingml/2006/main" xmlns:r="http://schemas.openxmlformats.org/officeDocument/2006/relationships" xmlns:p="http://schemas.openxmlformats.org/presentationml/2006/main">
   <p:cSld>
     <p:spTree>
@@ -11228,7 +11576,7 @@
 </p:sld>
 </file>
 
-<file path=ppt/slides/slide23.xml><?xml version="1.0" encoding="utf-8"?>
+<file path=ppt/slides/slide25.xml><?xml version="1.0" encoding="utf-8"?>
 <p:sld xmlns:a="http://schemas.openxmlformats.org/drawingml/2006/main" xmlns:r="http://schemas.openxmlformats.org/officeDocument/2006/relationships" xmlns:p="http://schemas.openxmlformats.org/presentationml/2006/main">
   <p:cSld>
     <p:spTree>
@@ -11440,7 +11788,7 @@
 </p:sld>
 </file>
 
-<file path=ppt/slides/slide24.xml><?xml version="1.0" encoding="utf-8"?>
+<file path=ppt/slides/slide26.xml><?xml version="1.0" encoding="utf-8"?>
 <p:sld xmlns:a="http://schemas.openxmlformats.org/drawingml/2006/main" xmlns:r="http://schemas.openxmlformats.org/officeDocument/2006/relationships" xmlns:p="http://schemas.openxmlformats.org/presentationml/2006/main">
   <p:cSld>
     <p:spTree>
@@ -12204,7 +12552,7 @@
 </p:sld>
 </file>
 
-<file path=ppt/slides/slide25.xml><?xml version="1.0" encoding="utf-8"?>
+<file path=ppt/slides/slide27.xml><?xml version="1.0" encoding="utf-8"?>
 <p:sld xmlns:a="http://schemas.openxmlformats.org/drawingml/2006/main" xmlns:r="http://schemas.openxmlformats.org/officeDocument/2006/relationships" xmlns:p="http://schemas.openxmlformats.org/presentationml/2006/main">
   <p:cSld>
     <p:spTree>
@@ -12809,7 +13157,7 @@
 </p:sld>
 </file>
 
-<file path=ppt/slides/slide26.xml><?xml version="1.0" encoding="utf-8"?>
+<file path=ppt/slides/slide28.xml><?xml version="1.0" encoding="utf-8"?>
 <p:sld xmlns:a="http://schemas.openxmlformats.org/drawingml/2006/main" xmlns:r="http://schemas.openxmlformats.org/officeDocument/2006/relationships" xmlns:p="http://schemas.openxmlformats.org/presentationml/2006/main">
   <p:cSld>
     <p:spTree>
@@ -13149,7 +13497,7 @@
 </p:sld>
 </file>
 
-<file path=ppt/slides/slide27.xml><?xml version="1.0" encoding="utf-8"?>
+<file path=ppt/slides/slide29.xml><?xml version="1.0" encoding="utf-8"?>
 <p:sld xmlns:a="http://schemas.openxmlformats.org/drawingml/2006/main" xmlns:r="http://schemas.openxmlformats.org/officeDocument/2006/relationships" xmlns:p="http://schemas.openxmlformats.org/presentationml/2006/main">
   <p:cSld>
     <p:spTree>
@@ -13336,7 +13684,102 @@
 </p:sld>
 </file>
 
-<file path=ppt/slides/slide28.xml><?xml version="1.0" encoding="utf-8"?>
+<file path=ppt/slides/slide3.xml><?xml version="1.0" encoding="utf-8"?>
+<p:sld xmlns:a="http://schemas.openxmlformats.org/drawingml/2006/main" xmlns:r="http://schemas.openxmlformats.org/officeDocument/2006/relationships" xmlns:p="http://schemas.openxmlformats.org/presentationml/2006/main">
+  <p:cSld>
+    <p:spTree>
+      <p:nvGrpSpPr>
+        <p:cNvPr id="1" name="">
+          <a:extLst>
+            <a:ext uri="{FF2B5EF4-FFF2-40B4-BE49-F238E27FC236}">
+              <a16:creationId xmlns:a16="http://schemas.microsoft.com/office/drawing/2014/main" id="{8F5D0BA0-662B-3134-7B5B-AF37D9484ADF}"/>
+            </a:ext>
+          </a:extLst>
+        </p:cNvPr>
+        <p:cNvGrpSpPr/>
+        <p:nvPr/>
+      </p:nvGrpSpPr>
+      <p:grpSpPr>
+        <a:xfrm>
+          <a:off x="0" y="0"/>
+          <a:ext cx="0" cy="0"/>
+          <a:chOff x="0" y="0"/>
+          <a:chExt cx="0" cy="0"/>
+        </a:xfrm>
+      </p:grpSpPr>
+      <p:sp>
+        <p:nvSpPr>
+          <p:cNvPr id="4" name="TextBox 3">
+            <a:extLst>
+              <a:ext uri="{FF2B5EF4-FFF2-40B4-BE49-F238E27FC236}">
+                <a16:creationId xmlns:a16="http://schemas.microsoft.com/office/drawing/2014/main" id="{B3535ADF-92FC-22E6-EEEE-CA7A7156ABF1}"/>
+              </a:ext>
+            </a:extLst>
+          </p:cNvPr>
+          <p:cNvSpPr txBox="1"/>
+          <p:nvPr/>
+        </p:nvSpPr>
+        <p:spPr>
+          <a:xfrm>
+            <a:off x="2826530" y="2600493"/>
+            <a:ext cx="6538971" cy="1015663"/>
+          </a:xfrm>
+          <a:prstGeom prst="rect">
+            <a:avLst/>
+          </a:prstGeom>
+          <a:noFill/>
+        </p:spPr>
+        <p:txBody>
+          <a:bodyPr wrap="none" rtlCol="0">
+            <a:spAutoFit/>
+          </a:bodyPr>
+          <a:lstStyle/>
+          <a:p>
+            <a:pPr algn="ctr"/>
+            <a:r>
+              <a:rPr lang="ko-KR" altLang="en-US" sz="6000" dirty="0" err="1">
+                <a:solidFill>
+                  <a:schemeClr val="accent2"/>
+                </a:solidFill>
+                <a:latin typeface="G마켓 산스 TTF Bold" panose="02000000000000000000" pitchFamily="2" charset="-127"/>
+                <a:ea typeface="G마켓 산스 TTF Bold" panose="02000000000000000000" pitchFamily="2" charset="-127"/>
+              </a:rPr>
+              <a:t>파이썬과</a:t>
+            </a:r>
+            <a:r>
+              <a:rPr lang="ko-KR" altLang="en-US" sz="6000" dirty="0">
+                <a:solidFill>
+                  <a:schemeClr val="accent2"/>
+                </a:solidFill>
+                <a:latin typeface="G마켓 산스 TTF Bold" panose="02000000000000000000" pitchFamily="2" charset="-127"/>
+                <a:ea typeface="G마켓 산스 TTF Bold" panose="02000000000000000000" pitchFamily="2" charset="-127"/>
+              </a:rPr>
+              <a:t> 함께 쓰기</a:t>
+            </a:r>
+            <a:endParaRPr lang="en-US" altLang="ko-KR" sz="6000" dirty="0">
+              <a:solidFill>
+                <a:schemeClr val="accent2"/>
+              </a:solidFill>
+              <a:latin typeface="G마켓 산스 TTF Bold" panose="02000000000000000000" pitchFamily="2" charset="-127"/>
+              <a:ea typeface="G마켓 산스 TTF Bold" panose="02000000000000000000" pitchFamily="2" charset="-127"/>
+            </a:endParaRPr>
+          </a:p>
+        </p:txBody>
+      </p:sp>
+    </p:spTree>
+    <p:extLst>
+      <p:ext uri="{BB962C8B-B14F-4D97-AF65-F5344CB8AC3E}">
+        <p14:creationId xmlns:p14="http://schemas.microsoft.com/office/powerpoint/2010/main" val="3455617091"/>
+      </p:ext>
+    </p:extLst>
+  </p:cSld>
+  <p:clrMapOvr>
+    <a:masterClrMapping/>
+  </p:clrMapOvr>
+</p:sld>
+</file>
+
+<file path=ppt/slides/slide30.xml><?xml version="1.0" encoding="utf-8"?>
 <p:sld xmlns:a="http://schemas.openxmlformats.org/drawingml/2006/main" xmlns:r="http://schemas.openxmlformats.org/officeDocument/2006/relationships" xmlns:p="http://schemas.openxmlformats.org/presentationml/2006/main">
   <p:cSld>
     <p:spTree>
@@ -13831,7 +14274,7 @@
 </p:sld>
 </file>
 
-<file path=ppt/slides/slide29.xml><?xml version="1.0" encoding="utf-8"?>
+<file path=ppt/slides/slide31.xml><?xml version="1.0" encoding="utf-8"?>
 <p:sld xmlns:a="http://schemas.openxmlformats.org/drawingml/2006/main" xmlns:r="http://schemas.openxmlformats.org/officeDocument/2006/relationships" xmlns:p="http://schemas.openxmlformats.org/presentationml/2006/main">
   <p:cSld>
     <p:spTree>
@@ -14260,102 +14703,7 @@
 </p:sld>
 </file>
 
-<file path=ppt/slides/slide3.xml><?xml version="1.0" encoding="utf-8"?>
-<p:sld xmlns:a="http://schemas.openxmlformats.org/drawingml/2006/main" xmlns:r="http://schemas.openxmlformats.org/officeDocument/2006/relationships" xmlns:p="http://schemas.openxmlformats.org/presentationml/2006/main">
-  <p:cSld>
-    <p:spTree>
-      <p:nvGrpSpPr>
-        <p:cNvPr id="1" name="">
-          <a:extLst>
-            <a:ext uri="{FF2B5EF4-FFF2-40B4-BE49-F238E27FC236}">
-              <a16:creationId xmlns:a16="http://schemas.microsoft.com/office/drawing/2014/main" id="{8F5D0BA0-662B-3134-7B5B-AF37D9484ADF}"/>
-            </a:ext>
-          </a:extLst>
-        </p:cNvPr>
-        <p:cNvGrpSpPr/>
-        <p:nvPr/>
-      </p:nvGrpSpPr>
-      <p:grpSpPr>
-        <a:xfrm>
-          <a:off x="0" y="0"/>
-          <a:ext cx="0" cy="0"/>
-          <a:chOff x="0" y="0"/>
-          <a:chExt cx="0" cy="0"/>
-        </a:xfrm>
-      </p:grpSpPr>
-      <p:sp>
-        <p:nvSpPr>
-          <p:cNvPr id="4" name="TextBox 3">
-            <a:extLst>
-              <a:ext uri="{FF2B5EF4-FFF2-40B4-BE49-F238E27FC236}">
-                <a16:creationId xmlns:a16="http://schemas.microsoft.com/office/drawing/2014/main" id="{B3535ADF-92FC-22E6-EEEE-CA7A7156ABF1}"/>
-              </a:ext>
-            </a:extLst>
-          </p:cNvPr>
-          <p:cNvSpPr txBox="1"/>
-          <p:nvPr/>
-        </p:nvSpPr>
-        <p:spPr>
-          <a:xfrm>
-            <a:off x="2826530" y="2600493"/>
-            <a:ext cx="6538971" cy="1015663"/>
-          </a:xfrm>
-          <a:prstGeom prst="rect">
-            <a:avLst/>
-          </a:prstGeom>
-          <a:noFill/>
-        </p:spPr>
-        <p:txBody>
-          <a:bodyPr wrap="none" rtlCol="0">
-            <a:spAutoFit/>
-          </a:bodyPr>
-          <a:lstStyle/>
-          <a:p>
-            <a:pPr algn="ctr"/>
-            <a:r>
-              <a:rPr lang="ko-KR" altLang="en-US" sz="6000" dirty="0" err="1">
-                <a:solidFill>
-                  <a:schemeClr val="accent2"/>
-                </a:solidFill>
-                <a:latin typeface="G마켓 산스 TTF Bold" panose="02000000000000000000" pitchFamily="2" charset="-127"/>
-                <a:ea typeface="G마켓 산스 TTF Bold" panose="02000000000000000000" pitchFamily="2" charset="-127"/>
-              </a:rPr>
-              <a:t>파이썬과</a:t>
-            </a:r>
-            <a:r>
-              <a:rPr lang="ko-KR" altLang="en-US" sz="6000" dirty="0">
-                <a:solidFill>
-                  <a:schemeClr val="accent2"/>
-                </a:solidFill>
-                <a:latin typeface="G마켓 산스 TTF Bold" panose="02000000000000000000" pitchFamily="2" charset="-127"/>
-                <a:ea typeface="G마켓 산스 TTF Bold" panose="02000000000000000000" pitchFamily="2" charset="-127"/>
-              </a:rPr>
-              <a:t> 함께 쓰기</a:t>
-            </a:r>
-            <a:endParaRPr lang="en-US" altLang="ko-KR" sz="6000" dirty="0">
-              <a:solidFill>
-                <a:schemeClr val="accent2"/>
-              </a:solidFill>
-              <a:latin typeface="G마켓 산스 TTF Bold" panose="02000000000000000000" pitchFamily="2" charset="-127"/>
-              <a:ea typeface="G마켓 산스 TTF Bold" panose="02000000000000000000" pitchFamily="2" charset="-127"/>
-            </a:endParaRPr>
-          </a:p>
-        </p:txBody>
-      </p:sp>
-    </p:spTree>
-    <p:extLst>
-      <p:ext uri="{BB962C8B-B14F-4D97-AF65-F5344CB8AC3E}">
-        <p14:creationId xmlns:p14="http://schemas.microsoft.com/office/powerpoint/2010/main" val="3455617091"/>
-      </p:ext>
-    </p:extLst>
-  </p:cSld>
-  <p:clrMapOvr>
-    <a:masterClrMapping/>
-  </p:clrMapOvr>
-</p:sld>
-</file>
-
-<file path=ppt/slides/slide30.xml><?xml version="1.0" encoding="utf-8"?>
+<file path=ppt/slides/slide32.xml><?xml version="1.0" encoding="utf-8"?>
 <p:sld xmlns:a="http://schemas.openxmlformats.org/drawingml/2006/main" xmlns:r="http://schemas.openxmlformats.org/officeDocument/2006/relationships" xmlns:p="http://schemas.openxmlformats.org/presentationml/2006/main">
   <p:cSld>
     <p:spTree>
@@ -14720,7 +15068,7 @@
 </p:sld>
 </file>
 
-<file path=ppt/slides/slide31.xml><?xml version="1.0" encoding="utf-8"?>
+<file path=ppt/slides/slide33.xml><?xml version="1.0" encoding="utf-8"?>
 <p:sld xmlns:a="http://schemas.openxmlformats.org/drawingml/2006/main" xmlns:r="http://schemas.openxmlformats.org/officeDocument/2006/relationships" xmlns:p="http://schemas.openxmlformats.org/presentationml/2006/main">
   <p:cSld>
     <p:spTree>
@@ -14986,7 +15334,7 @@
 </p:sld>
 </file>
 
-<file path=ppt/slides/slide32.xml><?xml version="1.0" encoding="utf-8"?>
+<file path=ppt/slides/slide34.xml><?xml version="1.0" encoding="utf-8"?>
 <p:sld xmlns:a="http://schemas.openxmlformats.org/drawingml/2006/main" xmlns:r="http://schemas.openxmlformats.org/officeDocument/2006/relationships" xmlns:p="http://schemas.openxmlformats.org/presentationml/2006/main">
   <p:cSld>
     <p:spTree>
@@ -15955,7 +16303,7 @@
 </p:sld>
 </file>
 
-<file path=ppt/slides/slide33.xml><?xml version="1.0" encoding="utf-8"?>
+<file path=ppt/slides/slide35.xml><?xml version="1.0" encoding="utf-8"?>
 <p:sld xmlns:a="http://schemas.openxmlformats.org/drawingml/2006/main" xmlns:r="http://schemas.openxmlformats.org/officeDocument/2006/relationships" xmlns:p="http://schemas.openxmlformats.org/presentationml/2006/main">
   <p:cSld>
     <p:spTree>
@@ -16050,7 +16398,7 @@
 </p:sld>
 </file>
 
-<file path=ppt/slides/slide34.xml><?xml version="1.0" encoding="utf-8"?>
+<file path=ppt/slides/slide36.xml><?xml version="1.0" encoding="utf-8"?>
 <p:sld xmlns:a="http://schemas.openxmlformats.org/drawingml/2006/main" xmlns:r="http://schemas.openxmlformats.org/officeDocument/2006/relationships" xmlns:p="http://schemas.openxmlformats.org/presentationml/2006/main">
   <p:cSld>
     <p:spTree>
@@ -16281,7 +16629,7 @@
 </p:sld>
 </file>
 
-<file path=ppt/slides/slide35.xml><?xml version="1.0" encoding="utf-8"?>
+<file path=ppt/slides/slide37.xml><?xml version="1.0" encoding="utf-8"?>
 <p:sld xmlns:a="http://schemas.openxmlformats.org/drawingml/2006/main" xmlns:r="http://schemas.openxmlformats.org/officeDocument/2006/relationships" xmlns:p="http://schemas.openxmlformats.org/presentationml/2006/main">
   <p:cSld>
     <p:spTree>
@@ -16518,7 +16866,7 @@
 </p:sld>
 </file>
 
-<file path=ppt/slides/slide36.xml><?xml version="1.0" encoding="utf-8"?>
+<file path=ppt/slides/slide38.xml><?xml version="1.0" encoding="utf-8"?>
 <p:sld xmlns:a="http://schemas.openxmlformats.org/drawingml/2006/main" xmlns:r="http://schemas.openxmlformats.org/officeDocument/2006/relationships" xmlns:p="http://schemas.openxmlformats.org/presentationml/2006/main">
   <p:cSld>
     <p:spTree>
@@ -16690,7 +17038,7 @@
 </p:sld>
 </file>
 
-<file path=ppt/slides/slide37.xml><?xml version="1.0" encoding="utf-8"?>
+<file path=ppt/slides/slide39.xml><?xml version="1.0" encoding="utf-8"?>
 <p:sld xmlns:a="http://schemas.openxmlformats.org/drawingml/2006/main" xmlns:r="http://schemas.openxmlformats.org/officeDocument/2006/relationships" xmlns:p="http://schemas.openxmlformats.org/presentationml/2006/main">
   <p:cSld>
     <p:spTree>
@@ -16796,1208 +17144,6 @@
     <p:extLst>
       <p:ext uri="{BB962C8B-B14F-4D97-AF65-F5344CB8AC3E}">
         <p14:creationId xmlns:p14="http://schemas.microsoft.com/office/powerpoint/2010/main" val="3404455846"/>
-      </p:ext>
-    </p:extLst>
-  </p:cSld>
-  <p:clrMapOvr>
-    <a:masterClrMapping/>
-  </p:clrMapOvr>
-</p:sld>
-</file>
-
-<file path=ppt/slides/slide38.xml><?xml version="1.0" encoding="utf-8"?>
-<p:sld xmlns:a="http://schemas.openxmlformats.org/drawingml/2006/main" xmlns:r="http://schemas.openxmlformats.org/officeDocument/2006/relationships" xmlns:p="http://schemas.openxmlformats.org/presentationml/2006/main">
-  <p:cSld>
-    <p:spTree>
-      <p:nvGrpSpPr>
-        <p:cNvPr id="1" name="">
-          <a:extLst>
-            <a:ext uri="{FF2B5EF4-FFF2-40B4-BE49-F238E27FC236}">
-              <a16:creationId xmlns:a16="http://schemas.microsoft.com/office/drawing/2014/main" id="{D416CC96-0A4D-3652-40E4-0E88590519B5}"/>
-            </a:ext>
-          </a:extLst>
-        </p:cNvPr>
-        <p:cNvGrpSpPr/>
-        <p:nvPr/>
-      </p:nvGrpSpPr>
-      <p:grpSpPr>
-        <a:xfrm>
-          <a:off x="0" y="0"/>
-          <a:ext cx="0" cy="0"/>
-          <a:chOff x="0" y="0"/>
-          <a:chExt cx="0" cy="0"/>
-        </a:xfrm>
-      </p:grpSpPr>
-      <p:pic>
-        <p:nvPicPr>
-          <p:cNvPr id="11" name="그림 10" descr="텍스트, 스크린샷, 폰트, 소프트웨어이(가) 표시된 사진&#10;&#10;AI가 생성한 콘텐츠는 부정확할 수 있습니다.">
-            <a:extLst>
-              <a:ext uri="{FF2B5EF4-FFF2-40B4-BE49-F238E27FC236}">
-                <a16:creationId xmlns:a16="http://schemas.microsoft.com/office/drawing/2014/main" id="{326838E0-1A46-152C-4663-463E3E86EA6F}"/>
-              </a:ext>
-            </a:extLst>
-          </p:cNvPr>
-          <p:cNvPicPr>
-            <a:picLocks noChangeAspect="1"/>
-          </p:cNvPicPr>
-          <p:nvPr/>
-        </p:nvPicPr>
-        <p:blipFill>
-          <a:blip r:embed="rId3">
-            <a:extLst>
-              <a:ext uri="{28A0092B-C50C-407E-A947-70E740481C1C}">
-                <a14:useLocalDpi xmlns:a14="http://schemas.microsoft.com/office/drawing/2010/main" val="0"/>
-              </a:ext>
-            </a:extLst>
-          </a:blip>
-          <a:stretch>
-            <a:fillRect/>
-          </a:stretch>
-        </p:blipFill>
-        <p:spPr>
-          <a:xfrm>
-            <a:off x="593558" y="385212"/>
-            <a:ext cx="11004884" cy="4576422"/>
-          </a:xfrm>
-          <a:prstGeom prst="rect">
-            <a:avLst/>
-          </a:prstGeom>
-        </p:spPr>
-      </p:pic>
-      <p:sp>
-        <p:nvSpPr>
-          <p:cNvPr id="2" name="제목 1">
-            <a:extLst>
-              <a:ext uri="{FF2B5EF4-FFF2-40B4-BE49-F238E27FC236}">
-                <a16:creationId xmlns:a16="http://schemas.microsoft.com/office/drawing/2014/main" id="{753B3671-8DE1-2A61-5634-147CC42AE941}"/>
-              </a:ext>
-            </a:extLst>
-          </p:cNvPr>
-          <p:cNvSpPr>
-            <a:spLocks noGrp="1"/>
-          </p:cNvSpPr>
-          <p:nvPr>
-            <p:ph type="title"/>
-          </p:nvPr>
-        </p:nvSpPr>
-        <p:spPr/>
-        <p:txBody>
-          <a:bodyPr>
-            <a:normAutofit/>
-          </a:bodyPr>
-          <a:lstStyle/>
-          <a:p>
-            <a:r>
-              <a:rPr lang="en-US" altLang="ko-KR" b="1" dirty="0"/>
-              <a:t>DB </a:t>
-            </a:r>
-            <a:r>
-              <a:rPr lang="ko-KR" altLang="en-US" b="1" dirty="0"/>
-              <a:t>세션 구성 </a:t>
-            </a:r>
-            <a:r>
-              <a:rPr lang="en-US" altLang="ko-KR" b="1" dirty="0"/>
-              <a:t>(db.py)</a:t>
-            </a:r>
-          </a:p>
-        </p:txBody>
-      </p:sp>
-      <p:sp>
-        <p:nvSpPr>
-          <p:cNvPr id="5" name="직사각형 4">
-            <a:extLst>
-              <a:ext uri="{FF2B5EF4-FFF2-40B4-BE49-F238E27FC236}">
-                <a16:creationId xmlns:a16="http://schemas.microsoft.com/office/drawing/2014/main" id="{FA1D204F-85A0-3D90-4525-91598FA94379}"/>
-              </a:ext>
-            </a:extLst>
-          </p:cNvPr>
-          <p:cNvSpPr/>
-          <p:nvPr/>
-        </p:nvSpPr>
-        <p:spPr>
-          <a:xfrm>
-            <a:off x="1215691" y="4249308"/>
-            <a:ext cx="8114501" cy="2086405"/>
-          </a:xfrm>
-          <a:prstGeom prst="rect">
-            <a:avLst/>
-          </a:prstGeom>
-        </p:spPr>
-        <p:txBody>
-          <a:bodyPr wrap="square">
-            <a:spAutoFit/>
-          </a:bodyPr>
-          <a:lstStyle/>
-          <a:p>
-            <a:pPr>
-              <a:lnSpc>
-                <a:spcPct val="150000"/>
-              </a:lnSpc>
-            </a:pPr>
-            <a:r>
-              <a:rPr lang="ko-KR" altLang="en-US" sz="1600" dirty="0">
-                <a:latin typeface="Pretendard Light" panose="02000403000000020004" pitchFamily="2" charset="-127"/>
-                <a:ea typeface="Pretendard Light" panose="02000403000000020004" pitchFamily="2" charset="-127"/>
-                <a:cs typeface="Pretendard Light" panose="02000403000000020004" pitchFamily="2" charset="-127"/>
-              </a:rPr>
-              <a:t>✔️ </a:t>
-            </a:r>
-            <a:r>
-              <a:rPr lang="en-US" altLang="ko-KR" sz="1600" dirty="0" err="1">
-                <a:latin typeface="Pretendard Light" panose="02000403000000020004" pitchFamily="2" charset="-127"/>
-                <a:ea typeface="Pretendard Light" panose="02000403000000020004" pitchFamily="2" charset="-127"/>
-                <a:cs typeface="Pretendard Light" panose="02000403000000020004" pitchFamily="2" charset="-127"/>
-              </a:rPr>
-              <a:t>create_engine</a:t>
-            </a:r>
-            <a:r>
-              <a:rPr lang="en-US" altLang="ko-KR" sz="1600" dirty="0">
-                <a:latin typeface="Pretendard Light" panose="02000403000000020004" pitchFamily="2" charset="-127"/>
-                <a:ea typeface="Pretendard Light" panose="02000403000000020004" pitchFamily="2" charset="-127"/>
-                <a:cs typeface="Pretendard Light" panose="02000403000000020004" pitchFamily="2" charset="-127"/>
-              </a:rPr>
-              <a:t> : engine </a:t>
-            </a:r>
-            <a:r>
-              <a:rPr lang="ko-KR" altLang="en-US" sz="1600" dirty="0">
-                <a:latin typeface="Pretendard Light" panose="02000403000000020004" pitchFamily="2" charset="-127"/>
-                <a:ea typeface="Pretendard Light" panose="02000403000000020004" pitchFamily="2" charset="-127"/>
-                <a:cs typeface="Pretendard Light" panose="02000403000000020004" pitchFamily="2" charset="-127"/>
-              </a:rPr>
-              <a:t>객체를 만들기 위한 함수</a:t>
-            </a:r>
-            <a:endParaRPr lang="en-US" altLang="ko-KR" sz="1600" dirty="0">
-              <a:latin typeface="Pretendard Light" panose="02000403000000020004" pitchFamily="2" charset="-127"/>
-              <a:ea typeface="Pretendard Light" panose="02000403000000020004" pitchFamily="2" charset="-127"/>
-              <a:cs typeface="Pretendard Light" panose="02000403000000020004" pitchFamily="2" charset="-127"/>
-            </a:endParaRPr>
-          </a:p>
-          <a:p>
-            <a:pPr>
-              <a:lnSpc>
-                <a:spcPct val="150000"/>
-              </a:lnSpc>
-            </a:pPr>
-            <a:r>
-              <a:rPr lang="ko-KR" altLang="en-US" sz="1600" dirty="0">
-                <a:latin typeface="Pretendard Light" panose="02000403000000020004" pitchFamily="2" charset="-127"/>
-                <a:ea typeface="Pretendard Light" panose="02000403000000020004" pitchFamily="2" charset="-127"/>
-                <a:cs typeface="Pretendard Light" panose="02000403000000020004" pitchFamily="2" charset="-127"/>
-              </a:rPr>
-              <a:t>✔️ </a:t>
-            </a:r>
-            <a:r>
-              <a:rPr lang="en-US" altLang="ko-KR" sz="1600" dirty="0" err="1">
-                <a:latin typeface="Pretendard Light" panose="02000403000000020004" pitchFamily="2" charset="-127"/>
-                <a:ea typeface="Pretendard Light" panose="02000403000000020004" pitchFamily="2" charset="-127"/>
-                <a:cs typeface="Pretendard Light" panose="02000403000000020004" pitchFamily="2" charset="-127"/>
-              </a:rPr>
-              <a:t>sessionmaker</a:t>
-            </a:r>
-            <a:r>
-              <a:rPr lang="en-US" altLang="ko-KR" sz="1600" dirty="0">
-                <a:latin typeface="Pretendard Light" panose="02000403000000020004" pitchFamily="2" charset="-127"/>
-                <a:ea typeface="Pretendard Light" panose="02000403000000020004" pitchFamily="2" charset="-127"/>
-                <a:cs typeface="Pretendard Light" panose="02000403000000020004" pitchFamily="2" charset="-127"/>
-              </a:rPr>
-              <a:t> : </a:t>
-            </a:r>
-            <a:r>
-              <a:rPr lang="ko-KR" altLang="en-US" sz="1600" dirty="0">
-                <a:latin typeface="Pretendard Light" panose="02000403000000020004" pitchFamily="2" charset="-127"/>
-                <a:ea typeface="Pretendard Light" panose="02000403000000020004" pitchFamily="2" charset="-127"/>
-                <a:cs typeface="Pretendard Light" panose="02000403000000020004" pitchFamily="2" charset="-127"/>
-              </a:rPr>
-              <a:t> 세션 객체를 생성하는 함수</a:t>
-            </a:r>
-            <a:endParaRPr lang="en-US" altLang="ko-KR" sz="1600" dirty="0">
-              <a:latin typeface="Pretendard Light" panose="02000403000000020004" pitchFamily="2" charset="-127"/>
-              <a:ea typeface="Pretendard Light" panose="02000403000000020004" pitchFamily="2" charset="-127"/>
-              <a:cs typeface="Pretendard Light" panose="02000403000000020004" pitchFamily="2" charset="-127"/>
-            </a:endParaRPr>
-          </a:p>
-          <a:p>
-            <a:pPr marL="742950" lvl="1" indent="-285750">
-              <a:lnSpc>
-                <a:spcPct val="150000"/>
-              </a:lnSpc>
-              <a:buFont typeface="Arial" panose="020B0604020202020204" pitchFamily="34" charset="0"/>
-              <a:buChar char="•"/>
-            </a:pPr>
-            <a:r>
-              <a:rPr lang="en-US" altLang="ko-KR" sz="1400" dirty="0" err="1">
-                <a:latin typeface="Pretendard Light" panose="02000403000000020004" pitchFamily="2" charset="-127"/>
-                <a:ea typeface="Pretendard Light" panose="02000403000000020004" pitchFamily="2" charset="-127"/>
-                <a:cs typeface="Pretendard Light" panose="02000403000000020004" pitchFamily="2" charset="-127"/>
-              </a:rPr>
-              <a:t>autocommit</a:t>
-            </a:r>
-            <a:r>
-              <a:rPr lang="en-US" altLang="ko-KR" sz="1400" dirty="0">
-                <a:latin typeface="Pretendard Light" panose="02000403000000020004" pitchFamily="2" charset="-127"/>
-                <a:ea typeface="Pretendard Light" panose="02000403000000020004" pitchFamily="2" charset="-127"/>
-                <a:cs typeface="Pretendard Light" panose="02000403000000020004" pitchFamily="2" charset="-127"/>
-              </a:rPr>
-              <a:t>=False </a:t>
-            </a:r>
-            <a:r>
-              <a:rPr lang="ko-KR" altLang="en-US" sz="1400" dirty="0" err="1">
-                <a:latin typeface="Pretendard Light" panose="02000403000000020004" pitchFamily="2" charset="-127"/>
-                <a:ea typeface="Pretendard Light" panose="02000403000000020004" pitchFamily="2" charset="-127"/>
-                <a:cs typeface="Pretendard Light" panose="02000403000000020004" pitchFamily="2" charset="-127"/>
-              </a:rPr>
-              <a:t>커밋은</a:t>
-            </a:r>
-            <a:r>
-              <a:rPr lang="ko-KR" altLang="en-US" sz="1400" dirty="0">
-                <a:latin typeface="Pretendard Light" panose="02000403000000020004" pitchFamily="2" charset="-127"/>
-                <a:ea typeface="Pretendard Light" panose="02000403000000020004" pitchFamily="2" charset="-127"/>
-                <a:cs typeface="Pretendard Light" panose="02000403000000020004" pitchFamily="2" charset="-127"/>
-              </a:rPr>
-              <a:t> 명시적으로 </a:t>
-            </a:r>
-            <a:r>
-              <a:rPr lang="en-US" altLang="ko-KR" sz="1400" dirty="0">
-                <a:latin typeface="Pretendard Light" panose="02000403000000020004" pitchFamily="2" charset="-127"/>
-                <a:ea typeface="Pretendard Light" panose="02000403000000020004" pitchFamily="2" charset="-127"/>
-                <a:cs typeface="Pretendard Light" panose="02000403000000020004" pitchFamily="2" charset="-127"/>
-              </a:rPr>
-              <a:t>commit() </a:t>
-            </a:r>
-            <a:r>
-              <a:rPr lang="ko-KR" altLang="en-US" sz="1400" dirty="0">
-                <a:latin typeface="Pretendard Light" panose="02000403000000020004" pitchFamily="2" charset="-127"/>
-                <a:ea typeface="Pretendard Light" panose="02000403000000020004" pitchFamily="2" charset="-127"/>
-                <a:cs typeface="Pretendard Light" panose="02000403000000020004" pitchFamily="2" charset="-127"/>
-              </a:rPr>
-              <a:t>해야 함</a:t>
-            </a:r>
-          </a:p>
-          <a:p>
-            <a:pPr marL="742950" lvl="1" indent="-285750">
-              <a:lnSpc>
-                <a:spcPct val="150000"/>
-              </a:lnSpc>
-              <a:buFont typeface="Arial" panose="020B0604020202020204" pitchFamily="34" charset="0"/>
-              <a:buChar char="•"/>
-            </a:pPr>
-            <a:r>
-              <a:rPr lang="en-US" altLang="ko-KR" sz="1400" dirty="0" err="1">
-                <a:latin typeface="Pretendard Light" panose="02000403000000020004" pitchFamily="2" charset="-127"/>
-                <a:ea typeface="Pretendard Light" panose="02000403000000020004" pitchFamily="2" charset="-127"/>
-                <a:cs typeface="Pretendard Light" panose="02000403000000020004" pitchFamily="2" charset="-127"/>
-              </a:rPr>
-              <a:t>autoflush</a:t>
-            </a:r>
-            <a:r>
-              <a:rPr lang="en-US" altLang="ko-KR" sz="1400" dirty="0">
-                <a:latin typeface="Pretendard Light" panose="02000403000000020004" pitchFamily="2" charset="-127"/>
-                <a:ea typeface="Pretendard Light" panose="02000403000000020004" pitchFamily="2" charset="-127"/>
-                <a:cs typeface="Pretendard Light" panose="02000403000000020004" pitchFamily="2" charset="-127"/>
-              </a:rPr>
-              <a:t>=False </a:t>
-            </a:r>
-            <a:r>
-              <a:rPr lang="ko-KR" altLang="en-US" sz="1400" dirty="0">
-                <a:latin typeface="Pretendard Light" panose="02000403000000020004" pitchFamily="2" charset="-127"/>
-                <a:ea typeface="Pretendard Light" panose="02000403000000020004" pitchFamily="2" charset="-127"/>
-                <a:cs typeface="Pretendard Light" panose="02000403000000020004" pitchFamily="2" charset="-127"/>
-              </a:rPr>
-              <a:t>쿼리 실행 전에 자동 </a:t>
-            </a:r>
-            <a:r>
-              <a:rPr lang="en-US" altLang="ko-KR" sz="1400" dirty="0">
-                <a:latin typeface="Pretendard Light" panose="02000403000000020004" pitchFamily="2" charset="-127"/>
-                <a:ea typeface="Pretendard Light" panose="02000403000000020004" pitchFamily="2" charset="-127"/>
-                <a:cs typeface="Pretendard Light" panose="02000403000000020004" pitchFamily="2" charset="-127"/>
-              </a:rPr>
-              <a:t>flush </a:t>
-            </a:r>
-            <a:r>
-              <a:rPr lang="ko-KR" altLang="en-US" sz="1400" dirty="0">
-                <a:latin typeface="Pretendard Light" panose="02000403000000020004" pitchFamily="2" charset="-127"/>
-                <a:ea typeface="Pretendard Light" panose="02000403000000020004" pitchFamily="2" charset="-127"/>
-                <a:cs typeface="Pretendard Light" panose="02000403000000020004" pitchFamily="2" charset="-127"/>
-              </a:rPr>
-              <a:t>안 함</a:t>
-            </a:r>
-          </a:p>
-          <a:p>
-            <a:pPr marL="742950" lvl="1" indent="-285750">
-              <a:lnSpc>
-                <a:spcPct val="150000"/>
-              </a:lnSpc>
-              <a:buFont typeface="Arial" panose="020B0604020202020204" pitchFamily="34" charset="0"/>
-              <a:buChar char="•"/>
-            </a:pPr>
-            <a:r>
-              <a:rPr lang="en-US" altLang="ko-KR" sz="1400" dirty="0">
-                <a:latin typeface="Pretendard Light" panose="02000403000000020004" pitchFamily="2" charset="-127"/>
-                <a:ea typeface="Pretendard Light" panose="02000403000000020004" pitchFamily="2" charset="-127"/>
-                <a:cs typeface="Pretendard Light" panose="02000403000000020004" pitchFamily="2" charset="-127"/>
-              </a:rPr>
-              <a:t>bind=engine </a:t>
-            </a:r>
-            <a:r>
-              <a:rPr lang="ko-KR" altLang="en-US" sz="1400" dirty="0">
-                <a:latin typeface="Pretendard Light" panose="02000403000000020004" pitchFamily="2" charset="-127"/>
-                <a:ea typeface="Pretendard Light" panose="02000403000000020004" pitchFamily="2" charset="-127"/>
-                <a:cs typeface="Pretendard Light" panose="02000403000000020004" pitchFamily="2" charset="-127"/>
-              </a:rPr>
-              <a:t>이 세션은 위에서 만든 </a:t>
-            </a:r>
-            <a:r>
-              <a:rPr lang="en-US" altLang="ko-KR" sz="1400" dirty="0">
-                <a:latin typeface="Pretendard Light" panose="02000403000000020004" pitchFamily="2" charset="-127"/>
-                <a:ea typeface="Pretendard Light" panose="02000403000000020004" pitchFamily="2" charset="-127"/>
-                <a:cs typeface="Pretendard Light" panose="02000403000000020004" pitchFamily="2" charset="-127"/>
-              </a:rPr>
-              <a:t>engine</a:t>
-            </a:r>
-            <a:r>
-              <a:rPr lang="ko-KR" altLang="en-US" sz="1400" dirty="0">
-                <a:latin typeface="Pretendard Light" panose="02000403000000020004" pitchFamily="2" charset="-127"/>
-                <a:ea typeface="Pretendard Light" panose="02000403000000020004" pitchFamily="2" charset="-127"/>
-                <a:cs typeface="Pretendard Light" panose="02000403000000020004" pitchFamily="2" charset="-127"/>
-              </a:rPr>
-              <a:t>과 연결됨</a:t>
-            </a:r>
-            <a:endParaRPr lang="en-US" altLang="ko-KR" sz="1400" dirty="0">
-              <a:latin typeface="Pretendard Light" panose="02000403000000020004" pitchFamily="2" charset="-127"/>
-              <a:ea typeface="Pretendard Light" panose="02000403000000020004" pitchFamily="2" charset="-127"/>
-              <a:cs typeface="Pretendard Light" panose="02000403000000020004" pitchFamily="2" charset="-127"/>
-            </a:endParaRPr>
-          </a:p>
-          <a:p>
-            <a:pPr>
-              <a:lnSpc>
-                <a:spcPct val="150000"/>
-              </a:lnSpc>
-            </a:pPr>
-            <a:r>
-              <a:rPr lang="ko-KR" altLang="en-US" sz="1400" dirty="0">
-                <a:latin typeface="Pretendard Light" panose="02000403000000020004" pitchFamily="2" charset="-127"/>
-                <a:ea typeface="Pretendard Light" panose="02000403000000020004" pitchFamily="2" charset="-127"/>
-                <a:cs typeface="Pretendard Light" panose="02000403000000020004" pitchFamily="2" charset="-127"/>
-              </a:rPr>
-              <a:t>✔️ </a:t>
-            </a:r>
-            <a:r>
-              <a:rPr lang="en-US" altLang="ko-KR" sz="1400" dirty="0" err="1">
-                <a:latin typeface="Pretendard Light" panose="02000403000000020004" pitchFamily="2" charset="-127"/>
-                <a:ea typeface="Pretendard Light" panose="02000403000000020004" pitchFamily="2" charset="-127"/>
-                <a:cs typeface="Pretendard Light" panose="02000403000000020004" pitchFamily="2" charset="-127"/>
-              </a:rPr>
-              <a:t>declarative_base</a:t>
-            </a:r>
-            <a:r>
-              <a:rPr lang="en-US" altLang="ko-KR" sz="1400" dirty="0">
-                <a:latin typeface="Pretendard Light" panose="02000403000000020004" pitchFamily="2" charset="-127"/>
-                <a:ea typeface="Pretendard Light" panose="02000403000000020004" pitchFamily="2" charset="-127"/>
-                <a:cs typeface="Pretendard Light" panose="02000403000000020004" pitchFamily="2" charset="-127"/>
-              </a:rPr>
-              <a:t> : </a:t>
-            </a:r>
-            <a:r>
-              <a:rPr lang="ko-KR" altLang="en-US" sz="1400" dirty="0">
-                <a:latin typeface="Pretendard Light" panose="02000403000000020004" pitchFamily="2" charset="-127"/>
-                <a:ea typeface="Pretendard Light" panose="02000403000000020004" pitchFamily="2" charset="-127"/>
-                <a:cs typeface="Pretendard Light" panose="02000403000000020004" pitchFamily="2" charset="-127"/>
-              </a:rPr>
-              <a:t>모든 모델 클래스가 상속해야 할 기반 클래스 생성</a:t>
-            </a:r>
-          </a:p>
-        </p:txBody>
-      </p:sp>
-      <p:sp>
-        <p:nvSpPr>
-          <p:cNvPr id="12" name="직사각형 11">
-            <a:extLst>
-              <a:ext uri="{FF2B5EF4-FFF2-40B4-BE49-F238E27FC236}">
-                <a16:creationId xmlns:a16="http://schemas.microsoft.com/office/drawing/2014/main" id="{D8C0EB0F-0381-D89B-52FE-C86C7693F0B2}"/>
-              </a:ext>
-            </a:extLst>
-          </p:cNvPr>
-          <p:cNvSpPr/>
-          <p:nvPr/>
-        </p:nvSpPr>
-        <p:spPr>
-          <a:xfrm>
-            <a:off x="1778828" y="3297609"/>
-            <a:ext cx="7796972" cy="195465"/>
-          </a:xfrm>
-          <a:prstGeom prst="rect">
-            <a:avLst/>
-          </a:prstGeom>
-          <a:noFill/>
-          <a:ln w="19050">
-            <a:solidFill>
-              <a:srgbClr val="FF5050"/>
-            </a:solidFill>
-          </a:ln>
-        </p:spPr>
-        <p:style>
-          <a:lnRef idx="2">
-            <a:schemeClr val="accent1">
-              <a:shade val="15000"/>
-            </a:schemeClr>
-          </a:lnRef>
-          <a:fillRef idx="1">
-            <a:schemeClr val="accent1"/>
-          </a:fillRef>
-          <a:effectRef idx="0">
-            <a:schemeClr val="accent1"/>
-          </a:effectRef>
-          <a:fontRef idx="minor">
-            <a:schemeClr val="lt1"/>
-          </a:fontRef>
-        </p:style>
-        <p:txBody>
-          <a:bodyPr rtlCol="0" anchor="ctr"/>
-          <a:lstStyle/>
-          <a:p>
-            <a:pPr algn="ctr"/>
-            <a:endParaRPr lang="ko-KR" altLang="en-US"/>
-          </a:p>
-        </p:txBody>
-      </p:sp>
-      <p:sp>
-        <p:nvSpPr>
-          <p:cNvPr id="13" name="TextBox 12">
-            <a:extLst>
-              <a:ext uri="{FF2B5EF4-FFF2-40B4-BE49-F238E27FC236}">
-                <a16:creationId xmlns:a16="http://schemas.microsoft.com/office/drawing/2014/main" id="{11BC08CD-4841-ECF2-DA74-EF7B53C205B1}"/>
-              </a:ext>
-            </a:extLst>
-          </p:cNvPr>
-          <p:cNvSpPr txBox="1"/>
-          <p:nvPr/>
-        </p:nvSpPr>
-        <p:spPr>
-          <a:xfrm>
-            <a:off x="6042025" y="3487177"/>
-            <a:ext cx="3757612" cy="307777"/>
-          </a:xfrm>
-          <a:prstGeom prst="rect">
-            <a:avLst/>
-          </a:prstGeom>
-          <a:noFill/>
-        </p:spPr>
-        <p:txBody>
-          <a:bodyPr wrap="square" rtlCol="0">
-            <a:spAutoFit/>
-          </a:bodyPr>
-          <a:lstStyle/>
-          <a:p>
-            <a:r>
-              <a:rPr lang="ko-KR" altLang="en-US" sz="1400" dirty="0">
-                <a:solidFill>
-                  <a:schemeClr val="bg1"/>
-                </a:solidFill>
-              </a:rPr>
-              <a:t>실제 </a:t>
-            </a:r>
-            <a:r>
-              <a:rPr lang="en-US" altLang="ko-KR" sz="1400" dirty="0">
-                <a:solidFill>
-                  <a:schemeClr val="bg1"/>
-                </a:solidFill>
-              </a:rPr>
-              <a:t>DB </a:t>
-            </a:r>
-            <a:r>
-              <a:rPr lang="ko-KR" altLang="en-US" sz="1400" dirty="0">
-                <a:solidFill>
-                  <a:schemeClr val="bg1"/>
-                </a:solidFill>
-              </a:rPr>
-              <a:t>작업을 수행할 세션을 만드는 함수를 생성</a:t>
-            </a:r>
-          </a:p>
-        </p:txBody>
-      </p:sp>
-      <p:sp>
-        <p:nvSpPr>
-          <p:cNvPr id="14" name="직사각형 13">
-            <a:extLst>
-              <a:ext uri="{FF2B5EF4-FFF2-40B4-BE49-F238E27FC236}">
-                <a16:creationId xmlns:a16="http://schemas.microsoft.com/office/drawing/2014/main" id="{D021FC4F-73F7-5276-D94C-A75E725E1B1D}"/>
-              </a:ext>
-            </a:extLst>
-          </p:cNvPr>
-          <p:cNvSpPr/>
-          <p:nvPr/>
-        </p:nvSpPr>
-        <p:spPr>
-          <a:xfrm>
-            <a:off x="1778828" y="3809081"/>
-            <a:ext cx="2640772" cy="195465"/>
-          </a:xfrm>
-          <a:prstGeom prst="rect">
-            <a:avLst/>
-          </a:prstGeom>
-          <a:noFill/>
-          <a:ln w="19050">
-            <a:solidFill>
-              <a:srgbClr val="FF5050"/>
-            </a:solidFill>
-          </a:ln>
-        </p:spPr>
-        <p:style>
-          <a:lnRef idx="2">
-            <a:schemeClr val="accent1">
-              <a:shade val="15000"/>
-            </a:schemeClr>
-          </a:lnRef>
-          <a:fillRef idx="1">
-            <a:schemeClr val="accent1"/>
-          </a:fillRef>
-          <a:effectRef idx="0">
-            <a:schemeClr val="accent1"/>
-          </a:effectRef>
-          <a:fontRef idx="minor">
-            <a:schemeClr val="lt1"/>
-          </a:fontRef>
-        </p:style>
-        <p:txBody>
-          <a:bodyPr rtlCol="0" anchor="ctr"/>
-          <a:lstStyle/>
-          <a:p>
-            <a:pPr algn="ctr"/>
-            <a:endParaRPr lang="ko-KR" altLang="en-US"/>
-          </a:p>
-        </p:txBody>
-      </p:sp>
-      <p:sp>
-        <p:nvSpPr>
-          <p:cNvPr id="16" name="TextBox 15">
-            <a:extLst>
-              <a:ext uri="{FF2B5EF4-FFF2-40B4-BE49-F238E27FC236}">
-                <a16:creationId xmlns:a16="http://schemas.microsoft.com/office/drawing/2014/main" id="{1FDB71D4-5F68-5145-E7C3-F6E34743DB17}"/>
-              </a:ext>
-            </a:extLst>
-          </p:cNvPr>
-          <p:cNvSpPr txBox="1"/>
-          <p:nvPr/>
-        </p:nvSpPr>
-        <p:spPr>
-          <a:xfrm>
-            <a:off x="4371257" y="3752924"/>
-            <a:ext cx="2858218" cy="307777"/>
-          </a:xfrm>
-          <a:prstGeom prst="rect">
-            <a:avLst/>
-          </a:prstGeom>
-          <a:noFill/>
-        </p:spPr>
-        <p:txBody>
-          <a:bodyPr wrap="square" rtlCol="0">
-            <a:spAutoFit/>
-          </a:bodyPr>
-          <a:lstStyle/>
-          <a:p>
-            <a:r>
-              <a:rPr lang="ko-KR" altLang="en-US" sz="1400" dirty="0">
-                <a:solidFill>
-                  <a:schemeClr val="bg1"/>
-                </a:solidFill>
-              </a:rPr>
-              <a:t>모든 </a:t>
-            </a:r>
-            <a:r>
-              <a:rPr lang="en-US" altLang="ko-KR" sz="1400" dirty="0">
-                <a:solidFill>
-                  <a:schemeClr val="bg1"/>
-                </a:solidFill>
-              </a:rPr>
-              <a:t>ORM </a:t>
-            </a:r>
-            <a:r>
-              <a:rPr lang="ko-KR" altLang="en-US" sz="1400" dirty="0">
-                <a:solidFill>
-                  <a:schemeClr val="bg1"/>
-                </a:solidFill>
-              </a:rPr>
-              <a:t>모델 클래스의 부모 클래스</a:t>
-            </a:r>
-          </a:p>
-        </p:txBody>
-      </p:sp>
-      <p:sp>
-        <p:nvSpPr>
-          <p:cNvPr id="3" name="직사각형 2"/>
-          <p:cNvSpPr/>
-          <p:nvPr/>
-        </p:nvSpPr>
-        <p:spPr>
-          <a:xfrm>
-            <a:off x="6308390" y="4293255"/>
-            <a:ext cx="4879744" cy="1061829"/>
-          </a:xfrm>
-          <a:prstGeom prst="rect">
-            <a:avLst/>
-          </a:prstGeom>
-        </p:spPr>
-        <p:txBody>
-          <a:bodyPr wrap="square">
-            <a:spAutoFit/>
-          </a:bodyPr>
-          <a:lstStyle/>
-          <a:p>
-            <a:pPr>
-              <a:lnSpc>
-                <a:spcPct val="150000"/>
-              </a:lnSpc>
-            </a:pPr>
-            <a:r>
-              <a:rPr lang="ko-KR" altLang="en-US" sz="1400" dirty="0">
-                <a:latin typeface="Pretendard Light" panose="02000403000000020004" pitchFamily="2" charset="-127"/>
-                <a:ea typeface="Pretendard Light" panose="02000403000000020004" pitchFamily="2" charset="-127"/>
-                <a:cs typeface="Pretendard Light" panose="02000403000000020004" pitchFamily="2" charset="-127"/>
-              </a:rPr>
-              <a:t>✔️ 세션 객체</a:t>
-            </a:r>
-            <a:r>
-              <a:rPr lang="en-US" altLang="ko-KR" sz="1400" dirty="0">
-                <a:latin typeface="Pretendard Light" pitchFamily="2" charset="-127"/>
-                <a:ea typeface="Pretendard Light" pitchFamily="2" charset="-127"/>
-                <a:cs typeface="Pretendard Light" pitchFamily="2" charset="-127"/>
-              </a:rPr>
-              <a:t>:</a:t>
-            </a:r>
-          </a:p>
-          <a:p>
-            <a:pPr marL="742950" lvl="1" indent="-285750">
-              <a:lnSpc>
-                <a:spcPct val="150000"/>
-              </a:lnSpc>
-              <a:buFont typeface="Arial" pitchFamily="34" charset="0"/>
-              <a:buChar char="•"/>
-            </a:pPr>
-            <a:r>
-              <a:rPr lang="ko-KR" altLang="en-US" sz="1400" dirty="0">
-                <a:latin typeface="Pretendard Light" pitchFamily="2" charset="-127"/>
-                <a:ea typeface="Pretendard Light" pitchFamily="2" charset="-127"/>
-                <a:cs typeface="Pretendard Light" pitchFamily="2" charset="-127"/>
-              </a:rPr>
-              <a:t>데이터베이스와의 연결을 관리하고</a:t>
-            </a:r>
-            <a:r>
-              <a:rPr lang="en-US" altLang="ko-KR" sz="1400" dirty="0">
-                <a:latin typeface="Pretendard Light" pitchFamily="2" charset="-127"/>
-                <a:ea typeface="Pretendard Light" pitchFamily="2" charset="-127"/>
-                <a:cs typeface="Pretendard Light" pitchFamily="2" charset="-127"/>
-              </a:rPr>
-              <a:t>, </a:t>
-            </a:r>
-            <a:r>
-              <a:rPr lang="ko-KR" altLang="en-US" sz="1400" dirty="0">
-                <a:latin typeface="Pretendard Light" pitchFamily="2" charset="-127"/>
-                <a:ea typeface="Pretendard Light" pitchFamily="2" charset="-127"/>
-                <a:cs typeface="Pretendard Light" pitchFamily="2" charset="-127"/>
-              </a:rPr>
-              <a:t>추가</a:t>
-            </a:r>
-            <a:r>
-              <a:rPr lang="en-US" altLang="ko-KR" sz="1400" dirty="0">
-                <a:latin typeface="Pretendard Light" pitchFamily="2" charset="-127"/>
-                <a:ea typeface="Pretendard Light" pitchFamily="2" charset="-127"/>
-                <a:cs typeface="Pretendard Light" pitchFamily="2" charset="-127"/>
-              </a:rPr>
-              <a:t>/</a:t>
-            </a:r>
-            <a:r>
-              <a:rPr lang="ko-KR" altLang="en-US" sz="1400" dirty="0">
-                <a:latin typeface="Pretendard Light" pitchFamily="2" charset="-127"/>
-                <a:ea typeface="Pretendard Light" pitchFamily="2" charset="-127"/>
-                <a:cs typeface="Pretendard Light" pitchFamily="2" charset="-127"/>
-              </a:rPr>
-              <a:t>조회</a:t>
-            </a:r>
-            <a:r>
-              <a:rPr lang="en-US" altLang="ko-KR" sz="1400" dirty="0">
-                <a:latin typeface="Pretendard Light" pitchFamily="2" charset="-127"/>
-                <a:ea typeface="Pretendard Light" pitchFamily="2" charset="-127"/>
-                <a:cs typeface="Pretendard Light" pitchFamily="2" charset="-127"/>
-              </a:rPr>
-              <a:t>/</a:t>
-            </a:r>
-            <a:r>
-              <a:rPr lang="ko-KR" altLang="en-US" sz="1400" dirty="0">
-                <a:latin typeface="Pretendard Light" pitchFamily="2" charset="-127"/>
-                <a:ea typeface="Pretendard Light" pitchFamily="2" charset="-127"/>
-                <a:cs typeface="Pretendard Light" pitchFamily="2" charset="-127"/>
-              </a:rPr>
-              <a:t>수정</a:t>
-            </a:r>
-            <a:r>
-              <a:rPr lang="en-US" altLang="ko-KR" sz="1400" dirty="0">
-                <a:latin typeface="Pretendard Light" pitchFamily="2" charset="-127"/>
-                <a:ea typeface="Pretendard Light" pitchFamily="2" charset="-127"/>
-                <a:cs typeface="Pretendard Light" pitchFamily="2" charset="-127"/>
-              </a:rPr>
-              <a:t>/</a:t>
-            </a:r>
-            <a:r>
-              <a:rPr lang="ko-KR" altLang="en-US" sz="1400" dirty="0">
-                <a:latin typeface="Pretendard Light" pitchFamily="2" charset="-127"/>
-                <a:ea typeface="Pretendard Light" pitchFamily="2" charset="-127"/>
-                <a:cs typeface="Pretendard Light" pitchFamily="2" charset="-127"/>
-              </a:rPr>
-              <a:t>삭제 작업</a:t>
-            </a:r>
-            <a:r>
-              <a:rPr lang="en-US" altLang="ko-KR" sz="1400" dirty="0">
-                <a:latin typeface="Pretendard Light" pitchFamily="2" charset="-127"/>
-                <a:ea typeface="Pretendard Light" pitchFamily="2" charset="-127"/>
-                <a:cs typeface="Pretendard Light" pitchFamily="2" charset="-127"/>
-              </a:rPr>
-              <a:t>(CRUD)</a:t>
-            </a:r>
-            <a:r>
-              <a:rPr lang="ko-KR" altLang="en-US" sz="1400" dirty="0">
-                <a:latin typeface="Pretendard Light" pitchFamily="2" charset="-127"/>
-                <a:ea typeface="Pretendard Light" pitchFamily="2" charset="-127"/>
-                <a:cs typeface="Pretendard Light" pitchFamily="2" charset="-127"/>
-              </a:rPr>
-              <a:t> 을 수행하는 도구</a:t>
-            </a:r>
-          </a:p>
-        </p:txBody>
-      </p:sp>
-    </p:spTree>
-    <p:extLst>
-      <p:ext uri="{BB962C8B-B14F-4D97-AF65-F5344CB8AC3E}">
-        <p14:creationId xmlns:p14="http://schemas.microsoft.com/office/powerpoint/2010/main" val="3904610275"/>
-      </p:ext>
-    </p:extLst>
-  </p:cSld>
-  <p:clrMapOvr>
-    <a:masterClrMapping/>
-  </p:clrMapOvr>
-</p:sld>
-</file>
-
-<file path=ppt/slides/slide39.xml><?xml version="1.0" encoding="utf-8"?>
-<p:sld xmlns:a="http://schemas.openxmlformats.org/drawingml/2006/main" xmlns:r="http://schemas.openxmlformats.org/officeDocument/2006/relationships" xmlns:p="http://schemas.openxmlformats.org/presentationml/2006/main">
-  <p:cSld>
-    <p:spTree>
-      <p:nvGrpSpPr>
-        <p:cNvPr id="1" name="">
-          <a:extLst>
-            <a:ext uri="{FF2B5EF4-FFF2-40B4-BE49-F238E27FC236}">
-              <a16:creationId xmlns:a16="http://schemas.microsoft.com/office/drawing/2014/main" id="{04C7F36B-0EF6-A0E3-5252-9FA662EF7267}"/>
-            </a:ext>
-          </a:extLst>
-        </p:cNvPr>
-        <p:cNvGrpSpPr/>
-        <p:nvPr/>
-      </p:nvGrpSpPr>
-      <p:grpSpPr>
-        <a:xfrm>
-          <a:off x="0" y="0"/>
-          <a:ext cx="0" cy="0"/>
-          <a:chOff x="0" y="0"/>
-          <a:chExt cx="0" cy="0"/>
-        </a:xfrm>
-      </p:grpSpPr>
-      <p:sp>
-        <p:nvSpPr>
-          <p:cNvPr id="2" name="제목 1">
-            <a:extLst>
-              <a:ext uri="{FF2B5EF4-FFF2-40B4-BE49-F238E27FC236}">
-                <a16:creationId xmlns:a16="http://schemas.microsoft.com/office/drawing/2014/main" id="{04613FB2-18D9-A55C-1F8F-597CF7E2CF16}"/>
-              </a:ext>
-            </a:extLst>
-          </p:cNvPr>
-          <p:cNvSpPr>
-            <a:spLocks noGrp="1"/>
-          </p:cNvSpPr>
-          <p:nvPr>
-            <p:ph type="title"/>
-          </p:nvPr>
-        </p:nvSpPr>
-        <p:spPr/>
-        <p:txBody>
-          <a:bodyPr>
-            <a:normAutofit/>
-          </a:bodyPr>
-          <a:lstStyle/>
-          <a:p>
-            <a:r>
-              <a:rPr lang="ko-KR" altLang="en-US" b="1" dirty="0"/>
-              <a:t>사용자 모델 정의 </a:t>
-            </a:r>
-            <a:r>
-              <a:rPr lang="en-US" altLang="ko-KR" b="1" dirty="0"/>
-              <a:t>(models.py)</a:t>
-            </a:r>
-          </a:p>
-        </p:txBody>
-      </p:sp>
-      <p:pic>
-        <p:nvPicPr>
-          <p:cNvPr id="7" name="그림 6" descr="텍스트, 스크린샷, 디스플레이, 소프트웨어이(가) 표시된 사진&#10;&#10;AI가 생성한 콘텐츠는 부정확할 수 있습니다.">
-            <a:extLst>
-              <a:ext uri="{FF2B5EF4-FFF2-40B4-BE49-F238E27FC236}">
-                <a16:creationId xmlns:a16="http://schemas.microsoft.com/office/drawing/2014/main" id="{8DC54A3B-5F73-B33B-8860-EB1B75CE9C63}"/>
-              </a:ext>
-            </a:extLst>
-          </p:cNvPr>
-          <p:cNvPicPr>
-            <a:picLocks noChangeAspect="1"/>
-          </p:cNvPicPr>
-          <p:nvPr/>
-        </p:nvPicPr>
-        <p:blipFill>
-          <a:blip r:embed="rId3">
-            <a:extLst>
-              <a:ext uri="{28A0092B-C50C-407E-A947-70E740481C1C}">
-                <a14:useLocalDpi xmlns:a14="http://schemas.microsoft.com/office/drawing/2010/main" val="0"/>
-              </a:ext>
-            </a:extLst>
-          </a:blip>
-          <a:stretch>
-            <a:fillRect/>
-          </a:stretch>
-        </p:blipFill>
-        <p:spPr>
-          <a:xfrm>
-            <a:off x="0" y="494292"/>
-            <a:ext cx="12192000" cy="6200078"/>
-          </a:xfrm>
-          <a:prstGeom prst="rect">
-            <a:avLst/>
-          </a:prstGeom>
-        </p:spPr>
-      </p:pic>
-      <p:sp>
-        <p:nvSpPr>
-          <p:cNvPr id="11" name="직사각형 10">
-            <a:extLst>
-              <a:ext uri="{FF2B5EF4-FFF2-40B4-BE49-F238E27FC236}">
-                <a16:creationId xmlns:a16="http://schemas.microsoft.com/office/drawing/2014/main" id="{9C27A6B0-646D-B3B6-2545-F9A8BFEE6342}"/>
-              </a:ext>
-            </a:extLst>
-          </p:cNvPr>
-          <p:cNvSpPr/>
-          <p:nvPr/>
-        </p:nvSpPr>
-        <p:spPr>
-          <a:xfrm>
-            <a:off x="1378778" y="2600326"/>
-            <a:ext cx="2304222" cy="226296"/>
-          </a:xfrm>
-          <a:prstGeom prst="rect">
-            <a:avLst/>
-          </a:prstGeom>
-          <a:noFill/>
-          <a:ln w="19050">
-            <a:solidFill>
-              <a:srgbClr val="FF5050"/>
-            </a:solidFill>
-          </a:ln>
-        </p:spPr>
-        <p:style>
-          <a:lnRef idx="2">
-            <a:schemeClr val="accent1">
-              <a:shade val="15000"/>
-            </a:schemeClr>
-          </a:lnRef>
-          <a:fillRef idx="1">
-            <a:schemeClr val="accent1"/>
-          </a:fillRef>
-          <a:effectRef idx="0">
-            <a:schemeClr val="accent1"/>
-          </a:effectRef>
-          <a:fontRef idx="minor">
-            <a:schemeClr val="lt1"/>
-          </a:fontRef>
-        </p:style>
-        <p:txBody>
-          <a:bodyPr rtlCol="0" anchor="ctr"/>
-          <a:lstStyle/>
-          <a:p>
-            <a:pPr algn="ctr"/>
-            <a:endParaRPr lang="ko-KR" altLang="en-US"/>
-          </a:p>
-        </p:txBody>
-      </p:sp>
-      <p:sp>
-        <p:nvSpPr>
-          <p:cNvPr id="15" name="TextBox 14">
-            <a:extLst>
-              <a:ext uri="{FF2B5EF4-FFF2-40B4-BE49-F238E27FC236}">
-                <a16:creationId xmlns:a16="http://schemas.microsoft.com/office/drawing/2014/main" id="{FD86053B-65AD-E88D-D92E-076AB4F21A5E}"/>
-              </a:ext>
-            </a:extLst>
-          </p:cNvPr>
-          <p:cNvSpPr txBox="1"/>
-          <p:nvPr/>
-        </p:nvSpPr>
-        <p:spPr>
-          <a:xfrm>
-            <a:off x="3721440" y="2559585"/>
-            <a:ext cx="2858218" cy="307777"/>
-          </a:xfrm>
-          <a:prstGeom prst="rect">
-            <a:avLst/>
-          </a:prstGeom>
-          <a:noFill/>
-        </p:spPr>
-        <p:txBody>
-          <a:bodyPr wrap="square" rtlCol="0">
-            <a:spAutoFit/>
-          </a:bodyPr>
-          <a:lstStyle/>
-          <a:p>
-            <a:r>
-              <a:rPr lang="en-US" altLang="ko-KR" sz="1400" dirty="0">
-                <a:solidFill>
-                  <a:schemeClr val="bg1"/>
-                </a:solidFill>
-              </a:rPr>
-              <a:t>db.py</a:t>
-            </a:r>
-            <a:r>
-              <a:rPr lang="ko-KR" altLang="en-US" sz="1400" dirty="0">
-                <a:solidFill>
-                  <a:schemeClr val="bg1"/>
-                </a:solidFill>
-              </a:rPr>
-              <a:t>에서 만든 </a:t>
-            </a:r>
-            <a:r>
-              <a:rPr lang="en-US" altLang="ko-KR" sz="1400" dirty="0">
-                <a:solidFill>
-                  <a:schemeClr val="bg1"/>
-                </a:solidFill>
-              </a:rPr>
-              <a:t>Base import</a:t>
-            </a:r>
-            <a:endParaRPr lang="ko-KR" altLang="en-US" sz="1400" dirty="0">
-              <a:solidFill>
-                <a:schemeClr val="bg1"/>
-              </a:solidFill>
-            </a:endParaRPr>
-          </a:p>
-        </p:txBody>
-      </p:sp>
-      <p:sp>
-        <p:nvSpPr>
-          <p:cNvPr id="17" name="직사각형 16">
-            <a:extLst>
-              <a:ext uri="{FF2B5EF4-FFF2-40B4-BE49-F238E27FC236}">
-                <a16:creationId xmlns:a16="http://schemas.microsoft.com/office/drawing/2014/main" id="{5E858949-3F59-4EFE-6813-4A68A0EBC138}"/>
-              </a:ext>
-            </a:extLst>
-          </p:cNvPr>
-          <p:cNvSpPr/>
-          <p:nvPr/>
-        </p:nvSpPr>
-        <p:spPr>
-          <a:xfrm>
-            <a:off x="2569329" y="3146425"/>
-            <a:ext cx="804066" cy="264551"/>
-          </a:xfrm>
-          <a:prstGeom prst="rect">
-            <a:avLst/>
-          </a:prstGeom>
-          <a:noFill/>
-          <a:ln w="19050">
-            <a:solidFill>
-              <a:srgbClr val="FF5050"/>
-            </a:solidFill>
-          </a:ln>
-        </p:spPr>
-        <p:style>
-          <a:lnRef idx="2">
-            <a:schemeClr val="accent1">
-              <a:shade val="15000"/>
-            </a:schemeClr>
-          </a:lnRef>
-          <a:fillRef idx="1">
-            <a:schemeClr val="accent1"/>
-          </a:fillRef>
-          <a:effectRef idx="0">
-            <a:schemeClr val="accent1"/>
-          </a:effectRef>
-          <a:fontRef idx="minor">
-            <a:schemeClr val="lt1"/>
-          </a:fontRef>
-        </p:style>
-        <p:txBody>
-          <a:bodyPr rtlCol="0" anchor="ctr"/>
-          <a:lstStyle/>
-          <a:p>
-            <a:pPr algn="ctr"/>
-            <a:endParaRPr lang="ko-KR" altLang="en-US"/>
-          </a:p>
-        </p:txBody>
-      </p:sp>
-      <p:sp>
-        <p:nvSpPr>
-          <p:cNvPr id="18" name="TextBox 17">
-            <a:extLst>
-              <a:ext uri="{FF2B5EF4-FFF2-40B4-BE49-F238E27FC236}">
-                <a16:creationId xmlns:a16="http://schemas.microsoft.com/office/drawing/2014/main" id="{B21A7513-0E15-D15B-7269-EA345343A6FE}"/>
-              </a:ext>
-            </a:extLst>
-          </p:cNvPr>
-          <p:cNvSpPr txBox="1"/>
-          <p:nvPr/>
-        </p:nvSpPr>
-        <p:spPr>
-          <a:xfrm>
-            <a:off x="3373395" y="3103199"/>
-            <a:ext cx="2378675" cy="307777"/>
-          </a:xfrm>
-          <a:prstGeom prst="rect">
-            <a:avLst/>
-          </a:prstGeom>
-          <a:noFill/>
-        </p:spPr>
-        <p:txBody>
-          <a:bodyPr wrap="square" rtlCol="0">
-            <a:spAutoFit/>
-          </a:bodyPr>
-          <a:lstStyle/>
-          <a:p>
-            <a:r>
-              <a:rPr lang="en-US" altLang="ko-KR" sz="1400" dirty="0">
-                <a:solidFill>
-                  <a:schemeClr val="bg1"/>
-                </a:solidFill>
-              </a:rPr>
-              <a:t>Base </a:t>
-            </a:r>
-            <a:r>
-              <a:rPr lang="ko-KR" altLang="en-US" sz="1400" dirty="0">
-                <a:solidFill>
-                  <a:schemeClr val="bg1"/>
-                </a:solidFill>
-              </a:rPr>
-              <a:t>상속한 </a:t>
-            </a:r>
-            <a:r>
-              <a:rPr lang="en-US" altLang="ko-KR" sz="1400" dirty="0">
-                <a:solidFill>
-                  <a:schemeClr val="bg1"/>
-                </a:solidFill>
-              </a:rPr>
-              <a:t>User </a:t>
-            </a:r>
-            <a:r>
-              <a:rPr lang="ko-KR" altLang="en-US" sz="1400" dirty="0">
-                <a:solidFill>
-                  <a:schemeClr val="bg1"/>
-                </a:solidFill>
-              </a:rPr>
-              <a:t>클래스 생성</a:t>
-            </a:r>
-          </a:p>
-        </p:txBody>
-      </p:sp>
-      <p:sp>
-        <p:nvSpPr>
-          <p:cNvPr id="19" name="오른쪽 중괄호 18">
-            <a:extLst>
-              <a:ext uri="{FF2B5EF4-FFF2-40B4-BE49-F238E27FC236}">
-                <a16:creationId xmlns:a16="http://schemas.microsoft.com/office/drawing/2014/main" id="{19539EE4-8918-1B6A-4148-70FC7A2056B5}"/>
-              </a:ext>
-            </a:extLst>
-          </p:cNvPr>
-          <p:cNvSpPr/>
-          <p:nvPr/>
-        </p:nvSpPr>
-        <p:spPr>
-          <a:xfrm>
-            <a:off x="8539480" y="4136390"/>
-            <a:ext cx="147320" cy="1405890"/>
-          </a:xfrm>
-          <a:prstGeom prst="rightBrace">
-            <a:avLst/>
-          </a:prstGeom>
-          <a:ln w="25400">
-            <a:solidFill>
-              <a:schemeClr val="bg1"/>
-            </a:solidFill>
-          </a:ln>
-        </p:spPr>
-        <p:style>
-          <a:lnRef idx="1">
-            <a:schemeClr val="accent1"/>
-          </a:lnRef>
-          <a:fillRef idx="0">
-            <a:schemeClr val="accent1"/>
-          </a:fillRef>
-          <a:effectRef idx="0">
-            <a:schemeClr val="accent1"/>
-          </a:effectRef>
-          <a:fontRef idx="minor">
-            <a:schemeClr val="tx1"/>
-          </a:fontRef>
-        </p:style>
-        <p:txBody>
-          <a:bodyPr rtlCol="0" anchor="ctr"/>
-          <a:lstStyle/>
-          <a:p>
-            <a:pPr algn="ctr"/>
-            <a:endParaRPr lang="ko-KR" altLang="en-US"/>
-          </a:p>
-        </p:txBody>
-      </p:sp>
-      <p:sp>
-        <p:nvSpPr>
-          <p:cNvPr id="20" name="TextBox 19">
-            <a:extLst>
-              <a:ext uri="{FF2B5EF4-FFF2-40B4-BE49-F238E27FC236}">
-                <a16:creationId xmlns:a16="http://schemas.microsoft.com/office/drawing/2014/main" id="{83319009-2843-2F74-7391-04B58FC630D7}"/>
-              </a:ext>
-            </a:extLst>
-          </p:cNvPr>
-          <p:cNvSpPr txBox="1"/>
-          <p:nvPr/>
-        </p:nvSpPr>
-        <p:spPr>
-          <a:xfrm>
-            <a:off x="8686801" y="4685446"/>
-            <a:ext cx="1364166" cy="310300"/>
-          </a:xfrm>
-          <a:prstGeom prst="rect">
-            <a:avLst/>
-          </a:prstGeom>
-          <a:noFill/>
-        </p:spPr>
-        <p:txBody>
-          <a:bodyPr wrap="square" rtlCol="0">
-            <a:spAutoFit/>
-          </a:bodyPr>
-          <a:lstStyle/>
-          <a:p>
-            <a:r>
-              <a:rPr lang="en-US" altLang="ko-KR" sz="1400" dirty="0">
-                <a:solidFill>
-                  <a:schemeClr val="bg1"/>
-                </a:solidFill>
-              </a:rPr>
-              <a:t>Table </a:t>
-            </a:r>
-            <a:r>
-              <a:rPr lang="ko-KR" altLang="en-US" sz="1400" dirty="0">
-                <a:solidFill>
-                  <a:schemeClr val="bg1"/>
-                </a:solidFill>
-              </a:rPr>
-              <a:t>구조 정의</a:t>
-            </a:r>
-          </a:p>
-        </p:txBody>
-      </p:sp>
-    </p:spTree>
-    <p:extLst>
-      <p:ext uri="{BB962C8B-B14F-4D97-AF65-F5344CB8AC3E}">
-        <p14:creationId xmlns:p14="http://schemas.microsoft.com/office/powerpoint/2010/main" val="1331635481"/>
       </p:ext>
     </p:extLst>
   </p:cSld>
@@ -18130,6 +17276,1208 @@
         <p:cNvPr id="1" name="">
           <a:extLst>
             <a:ext uri="{FF2B5EF4-FFF2-40B4-BE49-F238E27FC236}">
+              <a16:creationId xmlns:a16="http://schemas.microsoft.com/office/drawing/2014/main" id="{D416CC96-0A4D-3652-40E4-0E88590519B5}"/>
+            </a:ext>
+          </a:extLst>
+        </p:cNvPr>
+        <p:cNvGrpSpPr/>
+        <p:nvPr/>
+      </p:nvGrpSpPr>
+      <p:grpSpPr>
+        <a:xfrm>
+          <a:off x="0" y="0"/>
+          <a:ext cx="0" cy="0"/>
+          <a:chOff x="0" y="0"/>
+          <a:chExt cx="0" cy="0"/>
+        </a:xfrm>
+      </p:grpSpPr>
+      <p:pic>
+        <p:nvPicPr>
+          <p:cNvPr id="11" name="그림 10" descr="텍스트, 스크린샷, 폰트, 소프트웨어이(가) 표시된 사진&#10;&#10;AI가 생성한 콘텐츠는 부정확할 수 있습니다.">
+            <a:extLst>
+              <a:ext uri="{FF2B5EF4-FFF2-40B4-BE49-F238E27FC236}">
+                <a16:creationId xmlns:a16="http://schemas.microsoft.com/office/drawing/2014/main" id="{326838E0-1A46-152C-4663-463E3E86EA6F}"/>
+              </a:ext>
+            </a:extLst>
+          </p:cNvPr>
+          <p:cNvPicPr>
+            <a:picLocks noChangeAspect="1"/>
+          </p:cNvPicPr>
+          <p:nvPr/>
+        </p:nvPicPr>
+        <p:blipFill>
+          <a:blip r:embed="rId3">
+            <a:extLst>
+              <a:ext uri="{28A0092B-C50C-407E-A947-70E740481C1C}">
+                <a14:useLocalDpi xmlns:a14="http://schemas.microsoft.com/office/drawing/2010/main" val="0"/>
+              </a:ext>
+            </a:extLst>
+          </a:blip>
+          <a:stretch>
+            <a:fillRect/>
+          </a:stretch>
+        </p:blipFill>
+        <p:spPr>
+          <a:xfrm>
+            <a:off x="593558" y="385212"/>
+            <a:ext cx="11004884" cy="4576422"/>
+          </a:xfrm>
+          <a:prstGeom prst="rect">
+            <a:avLst/>
+          </a:prstGeom>
+        </p:spPr>
+      </p:pic>
+      <p:sp>
+        <p:nvSpPr>
+          <p:cNvPr id="2" name="제목 1">
+            <a:extLst>
+              <a:ext uri="{FF2B5EF4-FFF2-40B4-BE49-F238E27FC236}">
+                <a16:creationId xmlns:a16="http://schemas.microsoft.com/office/drawing/2014/main" id="{753B3671-8DE1-2A61-5634-147CC42AE941}"/>
+              </a:ext>
+            </a:extLst>
+          </p:cNvPr>
+          <p:cNvSpPr>
+            <a:spLocks noGrp="1"/>
+          </p:cNvSpPr>
+          <p:nvPr>
+            <p:ph type="title"/>
+          </p:nvPr>
+        </p:nvSpPr>
+        <p:spPr/>
+        <p:txBody>
+          <a:bodyPr>
+            <a:normAutofit/>
+          </a:bodyPr>
+          <a:lstStyle/>
+          <a:p>
+            <a:r>
+              <a:rPr lang="en-US" altLang="ko-KR" b="1" dirty="0"/>
+              <a:t>DB </a:t>
+            </a:r>
+            <a:r>
+              <a:rPr lang="ko-KR" altLang="en-US" b="1" dirty="0"/>
+              <a:t>세션 구성 </a:t>
+            </a:r>
+            <a:r>
+              <a:rPr lang="en-US" altLang="ko-KR" b="1" dirty="0"/>
+              <a:t>(db.py)</a:t>
+            </a:r>
+          </a:p>
+        </p:txBody>
+      </p:sp>
+      <p:sp>
+        <p:nvSpPr>
+          <p:cNvPr id="5" name="직사각형 4">
+            <a:extLst>
+              <a:ext uri="{FF2B5EF4-FFF2-40B4-BE49-F238E27FC236}">
+                <a16:creationId xmlns:a16="http://schemas.microsoft.com/office/drawing/2014/main" id="{FA1D204F-85A0-3D90-4525-91598FA94379}"/>
+              </a:ext>
+            </a:extLst>
+          </p:cNvPr>
+          <p:cNvSpPr/>
+          <p:nvPr/>
+        </p:nvSpPr>
+        <p:spPr>
+          <a:xfrm>
+            <a:off x="1215691" y="4249308"/>
+            <a:ext cx="8114501" cy="2086405"/>
+          </a:xfrm>
+          <a:prstGeom prst="rect">
+            <a:avLst/>
+          </a:prstGeom>
+        </p:spPr>
+        <p:txBody>
+          <a:bodyPr wrap="square">
+            <a:spAutoFit/>
+          </a:bodyPr>
+          <a:lstStyle/>
+          <a:p>
+            <a:pPr>
+              <a:lnSpc>
+                <a:spcPct val="150000"/>
+              </a:lnSpc>
+            </a:pPr>
+            <a:r>
+              <a:rPr lang="ko-KR" altLang="en-US" sz="1600" dirty="0">
+                <a:latin typeface="Pretendard Light" panose="02000403000000020004" pitchFamily="2" charset="-127"/>
+                <a:ea typeface="Pretendard Light" panose="02000403000000020004" pitchFamily="2" charset="-127"/>
+                <a:cs typeface="Pretendard Light" panose="02000403000000020004" pitchFamily="2" charset="-127"/>
+              </a:rPr>
+              <a:t>✔️ </a:t>
+            </a:r>
+            <a:r>
+              <a:rPr lang="en-US" altLang="ko-KR" sz="1600" dirty="0" err="1">
+                <a:latin typeface="Pretendard Light" panose="02000403000000020004" pitchFamily="2" charset="-127"/>
+                <a:ea typeface="Pretendard Light" panose="02000403000000020004" pitchFamily="2" charset="-127"/>
+                <a:cs typeface="Pretendard Light" panose="02000403000000020004" pitchFamily="2" charset="-127"/>
+              </a:rPr>
+              <a:t>create_engine</a:t>
+            </a:r>
+            <a:r>
+              <a:rPr lang="en-US" altLang="ko-KR" sz="1600" dirty="0">
+                <a:latin typeface="Pretendard Light" panose="02000403000000020004" pitchFamily="2" charset="-127"/>
+                <a:ea typeface="Pretendard Light" panose="02000403000000020004" pitchFamily="2" charset="-127"/>
+                <a:cs typeface="Pretendard Light" panose="02000403000000020004" pitchFamily="2" charset="-127"/>
+              </a:rPr>
+              <a:t> : engine </a:t>
+            </a:r>
+            <a:r>
+              <a:rPr lang="ko-KR" altLang="en-US" sz="1600" dirty="0">
+                <a:latin typeface="Pretendard Light" panose="02000403000000020004" pitchFamily="2" charset="-127"/>
+                <a:ea typeface="Pretendard Light" panose="02000403000000020004" pitchFamily="2" charset="-127"/>
+                <a:cs typeface="Pretendard Light" panose="02000403000000020004" pitchFamily="2" charset="-127"/>
+              </a:rPr>
+              <a:t>객체를 만들기 위한 함수</a:t>
+            </a:r>
+            <a:endParaRPr lang="en-US" altLang="ko-KR" sz="1600" dirty="0">
+              <a:latin typeface="Pretendard Light" panose="02000403000000020004" pitchFamily="2" charset="-127"/>
+              <a:ea typeface="Pretendard Light" panose="02000403000000020004" pitchFamily="2" charset="-127"/>
+              <a:cs typeface="Pretendard Light" panose="02000403000000020004" pitchFamily="2" charset="-127"/>
+            </a:endParaRPr>
+          </a:p>
+          <a:p>
+            <a:pPr>
+              <a:lnSpc>
+                <a:spcPct val="150000"/>
+              </a:lnSpc>
+            </a:pPr>
+            <a:r>
+              <a:rPr lang="ko-KR" altLang="en-US" sz="1600" dirty="0">
+                <a:latin typeface="Pretendard Light" panose="02000403000000020004" pitchFamily="2" charset="-127"/>
+                <a:ea typeface="Pretendard Light" panose="02000403000000020004" pitchFamily="2" charset="-127"/>
+                <a:cs typeface="Pretendard Light" panose="02000403000000020004" pitchFamily="2" charset="-127"/>
+              </a:rPr>
+              <a:t>✔️ </a:t>
+            </a:r>
+            <a:r>
+              <a:rPr lang="en-US" altLang="ko-KR" sz="1600" dirty="0" err="1">
+                <a:latin typeface="Pretendard Light" panose="02000403000000020004" pitchFamily="2" charset="-127"/>
+                <a:ea typeface="Pretendard Light" panose="02000403000000020004" pitchFamily="2" charset="-127"/>
+                <a:cs typeface="Pretendard Light" panose="02000403000000020004" pitchFamily="2" charset="-127"/>
+              </a:rPr>
+              <a:t>sessionmaker</a:t>
+            </a:r>
+            <a:r>
+              <a:rPr lang="en-US" altLang="ko-KR" sz="1600" dirty="0">
+                <a:latin typeface="Pretendard Light" panose="02000403000000020004" pitchFamily="2" charset="-127"/>
+                <a:ea typeface="Pretendard Light" panose="02000403000000020004" pitchFamily="2" charset="-127"/>
+                <a:cs typeface="Pretendard Light" panose="02000403000000020004" pitchFamily="2" charset="-127"/>
+              </a:rPr>
+              <a:t> : </a:t>
+            </a:r>
+            <a:r>
+              <a:rPr lang="ko-KR" altLang="en-US" sz="1600" dirty="0">
+                <a:latin typeface="Pretendard Light" panose="02000403000000020004" pitchFamily="2" charset="-127"/>
+                <a:ea typeface="Pretendard Light" panose="02000403000000020004" pitchFamily="2" charset="-127"/>
+                <a:cs typeface="Pretendard Light" panose="02000403000000020004" pitchFamily="2" charset="-127"/>
+              </a:rPr>
+              <a:t> 세션 객체를 생성하는 함수</a:t>
+            </a:r>
+            <a:endParaRPr lang="en-US" altLang="ko-KR" sz="1600" dirty="0">
+              <a:latin typeface="Pretendard Light" panose="02000403000000020004" pitchFamily="2" charset="-127"/>
+              <a:ea typeface="Pretendard Light" panose="02000403000000020004" pitchFamily="2" charset="-127"/>
+              <a:cs typeface="Pretendard Light" panose="02000403000000020004" pitchFamily="2" charset="-127"/>
+            </a:endParaRPr>
+          </a:p>
+          <a:p>
+            <a:pPr marL="742950" lvl="1" indent="-285750">
+              <a:lnSpc>
+                <a:spcPct val="150000"/>
+              </a:lnSpc>
+              <a:buFont typeface="Arial" panose="020B0604020202020204" pitchFamily="34" charset="0"/>
+              <a:buChar char="•"/>
+            </a:pPr>
+            <a:r>
+              <a:rPr lang="en-US" altLang="ko-KR" sz="1400" dirty="0" err="1">
+                <a:latin typeface="Pretendard Light" panose="02000403000000020004" pitchFamily="2" charset="-127"/>
+                <a:ea typeface="Pretendard Light" panose="02000403000000020004" pitchFamily="2" charset="-127"/>
+                <a:cs typeface="Pretendard Light" panose="02000403000000020004" pitchFamily="2" charset="-127"/>
+              </a:rPr>
+              <a:t>autocommit</a:t>
+            </a:r>
+            <a:r>
+              <a:rPr lang="en-US" altLang="ko-KR" sz="1400" dirty="0">
+                <a:latin typeface="Pretendard Light" panose="02000403000000020004" pitchFamily="2" charset="-127"/>
+                <a:ea typeface="Pretendard Light" panose="02000403000000020004" pitchFamily="2" charset="-127"/>
+                <a:cs typeface="Pretendard Light" panose="02000403000000020004" pitchFamily="2" charset="-127"/>
+              </a:rPr>
+              <a:t>=False </a:t>
+            </a:r>
+            <a:r>
+              <a:rPr lang="ko-KR" altLang="en-US" sz="1400" dirty="0" err="1">
+                <a:latin typeface="Pretendard Light" panose="02000403000000020004" pitchFamily="2" charset="-127"/>
+                <a:ea typeface="Pretendard Light" panose="02000403000000020004" pitchFamily="2" charset="-127"/>
+                <a:cs typeface="Pretendard Light" panose="02000403000000020004" pitchFamily="2" charset="-127"/>
+              </a:rPr>
+              <a:t>커밋은</a:t>
+            </a:r>
+            <a:r>
+              <a:rPr lang="ko-KR" altLang="en-US" sz="1400" dirty="0">
+                <a:latin typeface="Pretendard Light" panose="02000403000000020004" pitchFamily="2" charset="-127"/>
+                <a:ea typeface="Pretendard Light" panose="02000403000000020004" pitchFamily="2" charset="-127"/>
+                <a:cs typeface="Pretendard Light" panose="02000403000000020004" pitchFamily="2" charset="-127"/>
+              </a:rPr>
+              <a:t> 명시적으로 </a:t>
+            </a:r>
+            <a:r>
+              <a:rPr lang="en-US" altLang="ko-KR" sz="1400" dirty="0">
+                <a:latin typeface="Pretendard Light" panose="02000403000000020004" pitchFamily="2" charset="-127"/>
+                <a:ea typeface="Pretendard Light" panose="02000403000000020004" pitchFamily="2" charset="-127"/>
+                <a:cs typeface="Pretendard Light" panose="02000403000000020004" pitchFamily="2" charset="-127"/>
+              </a:rPr>
+              <a:t>commit() </a:t>
+            </a:r>
+            <a:r>
+              <a:rPr lang="ko-KR" altLang="en-US" sz="1400" dirty="0">
+                <a:latin typeface="Pretendard Light" panose="02000403000000020004" pitchFamily="2" charset="-127"/>
+                <a:ea typeface="Pretendard Light" panose="02000403000000020004" pitchFamily="2" charset="-127"/>
+                <a:cs typeface="Pretendard Light" panose="02000403000000020004" pitchFamily="2" charset="-127"/>
+              </a:rPr>
+              <a:t>해야 함</a:t>
+            </a:r>
+          </a:p>
+          <a:p>
+            <a:pPr marL="742950" lvl="1" indent="-285750">
+              <a:lnSpc>
+                <a:spcPct val="150000"/>
+              </a:lnSpc>
+              <a:buFont typeface="Arial" panose="020B0604020202020204" pitchFamily="34" charset="0"/>
+              <a:buChar char="•"/>
+            </a:pPr>
+            <a:r>
+              <a:rPr lang="en-US" altLang="ko-KR" sz="1400" dirty="0" err="1">
+                <a:latin typeface="Pretendard Light" panose="02000403000000020004" pitchFamily="2" charset="-127"/>
+                <a:ea typeface="Pretendard Light" panose="02000403000000020004" pitchFamily="2" charset="-127"/>
+                <a:cs typeface="Pretendard Light" panose="02000403000000020004" pitchFamily="2" charset="-127"/>
+              </a:rPr>
+              <a:t>autoflush</a:t>
+            </a:r>
+            <a:r>
+              <a:rPr lang="en-US" altLang="ko-KR" sz="1400" dirty="0">
+                <a:latin typeface="Pretendard Light" panose="02000403000000020004" pitchFamily="2" charset="-127"/>
+                <a:ea typeface="Pretendard Light" panose="02000403000000020004" pitchFamily="2" charset="-127"/>
+                <a:cs typeface="Pretendard Light" panose="02000403000000020004" pitchFamily="2" charset="-127"/>
+              </a:rPr>
+              <a:t>=False </a:t>
+            </a:r>
+            <a:r>
+              <a:rPr lang="ko-KR" altLang="en-US" sz="1400" dirty="0">
+                <a:latin typeface="Pretendard Light" panose="02000403000000020004" pitchFamily="2" charset="-127"/>
+                <a:ea typeface="Pretendard Light" panose="02000403000000020004" pitchFamily="2" charset="-127"/>
+                <a:cs typeface="Pretendard Light" panose="02000403000000020004" pitchFamily="2" charset="-127"/>
+              </a:rPr>
+              <a:t>쿼리 실행 전에 자동 </a:t>
+            </a:r>
+            <a:r>
+              <a:rPr lang="en-US" altLang="ko-KR" sz="1400" dirty="0">
+                <a:latin typeface="Pretendard Light" panose="02000403000000020004" pitchFamily="2" charset="-127"/>
+                <a:ea typeface="Pretendard Light" panose="02000403000000020004" pitchFamily="2" charset="-127"/>
+                <a:cs typeface="Pretendard Light" panose="02000403000000020004" pitchFamily="2" charset="-127"/>
+              </a:rPr>
+              <a:t>flush </a:t>
+            </a:r>
+            <a:r>
+              <a:rPr lang="ko-KR" altLang="en-US" sz="1400" dirty="0">
+                <a:latin typeface="Pretendard Light" panose="02000403000000020004" pitchFamily="2" charset="-127"/>
+                <a:ea typeface="Pretendard Light" panose="02000403000000020004" pitchFamily="2" charset="-127"/>
+                <a:cs typeface="Pretendard Light" panose="02000403000000020004" pitchFamily="2" charset="-127"/>
+              </a:rPr>
+              <a:t>안 함</a:t>
+            </a:r>
+          </a:p>
+          <a:p>
+            <a:pPr marL="742950" lvl="1" indent="-285750">
+              <a:lnSpc>
+                <a:spcPct val="150000"/>
+              </a:lnSpc>
+              <a:buFont typeface="Arial" panose="020B0604020202020204" pitchFamily="34" charset="0"/>
+              <a:buChar char="•"/>
+            </a:pPr>
+            <a:r>
+              <a:rPr lang="en-US" altLang="ko-KR" sz="1400" dirty="0">
+                <a:latin typeface="Pretendard Light" panose="02000403000000020004" pitchFamily="2" charset="-127"/>
+                <a:ea typeface="Pretendard Light" panose="02000403000000020004" pitchFamily="2" charset="-127"/>
+                <a:cs typeface="Pretendard Light" panose="02000403000000020004" pitchFamily="2" charset="-127"/>
+              </a:rPr>
+              <a:t>bind=engine </a:t>
+            </a:r>
+            <a:r>
+              <a:rPr lang="ko-KR" altLang="en-US" sz="1400" dirty="0">
+                <a:latin typeface="Pretendard Light" panose="02000403000000020004" pitchFamily="2" charset="-127"/>
+                <a:ea typeface="Pretendard Light" panose="02000403000000020004" pitchFamily="2" charset="-127"/>
+                <a:cs typeface="Pretendard Light" panose="02000403000000020004" pitchFamily="2" charset="-127"/>
+              </a:rPr>
+              <a:t>이 세션은 위에서 만든 </a:t>
+            </a:r>
+            <a:r>
+              <a:rPr lang="en-US" altLang="ko-KR" sz="1400" dirty="0">
+                <a:latin typeface="Pretendard Light" panose="02000403000000020004" pitchFamily="2" charset="-127"/>
+                <a:ea typeface="Pretendard Light" panose="02000403000000020004" pitchFamily="2" charset="-127"/>
+                <a:cs typeface="Pretendard Light" panose="02000403000000020004" pitchFamily="2" charset="-127"/>
+              </a:rPr>
+              <a:t>engine</a:t>
+            </a:r>
+            <a:r>
+              <a:rPr lang="ko-KR" altLang="en-US" sz="1400" dirty="0">
+                <a:latin typeface="Pretendard Light" panose="02000403000000020004" pitchFamily="2" charset="-127"/>
+                <a:ea typeface="Pretendard Light" panose="02000403000000020004" pitchFamily="2" charset="-127"/>
+                <a:cs typeface="Pretendard Light" panose="02000403000000020004" pitchFamily="2" charset="-127"/>
+              </a:rPr>
+              <a:t>과 연결됨</a:t>
+            </a:r>
+            <a:endParaRPr lang="en-US" altLang="ko-KR" sz="1400" dirty="0">
+              <a:latin typeface="Pretendard Light" panose="02000403000000020004" pitchFamily="2" charset="-127"/>
+              <a:ea typeface="Pretendard Light" panose="02000403000000020004" pitchFamily="2" charset="-127"/>
+              <a:cs typeface="Pretendard Light" panose="02000403000000020004" pitchFamily="2" charset="-127"/>
+            </a:endParaRPr>
+          </a:p>
+          <a:p>
+            <a:pPr>
+              <a:lnSpc>
+                <a:spcPct val="150000"/>
+              </a:lnSpc>
+            </a:pPr>
+            <a:r>
+              <a:rPr lang="ko-KR" altLang="en-US" sz="1400" dirty="0">
+                <a:latin typeface="Pretendard Light" panose="02000403000000020004" pitchFamily="2" charset="-127"/>
+                <a:ea typeface="Pretendard Light" panose="02000403000000020004" pitchFamily="2" charset="-127"/>
+                <a:cs typeface="Pretendard Light" panose="02000403000000020004" pitchFamily="2" charset="-127"/>
+              </a:rPr>
+              <a:t>✔️ </a:t>
+            </a:r>
+            <a:r>
+              <a:rPr lang="en-US" altLang="ko-KR" sz="1400" dirty="0" err="1">
+                <a:latin typeface="Pretendard Light" panose="02000403000000020004" pitchFamily="2" charset="-127"/>
+                <a:ea typeface="Pretendard Light" panose="02000403000000020004" pitchFamily="2" charset="-127"/>
+                <a:cs typeface="Pretendard Light" panose="02000403000000020004" pitchFamily="2" charset="-127"/>
+              </a:rPr>
+              <a:t>declarative_base</a:t>
+            </a:r>
+            <a:r>
+              <a:rPr lang="en-US" altLang="ko-KR" sz="1400" dirty="0">
+                <a:latin typeface="Pretendard Light" panose="02000403000000020004" pitchFamily="2" charset="-127"/>
+                <a:ea typeface="Pretendard Light" panose="02000403000000020004" pitchFamily="2" charset="-127"/>
+                <a:cs typeface="Pretendard Light" panose="02000403000000020004" pitchFamily="2" charset="-127"/>
+              </a:rPr>
+              <a:t> : </a:t>
+            </a:r>
+            <a:r>
+              <a:rPr lang="ko-KR" altLang="en-US" sz="1400" dirty="0">
+                <a:latin typeface="Pretendard Light" panose="02000403000000020004" pitchFamily="2" charset="-127"/>
+                <a:ea typeface="Pretendard Light" panose="02000403000000020004" pitchFamily="2" charset="-127"/>
+                <a:cs typeface="Pretendard Light" panose="02000403000000020004" pitchFamily="2" charset="-127"/>
+              </a:rPr>
+              <a:t>모든 모델 클래스가 상속해야 할 기반 클래스 생성</a:t>
+            </a:r>
+          </a:p>
+        </p:txBody>
+      </p:sp>
+      <p:sp>
+        <p:nvSpPr>
+          <p:cNvPr id="12" name="직사각형 11">
+            <a:extLst>
+              <a:ext uri="{FF2B5EF4-FFF2-40B4-BE49-F238E27FC236}">
+                <a16:creationId xmlns:a16="http://schemas.microsoft.com/office/drawing/2014/main" id="{D8C0EB0F-0381-D89B-52FE-C86C7693F0B2}"/>
+              </a:ext>
+            </a:extLst>
+          </p:cNvPr>
+          <p:cNvSpPr/>
+          <p:nvPr/>
+        </p:nvSpPr>
+        <p:spPr>
+          <a:xfrm>
+            <a:off x="1778828" y="3297609"/>
+            <a:ext cx="7796972" cy="195465"/>
+          </a:xfrm>
+          <a:prstGeom prst="rect">
+            <a:avLst/>
+          </a:prstGeom>
+          <a:noFill/>
+          <a:ln w="19050">
+            <a:solidFill>
+              <a:srgbClr val="FF5050"/>
+            </a:solidFill>
+          </a:ln>
+        </p:spPr>
+        <p:style>
+          <a:lnRef idx="2">
+            <a:schemeClr val="accent1">
+              <a:shade val="15000"/>
+            </a:schemeClr>
+          </a:lnRef>
+          <a:fillRef idx="1">
+            <a:schemeClr val="accent1"/>
+          </a:fillRef>
+          <a:effectRef idx="0">
+            <a:schemeClr val="accent1"/>
+          </a:effectRef>
+          <a:fontRef idx="minor">
+            <a:schemeClr val="lt1"/>
+          </a:fontRef>
+        </p:style>
+        <p:txBody>
+          <a:bodyPr rtlCol="0" anchor="ctr"/>
+          <a:lstStyle/>
+          <a:p>
+            <a:pPr algn="ctr"/>
+            <a:endParaRPr lang="ko-KR" altLang="en-US"/>
+          </a:p>
+        </p:txBody>
+      </p:sp>
+      <p:sp>
+        <p:nvSpPr>
+          <p:cNvPr id="13" name="TextBox 12">
+            <a:extLst>
+              <a:ext uri="{FF2B5EF4-FFF2-40B4-BE49-F238E27FC236}">
+                <a16:creationId xmlns:a16="http://schemas.microsoft.com/office/drawing/2014/main" id="{11BC08CD-4841-ECF2-DA74-EF7B53C205B1}"/>
+              </a:ext>
+            </a:extLst>
+          </p:cNvPr>
+          <p:cNvSpPr txBox="1"/>
+          <p:nvPr/>
+        </p:nvSpPr>
+        <p:spPr>
+          <a:xfrm>
+            <a:off x="6042025" y="3487177"/>
+            <a:ext cx="3757612" cy="307777"/>
+          </a:xfrm>
+          <a:prstGeom prst="rect">
+            <a:avLst/>
+          </a:prstGeom>
+          <a:noFill/>
+        </p:spPr>
+        <p:txBody>
+          <a:bodyPr wrap="square" rtlCol="0">
+            <a:spAutoFit/>
+          </a:bodyPr>
+          <a:lstStyle/>
+          <a:p>
+            <a:r>
+              <a:rPr lang="ko-KR" altLang="en-US" sz="1400" dirty="0">
+                <a:solidFill>
+                  <a:schemeClr val="bg1"/>
+                </a:solidFill>
+              </a:rPr>
+              <a:t>실제 </a:t>
+            </a:r>
+            <a:r>
+              <a:rPr lang="en-US" altLang="ko-KR" sz="1400" dirty="0">
+                <a:solidFill>
+                  <a:schemeClr val="bg1"/>
+                </a:solidFill>
+              </a:rPr>
+              <a:t>DB </a:t>
+            </a:r>
+            <a:r>
+              <a:rPr lang="ko-KR" altLang="en-US" sz="1400" dirty="0">
+                <a:solidFill>
+                  <a:schemeClr val="bg1"/>
+                </a:solidFill>
+              </a:rPr>
+              <a:t>작업을 수행할 세션을 만드는 함수를 생성</a:t>
+            </a:r>
+          </a:p>
+        </p:txBody>
+      </p:sp>
+      <p:sp>
+        <p:nvSpPr>
+          <p:cNvPr id="14" name="직사각형 13">
+            <a:extLst>
+              <a:ext uri="{FF2B5EF4-FFF2-40B4-BE49-F238E27FC236}">
+                <a16:creationId xmlns:a16="http://schemas.microsoft.com/office/drawing/2014/main" id="{D021FC4F-73F7-5276-D94C-A75E725E1B1D}"/>
+              </a:ext>
+            </a:extLst>
+          </p:cNvPr>
+          <p:cNvSpPr/>
+          <p:nvPr/>
+        </p:nvSpPr>
+        <p:spPr>
+          <a:xfrm>
+            <a:off x="1778828" y="3809081"/>
+            <a:ext cx="2640772" cy="195465"/>
+          </a:xfrm>
+          <a:prstGeom prst="rect">
+            <a:avLst/>
+          </a:prstGeom>
+          <a:noFill/>
+          <a:ln w="19050">
+            <a:solidFill>
+              <a:srgbClr val="FF5050"/>
+            </a:solidFill>
+          </a:ln>
+        </p:spPr>
+        <p:style>
+          <a:lnRef idx="2">
+            <a:schemeClr val="accent1">
+              <a:shade val="15000"/>
+            </a:schemeClr>
+          </a:lnRef>
+          <a:fillRef idx="1">
+            <a:schemeClr val="accent1"/>
+          </a:fillRef>
+          <a:effectRef idx="0">
+            <a:schemeClr val="accent1"/>
+          </a:effectRef>
+          <a:fontRef idx="minor">
+            <a:schemeClr val="lt1"/>
+          </a:fontRef>
+        </p:style>
+        <p:txBody>
+          <a:bodyPr rtlCol="0" anchor="ctr"/>
+          <a:lstStyle/>
+          <a:p>
+            <a:pPr algn="ctr"/>
+            <a:endParaRPr lang="ko-KR" altLang="en-US"/>
+          </a:p>
+        </p:txBody>
+      </p:sp>
+      <p:sp>
+        <p:nvSpPr>
+          <p:cNvPr id="16" name="TextBox 15">
+            <a:extLst>
+              <a:ext uri="{FF2B5EF4-FFF2-40B4-BE49-F238E27FC236}">
+                <a16:creationId xmlns:a16="http://schemas.microsoft.com/office/drawing/2014/main" id="{1FDB71D4-5F68-5145-E7C3-F6E34743DB17}"/>
+              </a:ext>
+            </a:extLst>
+          </p:cNvPr>
+          <p:cNvSpPr txBox="1"/>
+          <p:nvPr/>
+        </p:nvSpPr>
+        <p:spPr>
+          <a:xfrm>
+            <a:off x="4371257" y="3752924"/>
+            <a:ext cx="2858218" cy="307777"/>
+          </a:xfrm>
+          <a:prstGeom prst="rect">
+            <a:avLst/>
+          </a:prstGeom>
+          <a:noFill/>
+        </p:spPr>
+        <p:txBody>
+          <a:bodyPr wrap="square" rtlCol="0">
+            <a:spAutoFit/>
+          </a:bodyPr>
+          <a:lstStyle/>
+          <a:p>
+            <a:r>
+              <a:rPr lang="ko-KR" altLang="en-US" sz="1400" dirty="0">
+                <a:solidFill>
+                  <a:schemeClr val="bg1"/>
+                </a:solidFill>
+              </a:rPr>
+              <a:t>모든 </a:t>
+            </a:r>
+            <a:r>
+              <a:rPr lang="en-US" altLang="ko-KR" sz="1400" dirty="0">
+                <a:solidFill>
+                  <a:schemeClr val="bg1"/>
+                </a:solidFill>
+              </a:rPr>
+              <a:t>ORM </a:t>
+            </a:r>
+            <a:r>
+              <a:rPr lang="ko-KR" altLang="en-US" sz="1400" dirty="0">
+                <a:solidFill>
+                  <a:schemeClr val="bg1"/>
+                </a:solidFill>
+              </a:rPr>
+              <a:t>모델 클래스의 부모 클래스</a:t>
+            </a:r>
+          </a:p>
+        </p:txBody>
+      </p:sp>
+      <p:sp>
+        <p:nvSpPr>
+          <p:cNvPr id="3" name="직사각형 2"/>
+          <p:cNvSpPr/>
+          <p:nvPr/>
+        </p:nvSpPr>
+        <p:spPr>
+          <a:xfrm>
+            <a:off x="6308390" y="4293255"/>
+            <a:ext cx="4879744" cy="1061829"/>
+          </a:xfrm>
+          <a:prstGeom prst="rect">
+            <a:avLst/>
+          </a:prstGeom>
+        </p:spPr>
+        <p:txBody>
+          <a:bodyPr wrap="square">
+            <a:spAutoFit/>
+          </a:bodyPr>
+          <a:lstStyle/>
+          <a:p>
+            <a:pPr>
+              <a:lnSpc>
+                <a:spcPct val="150000"/>
+              </a:lnSpc>
+            </a:pPr>
+            <a:r>
+              <a:rPr lang="ko-KR" altLang="en-US" sz="1400" dirty="0">
+                <a:latin typeface="Pretendard Light" panose="02000403000000020004" pitchFamily="2" charset="-127"/>
+                <a:ea typeface="Pretendard Light" panose="02000403000000020004" pitchFamily="2" charset="-127"/>
+                <a:cs typeface="Pretendard Light" panose="02000403000000020004" pitchFamily="2" charset="-127"/>
+              </a:rPr>
+              <a:t>✔️ 세션 객체</a:t>
+            </a:r>
+            <a:r>
+              <a:rPr lang="en-US" altLang="ko-KR" sz="1400" dirty="0">
+                <a:latin typeface="Pretendard Light" pitchFamily="2" charset="-127"/>
+                <a:ea typeface="Pretendard Light" pitchFamily="2" charset="-127"/>
+                <a:cs typeface="Pretendard Light" pitchFamily="2" charset="-127"/>
+              </a:rPr>
+              <a:t>:</a:t>
+            </a:r>
+          </a:p>
+          <a:p>
+            <a:pPr marL="742950" lvl="1" indent="-285750">
+              <a:lnSpc>
+                <a:spcPct val="150000"/>
+              </a:lnSpc>
+              <a:buFont typeface="Arial" pitchFamily="34" charset="0"/>
+              <a:buChar char="•"/>
+            </a:pPr>
+            <a:r>
+              <a:rPr lang="ko-KR" altLang="en-US" sz="1400" dirty="0">
+                <a:latin typeface="Pretendard Light" pitchFamily="2" charset="-127"/>
+                <a:ea typeface="Pretendard Light" pitchFamily="2" charset="-127"/>
+                <a:cs typeface="Pretendard Light" pitchFamily="2" charset="-127"/>
+              </a:rPr>
+              <a:t>데이터베이스와의 연결을 관리하고</a:t>
+            </a:r>
+            <a:r>
+              <a:rPr lang="en-US" altLang="ko-KR" sz="1400" dirty="0">
+                <a:latin typeface="Pretendard Light" pitchFamily="2" charset="-127"/>
+                <a:ea typeface="Pretendard Light" pitchFamily="2" charset="-127"/>
+                <a:cs typeface="Pretendard Light" pitchFamily="2" charset="-127"/>
+              </a:rPr>
+              <a:t>, </a:t>
+            </a:r>
+            <a:r>
+              <a:rPr lang="ko-KR" altLang="en-US" sz="1400" dirty="0">
+                <a:latin typeface="Pretendard Light" pitchFamily="2" charset="-127"/>
+                <a:ea typeface="Pretendard Light" pitchFamily="2" charset="-127"/>
+                <a:cs typeface="Pretendard Light" pitchFamily="2" charset="-127"/>
+              </a:rPr>
+              <a:t>추가</a:t>
+            </a:r>
+            <a:r>
+              <a:rPr lang="en-US" altLang="ko-KR" sz="1400" dirty="0">
+                <a:latin typeface="Pretendard Light" pitchFamily="2" charset="-127"/>
+                <a:ea typeface="Pretendard Light" pitchFamily="2" charset="-127"/>
+                <a:cs typeface="Pretendard Light" pitchFamily="2" charset="-127"/>
+              </a:rPr>
+              <a:t>/</a:t>
+            </a:r>
+            <a:r>
+              <a:rPr lang="ko-KR" altLang="en-US" sz="1400" dirty="0">
+                <a:latin typeface="Pretendard Light" pitchFamily="2" charset="-127"/>
+                <a:ea typeface="Pretendard Light" pitchFamily="2" charset="-127"/>
+                <a:cs typeface="Pretendard Light" pitchFamily="2" charset="-127"/>
+              </a:rPr>
+              <a:t>조회</a:t>
+            </a:r>
+            <a:r>
+              <a:rPr lang="en-US" altLang="ko-KR" sz="1400" dirty="0">
+                <a:latin typeface="Pretendard Light" pitchFamily="2" charset="-127"/>
+                <a:ea typeface="Pretendard Light" pitchFamily="2" charset="-127"/>
+                <a:cs typeface="Pretendard Light" pitchFamily="2" charset="-127"/>
+              </a:rPr>
+              <a:t>/</a:t>
+            </a:r>
+            <a:r>
+              <a:rPr lang="ko-KR" altLang="en-US" sz="1400" dirty="0">
+                <a:latin typeface="Pretendard Light" pitchFamily="2" charset="-127"/>
+                <a:ea typeface="Pretendard Light" pitchFamily="2" charset="-127"/>
+                <a:cs typeface="Pretendard Light" pitchFamily="2" charset="-127"/>
+              </a:rPr>
+              <a:t>수정</a:t>
+            </a:r>
+            <a:r>
+              <a:rPr lang="en-US" altLang="ko-KR" sz="1400" dirty="0">
+                <a:latin typeface="Pretendard Light" pitchFamily="2" charset="-127"/>
+                <a:ea typeface="Pretendard Light" pitchFamily="2" charset="-127"/>
+                <a:cs typeface="Pretendard Light" pitchFamily="2" charset="-127"/>
+              </a:rPr>
+              <a:t>/</a:t>
+            </a:r>
+            <a:r>
+              <a:rPr lang="ko-KR" altLang="en-US" sz="1400" dirty="0">
+                <a:latin typeface="Pretendard Light" pitchFamily="2" charset="-127"/>
+                <a:ea typeface="Pretendard Light" pitchFamily="2" charset="-127"/>
+                <a:cs typeface="Pretendard Light" pitchFamily="2" charset="-127"/>
+              </a:rPr>
+              <a:t>삭제 작업</a:t>
+            </a:r>
+            <a:r>
+              <a:rPr lang="en-US" altLang="ko-KR" sz="1400" dirty="0">
+                <a:latin typeface="Pretendard Light" pitchFamily="2" charset="-127"/>
+                <a:ea typeface="Pretendard Light" pitchFamily="2" charset="-127"/>
+                <a:cs typeface="Pretendard Light" pitchFamily="2" charset="-127"/>
+              </a:rPr>
+              <a:t>(CRUD)</a:t>
+            </a:r>
+            <a:r>
+              <a:rPr lang="ko-KR" altLang="en-US" sz="1400" dirty="0">
+                <a:latin typeface="Pretendard Light" pitchFamily="2" charset="-127"/>
+                <a:ea typeface="Pretendard Light" pitchFamily="2" charset="-127"/>
+                <a:cs typeface="Pretendard Light" pitchFamily="2" charset="-127"/>
+              </a:rPr>
+              <a:t> 을 수행하는 도구</a:t>
+            </a:r>
+          </a:p>
+        </p:txBody>
+      </p:sp>
+    </p:spTree>
+    <p:extLst>
+      <p:ext uri="{BB962C8B-B14F-4D97-AF65-F5344CB8AC3E}">
+        <p14:creationId xmlns:p14="http://schemas.microsoft.com/office/powerpoint/2010/main" val="3904610275"/>
+      </p:ext>
+    </p:extLst>
+  </p:cSld>
+  <p:clrMapOvr>
+    <a:masterClrMapping/>
+  </p:clrMapOvr>
+</p:sld>
+</file>
+
+<file path=ppt/slides/slide41.xml><?xml version="1.0" encoding="utf-8"?>
+<p:sld xmlns:a="http://schemas.openxmlformats.org/drawingml/2006/main" xmlns:r="http://schemas.openxmlformats.org/officeDocument/2006/relationships" xmlns:p="http://schemas.openxmlformats.org/presentationml/2006/main">
+  <p:cSld>
+    <p:spTree>
+      <p:nvGrpSpPr>
+        <p:cNvPr id="1" name="">
+          <a:extLst>
+            <a:ext uri="{FF2B5EF4-FFF2-40B4-BE49-F238E27FC236}">
+              <a16:creationId xmlns:a16="http://schemas.microsoft.com/office/drawing/2014/main" id="{04C7F36B-0EF6-A0E3-5252-9FA662EF7267}"/>
+            </a:ext>
+          </a:extLst>
+        </p:cNvPr>
+        <p:cNvGrpSpPr/>
+        <p:nvPr/>
+      </p:nvGrpSpPr>
+      <p:grpSpPr>
+        <a:xfrm>
+          <a:off x="0" y="0"/>
+          <a:ext cx="0" cy="0"/>
+          <a:chOff x="0" y="0"/>
+          <a:chExt cx="0" cy="0"/>
+        </a:xfrm>
+      </p:grpSpPr>
+      <p:sp>
+        <p:nvSpPr>
+          <p:cNvPr id="2" name="제목 1">
+            <a:extLst>
+              <a:ext uri="{FF2B5EF4-FFF2-40B4-BE49-F238E27FC236}">
+                <a16:creationId xmlns:a16="http://schemas.microsoft.com/office/drawing/2014/main" id="{04613FB2-18D9-A55C-1F8F-597CF7E2CF16}"/>
+              </a:ext>
+            </a:extLst>
+          </p:cNvPr>
+          <p:cNvSpPr>
+            <a:spLocks noGrp="1"/>
+          </p:cNvSpPr>
+          <p:nvPr>
+            <p:ph type="title"/>
+          </p:nvPr>
+        </p:nvSpPr>
+        <p:spPr/>
+        <p:txBody>
+          <a:bodyPr>
+            <a:normAutofit/>
+          </a:bodyPr>
+          <a:lstStyle/>
+          <a:p>
+            <a:r>
+              <a:rPr lang="ko-KR" altLang="en-US" b="1" dirty="0"/>
+              <a:t>사용자 모델 정의 </a:t>
+            </a:r>
+            <a:r>
+              <a:rPr lang="en-US" altLang="ko-KR" b="1" dirty="0"/>
+              <a:t>(models.py)</a:t>
+            </a:r>
+          </a:p>
+        </p:txBody>
+      </p:sp>
+      <p:pic>
+        <p:nvPicPr>
+          <p:cNvPr id="7" name="그림 6" descr="텍스트, 스크린샷, 디스플레이, 소프트웨어이(가) 표시된 사진&#10;&#10;AI가 생성한 콘텐츠는 부정확할 수 있습니다.">
+            <a:extLst>
+              <a:ext uri="{FF2B5EF4-FFF2-40B4-BE49-F238E27FC236}">
+                <a16:creationId xmlns:a16="http://schemas.microsoft.com/office/drawing/2014/main" id="{8DC54A3B-5F73-B33B-8860-EB1B75CE9C63}"/>
+              </a:ext>
+            </a:extLst>
+          </p:cNvPr>
+          <p:cNvPicPr>
+            <a:picLocks noChangeAspect="1"/>
+          </p:cNvPicPr>
+          <p:nvPr/>
+        </p:nvPicPr>
+        <p:blipFill>
+          <a:blip r:embed="rId3">
+            <a:extLst>
+              <a:ext uri="{28A0092B-C50C-407E-A947-70E740481C1C}">
+                <a14:useLocalDpi xmlns:a14="http://schemas.microsoft.com/office/drawing/2010/main" val="0"/>
+              </a:ext>
+            </a:extLst>
+          </a:blip>
+          <a:stretch>
+            <a:fillRect/>
+          </a:stretch>
+        </p:blipFill>
+        <p:spPr>
+          <a:xfrm>
+            <a:off x="0" y="494292"/>
+            <a:ext cx="12192000" cy="6200078"/>
+          </a:xfrm>
+          <a:prstGeom prst="rect">
+            <a:avLst/>
+          </a:prstGeom>
+        </p:spPr>
+      </p:pic>
+      <p:sp>
+        <p:nvSpPr>
+          <p:cNvPr id="11" name="직사각형 10">
+            <a:extLst>
+              <a:ext uri="{FF2B5EF4-FFF2-40B4-BE49-F238E27FC236}">
+                <a16:creationId xmlns:a16="http://schemas.microsoft.com/office/drawing/2014/main" id="{9C27A6B0-646D-B3B6-2545-F9A8BFEE6342}"/>
+              </a:ext>
+            </a:extLst>
+          </p:cNvPr>
+          <p:cNvSpPr/>
+          <p:nvPr/>
+        </p:nvSpPr>
+        <p:spPr>
+          <a:xfrm>
+            <a:off x="1378778" y="2600326"/>
+            <a:ext cx="2304222" cy="226296"/>
+          </a:xfrm>
+          <a:prstGeom prst="rect">
+            <a:avLst/>
+          </a:prstGeom>
+          <a:noFill/>
+          <a:ln w="19050">
+            <a:solidFill>
+              <a:srgbClr val="FF5050"/>
+            </a:solidFill>
+          </a:ln>
+        </p:spPr>
+        <p:style>
+          <a:lnRef idx="2">
+            <a:schemeClr val="accent1">
+              <a:shade val="15000"/>
+            </a:schemeClr>
+          </a:lnRef>
+          <a:fillRef idx="1">
+            <a:schemeClr val="accent1"/>
+          </a:fillRef>
+          <a:effectRef idx="0">
+            <a:schemeClr val="accent1"/>
+          </a:effectRef>
+          <a:fontRef idx="minor">
+            <a:schemeClr val="lt1"/>
+          </a:fontRef>
+        </p:style>
+        <p:txBody>
+          <a:bodyPr rtlCol="0" anchor="ctr"/>
+          <a:lstStyle/>
+          <a:p>
+            <a:pPr algn="ctr"/>
+            <a:endParaRPr lang="ko-KR" altLang="en-US"/>
+          </a:p>
+        </p:txBody>
+      </p:sp>
+      <p:sp>
+        <p:nvSpPr>
+          <p:cNvPr id="15" name="TextBox 14">
+            <a:extLst>
+              <a:ext uri="{FF2B5EF4-FFF2-40B4-BE49-F238E27FC236}">
+                <a16:creationId xmlns:a16="http://schemas.microsoft.com/office/drawing/2014/main" id="{FD86053B-65AD-E88D-D92E-076AB4F21A5E}"/>
+              </a:ext>
+            </a:extLst>
+          </p:cNvPr>
+          <p:cNvSpPr txBox="1"/>
+          <p:nvPr/>
+        </p:nvSpPr>
+        <p:spPr>
+          <a:xfrm>
+            <a:off x="3721440" y="2559585"/>
+            <a:ext cx="2858218" cy="307777"/>
+          </a:xfrm>
+          <a:prstGeom prst="rect">
+            <a:avLst/>
+          </a:prstGeom>
+          <a:noFill/>
+        </p:spPr>
+        <p:txBody>
+          <a:bodyPr wrap="square" rtlCol="0">
+            <a:spAutoFit/>
+          </a:bodyPr>
+          <a:lstStyle/>
+          <a:p>
+            <a:r>
+              <a:rPr lang="en-US" altLang="ko-KR" sz="1400" dirty="0">
+                <a:solidFill>
+                  <a:schemeClr val="bg1"/>
+                </a:solidFill>
+              </a:rPr>
+              <a:t>db.py</a:t>
+            </a:r>
+            <a:r>
+              <a:rPr lang="ko-KR" altLang="en-US" sz="1400" dirty="0">
+                <a:solidFill>
+                  <a:schemeClr val="bg1"/>
+                </a:solidFill>
+              </a:rPr>
+              <a:t>에서 만든 </a:t>
+            </a:r>
+            <a:r>
+              <a:rPr lang="en-US" altLang="ko-KR" sz="1400" dirty="0">
+                <a:solidFill>
+                  <a:schemeClr val="bg1"/>
+                </a:solidFill>
+              </a:rPr>
+              <a:t>Base import</a:t>
+            </a:r>
+            <a:endParaRPr lang="ko-KR" altLang="en-US" sz="1400" dirty="0">
+              <a:solidFill>
+                <a:schemeClr val="bg1"/>
+              </a:solidFill>
+            </a:endParaRPr>
+          </a:p>
+        </p:txBody>
+      </p:sp>
+      <p:sp>
+        <p:nvSpPr>
+          <p:cNvPr id="17" name="직사각형 16">
+            <a:extLst>
+              <a:ext uri="{FF2B5EF4-FFF2-40B4-BE49-F238E27FC236}">
+                <a16:creationId xmlns:a16="http://schemas.microsoft.com/office/drawing/2014/main" id="{5E858949-3F59-4EFE-6813-4A68A0EBC138}"/>
+              </a:ext>
+            </a:extLst>
+          </p:cNvPr>
+          <p:cNvSpPr/>
+          <p:nvPr/>
+        </p:nvSpPr>
+        <p:spPr>
+          <a:xfrm>
+            <a:off x="2569329" y="3146425"/>
+            <a:ext cx="804066" cy="264551"/>
+          </a:xfrm>
+          <a:prstGeom prst="rect">
+            <a:avLst/>
+          </a:prstGeom>
+          <a:noFill/>
+          <a:ln w="19050">
+            <a:solidFill>
+              <a:srgbClr val="FF5050"/>
+            </a:solidFill>
+          </a:ln>
+        </p:spPr>
+        <p:style>
+          <a:lnRef idx="2">
+            <a:schemeClr val="accent1">
+              <a:shade val="15000"/>
+            </a:schemeClr>
+          </a:lnRef>
+          <a:fillRef idx="1">
+            <a:schemeClr val="accent1"/>
+          </a:fillRef>
+          <a:effectRef idx="0">
+            <a:schemeClr val="accent1"/>
+          </a:effectRef>
+          <a:fontRef idx="minor">
+            <a:schemeClr val="lt1"/>
+          </a:fontRef>
+        </p:style>
+        <p:txBody>
+          <a:bodyPr rtlCol="0" anchor="ctr"/>
+          <a:lstStyle/>
+          <a:p>
+            <a:pPr algn="ctr"/>
+            <a:endParaRPr lang="ko-KR" altLang="en-US"/>
+          </a:p>
+        </p:txBody>
+      </p:sp>
+      <p:sp>
+        <p:nvSpPr>
+          <p:cNvPr id="18" name="TextBox 17">
+            <a:extLst>
+              <a:ext uri="{FF2B5EF4-FFF2-40B4-BE49-F238E27FC236}">
+                <a16:creationId xmlns:a16="http://schemas.microsoft.com/office/drawing/2014/main" id="{B21A7513-0E15-D15B-7269-EA345343A6FE}"/>
+              </a:ext>
+            </a:extLst>
+          </p:cNvPr>
+          <p:cNvSpPr txBox="1"/>
+          <p:nvPr/>
+        </p:nvSpPr>
+        <p:spPr>
+          <a:xfrm>
+            <a:off x="3373395" y="3103199"/>
+            <a:ext cx="2378675" cy="307777"/>
+          </a:xfrm>
+          <a:prstGeom prst="rect">
+            <a:avLst/>
+          </a:prstGeom>
+          <a:noFill/>
+        </p:spPr>
+        <p:txBody>
+          <a:bodyPr wrap="square" rtlCol="0">
+            <a:spAutoFit/>
+          </a:bodyPr>
+          <a:lstStyle/>
+          <a:p>
+            <a:r>
+              <a:rPr lang="en-US" altLang="ko-KR" sz="1400" dirty="0">
+                <a:solidFill>
+                  <a:schemeClr val="bg1"/>
+                </a:solidFill>
+              </a:rPr>
+              <a:t>Base </a:t>
+            </a:r>
+            <a:r>
+              <a:rPr lang="ko-KR" altLang="en-US" sz="1400" dirty="0">
+                <a:solidFill>
+                  <a:schemeClr val="bg1"/>
+                </a:solidFill>
+              </a:rPr>
+              <a:t>상속한 </a:t>
+            </a:r>
+            <a:r>
+              <a:rPr lang="en-US" altLang="ko-KR" sz="1400" dirty="0">
+                <a:solidFill>
+                  <a:schemeClr val="bg1"/>
+                </a:solidFill>
+              </a:rPr>
+              <a:t>User </a:t>
+            </a:r>
+            <a:r>
+              <a:rPr lang="ko-KR" altLang="en-US" sz="1400" dirty="0">
+                <a:solidFill>
+                  <a:schemeClr val="bg1"/>
+                </a:solidFill>
+              </a:rPr>
+              <a:t>클래스 생성</a:t>
+            </a:r>
+          </a:p>
+        </p:txBody>
+      </p:sp>
+      <p:sp>
+        <p:nvSpPr>
+          <p:cNvPr id="19" name="오른쪽 중괄호 18">
+            <a:extLst>
+              <a:ext uri="{FF2B5EF4-FFF2-40B4-BE49-F238E27FC236}">
+                <a16:creationId xmlns:a16="http://schemas.microsoft.com/office/drawing/2014/main" id="{19539EE4-8918-1B6A-4148-70FC7A2056B5}"/>
+              </a:ext>
+            </a:extLst>
+          </p:cNvPr>
+          <p:cNvSpPr/>
+          <p:nvPr/>
+        </p:nvSpPr>
+        <p:spPr>
+          <a:xfrm>
+            <a:off x="8539480" y="4136390"/>
+            <a:ext cx="147320" cy="1405890"/>
+          </a:xfrm>
+          <a:prstGeom prst="rightBrace">
+            <a:avLst/>
+          </a:prstGeom>
+          <a:ln w="25400">
+            <a:solidFill>
+              <a:schemeClr val="bg1"/>
+            </a:solidFill>
+          </a:ln>
+        </p:spPr>
+        <p:style>
+          <a:lnRef idx="1">
+            <a:schemeClr val="accent1"/>
+          </a:lnRef>
+          <a:fillRef idx="0">
+            <a:schemeClr val="accent1"/>
+          </a:fillRef>
+          <a:effectRef idx="0">
+            <a:schemeClr val="accent1"/>
+          </a:effectRef>
+          <a:fontRef idx="minor">
+            <a:schemeClr val="tx1"/>
+          </a:fontRef>
+        </p:style>
+        <p:txBody>
+          <a:bodyPr rtlCol="0" anchor="ctr"/>
+          <a:lstStyle/>
+          <a:p>
+            <a:pPr algn="ctr"/>
+            <a:endParaRPr lang="ko-KR" altLang="en-US"/>
+          </a:p>
+        </p:txBody>
+      </p:sp>
+      <p:sp>
+        <p:nvSpPr>
+          <p:cNvPr id="20" name="TextBox 19">
+            <a:extLst>
+              <a:ext uri="{FF2B5EF4-FFF2-40B4-BE49-F238E27FC236}">
+                <a16:creationId xmlns:a16="http://schemas.microsoft.com/office/drawing/2014/main" id="{83319009-2843-2F74-7391-04B58FC630D7}"/>
+              </a:ext>
+            </a:extLst>
+          </p:cNvPr>
+          <p:cNvSpPr txBox="1"/>
+          <p:nvPr/>
+        </p:nvSpPr>
+        <p:spPr>
+          <a:xfrm>
+            <a:off x="8686801" y="4685446"/>
+            <a:ext cx="1364166" cy="310300"/>
+          </a:xfrm>
+          <a:prstGeom prst="rect">
+            <a:avLst/>
+          </a:prstGeom>
+          <a:noFill/>
+        </p:spPr>
+        <p:txBody>
+          <a:bodyPr wrap="square" rtlCol="0">
+            <a:spAutoFit/>
+          </a:bodyPr>
+          <a:lstStyle/>
+          <a:p>
+            <a:r>
+              <a:rPr lang="en-US" altLang="ko-KR" sz="1400" dirty="0">
+                <a:solidFill>
+                  <a:schemeClr val="bg1"/>
+                </a:solidFill>
+              </a:rPr>
+              <a:t>Table </a:t>
+            </a:r>
+            <a:r>
+              <a:rPr lang="ko-KR" altLang="en-US" sz="1400" dirty="0">
+                <a:solidFill>
+                  <a:schemeClr val="bg1"/>
+                </a:solidFill>
+              </a:rPr>
+              <a:t>구조 정의</a:t>
+            </a:r>
+          </a:p>
+        </p:txBody>
+      </p:sp>
+    </p:spTree>
+    <p:extLst>
+      <p:ext uri="{BB962C8B-B14F-4D97-AF65-F5344CB8AC3E}">
+        <p14:creationId xmlns:p14="http://schemas.microsoft.com/office/powerpoint/2010/main" val="1331635481"/>
+      </p:ext>
+    </p:extLst>
+  </p:cSld>
+  <p:clrMapOvr>
+    <a:masterClrMapping/>
+  </p:clrMapOvr>
+</p:sld>
+</file>
+
+<file path=ppt/slides/slide42.xml><?xml version="1.0" encoding="utf-8"?>
+<p:sld xmlns:a="http://schemas.openxmlformats.org/drawingml/2006/main" xmlns:r="http://schemas.openxmlformats.org/officeDocument/2006/relationships" xmlns:p="http://schemas.openxmlformats.org/presentationml/2006/main">
+  <p:cSld>
+    <p:spTree>
+      <p:nvGrpSpPr>
+        <p:cNvPr id="1" name="">
+          <a:extLst>
+            <a:ext uri="{FF2B5EF4-FFF2-40B4-BE49-F238E27FC236}">
               <a16:creationId xmlns:a16="http://schemas.microsoft.com/office/drawing/2014/main" id="{7D277A68-D49B-75C7-278F-504AA6A41CC9}"/>
             </a:ext>
           </a:extLst>
@@ -18388,7 +18736,7 @@
 </p:sld>
 </file>
 
-<file path=ppt/slides/slide41.xml><?xml version="1.0" encoding="utf-8"?>
+<file path=ppt/slides/slide43.xml><?xml version="1.0" encoding="utf-8"?>
 <p:sld xmlns:a="http://schemas.openxmlformats.org/drawingml/2006/main" xmlns:r="http://schemas.openxmlformats.org/officeDocument/2006/relationships" xmlns:p="http://schemas.openxmlformats.org/presentationml/2006/main">
   <p:cSld>
     <p:spTree>
@@ -18495,7 +18843,7 @@
 </p:sld>
 </file>
 
-<file path=ppt/slides/slide42.xml><?xml version="1.0" encoding="utf-8"?>
+<file path=ppt/slides/slide44.xml><?xml version="1.0" encoding="utf-8"?>
 <p:sld xmlns:a="http://schemas.openxmlformats.org/drawingml/2006/main" xmlns:r="http://schemas.openxmlformats.org/officeDocument/2006/relationships" xmlns:p="http://schemas.openxmlformats.org/presentationml/2006/main">
   <p:cSld>
     <p:spTree>
@@ -18790,7 +19138,7 @@
 </p:sld>
 </file>
 
-<file path=ppt/slides/slide43.xml><?xml version="1.0" encoding="utf-8"?>
+<file path=ppt/slides/slide45.xml><?xml version="1.0" encoding="utf-8"?>
 <p:sld xmlns:a="http://schemas.openxmlformats.org/drawingml/2006/main" xmlns:r="http://schemas.openxmlformats.org/officeDocument/2006/relationships" xmlns:p="http://schemas.openxmlformats.org/presentationml/2006/main">
   <p:cSld>
     <p:spTree>
@@ -19092,7 +19440,7 @@
 </p:sld>
 </file>
 
-<file path=ppt/slides/slide44.xml><?xml version="1.0" encoding="utf-8"?>
+<file path=ppt/slides/slide46.xml><?xml version="1.0" encoding="utf-8"?>
 <p:sld xmlns:a="http://schemas.openxmlformats.org/drawingml/2006/main" xmlns:r="http://schemas.openxmlformats.org/officeDocument/2006/relationships" xmlns:p="http://schemas.openxmlformats.org/presentationml/2006/main">
   <p:cSld>
     <p:spTree>
@@ -19303,7 +19651,7 @@
 </p:sld>
 </file>
 
-<file path=ppt/slides/slide45.xml><?xml version="1.0" encoding="utf-8"?>
+<file path=ppt/slides/slide47.xml><?xml version="1.0" encoding="utf-8"?>
 <p:sld xmlns:a="http://schemas.openxmlformats.org/drawingml/2006/main" xmlns:r="http://schemas.openxmlformats.org/officeDocument/2006/relationships" xmlns:p="http://schemas.openxmlformats.org/presentationml/2006/main">
   <p:cSld>
     <p:spTree>
@@ -19513,7 +19861,7 @@
 </p:sld>
 </file>
 
-<file path=ppt/slides/slide46.xml><?xml version="1.0" encoding="utf-8"?>
+<file path=ppt/slides/slide48.xml><?xml version="1.0" encoding="utf-8"?>
 <p:sld xmlns:a="http://schemas.openxmlformats.org/drawingml/2006/main" xmlns:r="http://schemas.openxmlformats.org/officeDocument/2006/relationships" xmlns:p="http://schemas.openxmlformats.org/presentationml/2006/main" show="0">
   <p:cSld>
     <p:spTree>
@@ -19628,7 +19976,7 @@
 </p:sld>
 </file>
 
-<file path=ppt/slides/slide47.xml><?xml version="1.0" encoding="utf-8"?>
+<file path=ppt/slides/slide49.xml><?xml version="1.0" encoding="utf-8"?>
 <p:sld xmlns:a="http://schemas.openxmlformats.org/drawingml/2006/main" xmlns:r="http://schemas.openxmlformats.org/officeDocument/2006/relationships" xmlns:p="http://schemas.openxmlformats.org/presentationml/2006/main" show="0">
   <p:cSld>
     <p:spTree>
@@ -19774,7 +20122,108 @@
 </p:sld>
 </file>
 
-<file path=ppt/slides/slide48.xml><?xml version="1.0" encoding="utf-8"?>
+<file path=ppt/slides/slide5.xml><?xml version="1.0" encoding="utf-8"?>
+<p:sld xmlns:a="http://schemas.openxmlformats.org/drawingml/2006/main" xmlns:r="http://schemas.openxmlformats.org/officeDocument/2006/relationships" xmlns:p="http://schemas.openxmlformats.org/presentationml/2006/main">
+  <p:cSld>
+    <p:spTree>
+      <p:nvGrpSpPr>
+        <p:cNvPr id="1" name="">
+          <a:extLst>
+            <a:ext uri="{FF2B5EF4-FFF2-40B4-BE49-F238E27FC236}">
+              <a16:creationId xmlns:a16="http://schemas.microsoft.com/office/drawing/2014/main" id="{9BA349FE-4E21-A2BF-CABD-BA7D35D81BBA}"/>
+            </a:ext>
+          </a:extLst>
+        </p:cNvPr>
+        <p:cNvGrpSpPr/>
+        <p:nvPr/>
+      </p:nvGrpSpPr>
+      <p:grpSpPr>
+        <a:xfrm>
+          <a:off x="0" y="0"/>
+          <a:ext cx="0" cy="0"/>
+          <a:chOff x="0" y="0"/>
+          <a:chExt cx="0" cy="0"/>
+        </a:xfrm>
+      </p:grpSpPr>
+      <p:sp>
+        <p:nvSpPr>
+          <p:cNvPr id="2" name="제목 1">
+            <a:extLst>
+              <a:ext uri="{FF2B5EF4-FFF2-40B4-BE49-F238E27FC236}">
+                <a16:creationId xmlns:a16="http://schemas.microsoft.com/office/drawing/2014/main" id="{CF14DE52-6E53-C56C-AF36-38DE032A1357}"/>
+              </a:ext>
+            </a:extLst>
+          </p:cNvPr>
+          <p:cNvSpPr>
+            <a:spLocks noGrp="1"/>
+          </p:cNvSpPr>
+          <p:nvPr>
+            <p:ph type="title"/>
+          </p:nvPr>
+        </p:nvSpPr>
+        <p:spPr/>
+        <p:txBody>
+          <a:bodyPr>
+            <a:normAutofit/>
+          </a:bodyPr>
+          <a:lstStyle/>
+          <a:p>
+            <a:r>
+              <a:rPr lang="en-US" altLang="ko-KR" b="1" dirty="0"/>
+              <a:t>CRUD </a:t>
+            </a:r>
+            <a:r>
+              <a:rPr lang="ko-KR" altLang="en-US" b="1" dirty="0"/>
+              <a:t>테스트 테이블 만들기</a:t>
+            </a:r>
+            <a:endParaRPr lang="en-US" altLang="ko-KR" b="1" dirty="0"/>
+          </a:p>
+        </p:txBody>
+      </p:sp>
+      <p:pic>
+        <p:nvPicPr>
+          <p:cNvPr id="14" name="그림 13">
+            <a:extLst>
+              <a:ext uri="{FF2B5EF4-FFF2-40B4-BE49-F238E27FC236}">
+                <a16:creationId xmlns:a16="http://schemas.microsoft.com/office/drawing/2014/main" id="{86B888A5-DF57-12D0-E027-98F38234A298}"/>
+              </a:ext>
+            </a:extLst>
+          </p:cNvPr>
+          <p:cNvPicPr>
+            <a:picLocks noChangeAspect="1"/>
+          </p:cNvPicPr>
+          <p:nvPr/>
+        </p:nvPicPr>
+        <p:blipFill>
+          <a:blip r:embed="rId3"/>
+          <a:stretch>
+            <a:fillRect/>
+          </a:stretch>
+        </p:blipFill>
+        <p:spPr>
+          <a:xfrm>
+            <a:off x="825500" y="994766"/>
+            <a:ext cx="10541000" cy="5071668"/>
+          </a:xfrm>
+          <a:prstGeom prst="rect">
+            <a:avLst/>
+          </a:prstGeom>
+        </p:spPr>
+      </p:pic>
+    </p:spTree>
+    <p:extLst>
+      <p:ext uri="{BB962C8B-B14F-4D97-AF65-F5344CB8AC3E}">
+        <p14:creationId xmlns:p14="http://schemas.microsoft.com/office/powerpoint/2010/main" val="155472101"/>
+      </p:ext>
+    </p:extLst>
+  </p:cSld>
+  <p:clrMapOvr>
+    <a:masterClrMapping/>
+  </p:clrMapOvr>
+</p:sld>
+</file>
+
+<file path=ppt/slides/slide50.xml><?xml version="1.0" encoding="utf-8"?>
 <p:sld xmlns:a="http://schemas.openxmlformats.org/drawingml/2006/main" xmlns:r="http://schemas.openxmlformats.org/officeDocument/2006/relationships" xmlns:p="http://schemas.openxmlformats.org/presentationml/2006/main" show="0">
   <p:cSld>
     <p:spTree>
@@ -20004,7 +20453,7 @@
 </p:sld>
 </file>
 
-<file path=ppt/slides/slide49.xml><?xml version="1.0" encoding="utf-8"?>
+<file path=ppt/slides/slide51.xml><?xml version="1.0" encoding="utf-8"?>
 <p:sld xmlns:a="http://schemas.openxmlformats.org/drawingml/2006/main" xmlns:r="http://schemas.openxmlformats.org/officeDocument/2006/relationships" xmlns:p="http://schemas.openxmlformats.org/presentationml/2006/main" show="0">
   <p:cSld>
     <p:spTree>
@@ -20181,108 +20630,7 @@
 </p:sld>
 </file>
 
-<file path=ppt/slides/slide5.xml><?xml version="1.0" encoding="utf-8"?>
-<p:sld xmlns:a="http://schemas.openxmlformats.org/drawingml/2006/main" xmlns:r="http://schemas.openxmlformats.org/officeDocument/2006/relationships" xmlns:p="http://schemas.openxmlformats.org/presentationml/2006/main">
-  <p:cSld>
-    <p:spTree>
-      <p:nvGrpSpPr>
-        <p:cNvPr id="1" name="">
-          <a:extLst>
-            <a:ext uri="{FF2B5EF4-FFF2-40B4-BE49-F238E27FC236}">
-              <a16:creationId xmlns:a16="http://schemas.microsoft.com/office/drawing/2014/main" id="{9BA349FE-4E21-A2BF-CABD-BA7D35D81BBA}"/>
-            </a:ext>
-          </a:extLst>
-        </p:cNvPr>
-        <p:cNvGrpSpPr/>
-        <p:nvPr/>
-      </p:nvGrpSpPr>
-      <p:grpSpPr>
-        <a:xfrm>
-          <a:off x="0" y="0"/>
-          <a:ext cx="0" cy="0"/>
-          <a:chOff x="0" y="0"/>
-          <a:chExt cx="0" cy="0"/>
-        </a:xfrm>
-      </p:grpSpPr>
-      <p:sp>
-        <p:nvSpPr>
-          <p:cNvPr id="2" name="제목 1">
-            <a:extLst>
-              <a:ext uri="{FF2B5EF4-FFF2-40B4-BE49-F238E27FC236}">
-                <a16:creationId xmlns:a16="http://schemas.microsoft.com/office/drawing/2014/main" id="{CF14DE52-6E53-C56C-AF36-38DE032A1357}"/>
-              </a:ext>
-            </a:extLst>
-          </p:cNvPr>
-          <p:cNvSpPr>
-            <a:spLocks noGrp="1"/>
-          </p:cNvSpPr>
-          <p:nvPr>
-            <p:ph type="title"/>
-          </p:nvPr>
-        </p:nvSpPr>
-        <p:spPr/>
-        <p:txBody>
-          <a:bodyPr>
-            <a:normAutofit/>
-          </a:bodyPr>
-          <a:lstStyle/>
-          <a:p>
-            <a:r>
-              <a:rPr lang="en-US" altLang="ko-KR" b="1" dirty="0"/>
-              <a:t>CRUD </a:t>
-            </a:r>
-            <a:r>
-              <a:rPr lang="ko-KR" altLang="en-US" b="1" dirty="0"/>
-              <a:t>테스트 테이블 만들기</a:t>
-            </a:r>
-            <a:endParaRPr lang="en-US" altLang="ko-KR" b="1" dirty="0"/>
-          </a:p>
-        </p:txBody>
-      </p:sp>
-      <p:pic>
-        <p:nvPicPr>
-          <p:cNvPr id="14" name="그림 13">
-            <a:extLst>
-              <a:ext uri="{FF2B5EF4-FFF2-40B4-BE49-F238E27FC236}">
-                <a16:creationId xmlns:a16="http://schemas.microsoft.com/office/drawing/2014/main" id="{86B888A5-DF57-12D0-E027-98F38234A298}"/>
-              </a:ext>
-            </a:extLst>
-          </p:cNvPr>
-          <p:cNvPicPr>
-            <a:picLocks noChangeAspect="1"/>
-          </p:cNvPicPr>
-          <p:nvPr/>
-        </p:nvPicPr>
-        <p:blipFill>
-          <a:blip r:embed="rId3"/>
-          <a:stretch>
-            <a:fillRect/>
-          </a:stretch>
-        </p:blipFill>
-        <p:spPr>
-          <a:xfrm>
-            <a:off x="825500" y="994766"/>
-            <a:ext cx="10541000" cy="5071668"/>
-          </a:xfrm>
-          <a:prstGeom prst="rect">
-            <a:avLst/>
-          </a:prstGeom>
-        </p:spPr>
-      </p:pic>
-    </p:spTree>
-    <p:extLst>
-      <p:ext uri="{BB962C8B-B14F-4D97-AF65-F5344CB8AC3E}">
-        <p14:creationId xmlns:p14="http://schemas.microsoft.com/office/powerpoint/2010/main" val="155472101"/>
-      </p:ext>
-    </p:extLst>
-  </p:cSld>
-  <p:clrMapOvr>
-    <a:masterClrMapping/>
-  </p:clrMapOvr>
-</p:sld>
-</file>
-
-<file path=ppt/slides/slide50.xml><?xml version="1.0" encoding="utf-8"?>
+<file path=ppt/slides/slide52.xml><?xml version="1.0" encoding="utf-8"?>
 <p:sld xmlns:a="http://schemas.openxmlformats.org/drawingml/2006/main" xmlns:r="http://schemas.openxmlformats.org/officeDocument/2006/relationships" xmlns:p="http://schemas.openxmlformats.org/presentationml/2006/main" show="0">
   <p:cSld>
     <p:spTree>
@@ -20506,7 +20854,7 @@
 </p:sld>
 </file>
 
-<file path=ppt/slides/slide51.xml><?xml version="1.0" encoding="utf-8"?>
+<file path=ppt/slides/slide53.xml><?xml version="1.0" encoding="utf-8"?>
 <p:sld xmlns:a="http://schemas.openxmlformats.org/drawingml/2006/main" xmlns:r="http://schemas.openxmlformats.org/officeDocument/2006/relationships" xmlns:p="http://schemas.openxmlformats.org/presentationml/2006/main" show="0">
   <p:cSld>
     <p:spTree>
@@ -20818,7 +21166,7 @@
 </p:sld>
 </file>
 
-<file path=ppt/slides/slide52.xml><?xml version="1.0" encoding="utf-8"?>
+<file path=ppt/slides/slide54.xml><?xml version="1.0" encoding="utf-8"?>
 <p:sld xmlns:a="http://schemas.openxmlformats.org/drawingml/2006/main" xmlns:r="http://schemas.openxmlformats.org/officeDocument/2006/relationships" xmlns:p="http://schemas.openxmlformats.org/presentationml/2006/main" show="0">
   <p:cSld>
     <p:spTree>
@@ -21050,7 +21398,7 @@
 </p:sld>
 </file>
 
-<file path=ppt/slides/slide53.xml><?xml version="1.0" encoding="utf-8"?>
+<file path=ppt/slides/slide55.xml><?xml version="1.0" encoding="utf-8"?>
 <p:sld xmlns:a="http://schemas.openxmlformats.org/drawingml/2006/main" xmlns:r="http://schemas.openxmlformats.org/officeDocument/2006/relationships" xmlns:p="http://schemas.openxmlformats.org/presentationml/2006/main" show="0">
   <p:cSld>
     <p:spTree>
@@ -21230,7 +21578,7 @@
 </p:sld>
 </file>
 
-<file path=ppt/slides/slide54.xml><?xml version="1.0" encoding="utf-8"?>
+<file path=ppt/slides/slide56.xml><?xml version="1.0" encoding="utf-8"?>
 <p:sld xmlns:a="http://schemas.openxmlformats.org/drawingml/2006/main" xmlns:r="http://schemas.openxmlformats.org/officeDocument/2006/relationships" xmlns:p="http://schemas.openxmlformats.org/presentationml/2006/main" show="0">
   <p:cSld>
     <p:spTree>
@@ -21483,7 +21831,7 @@
 </p:sld>
 </file>
 
-<file path=ppt/slides/slide55.xml><?xml version="1.0" encoding="utf-8"?>
+<file path=ppt/slides/slide57.xml><?xml version="1.0" encoding="utf-8"?>
 <p:sld xmlns:a="http://schemas.openxmlformats.org/drawingml/2006/main" xmlns:r="http://schemas.openxmlformats.org/officeDocument/2006/relationships" xmlns:p="http://schemas.openxmlformats.org/presentationml/2006/main" show="0">
   <p:cSld>
     <p:spTree>
@@ -21826,7 +22174,7 @@
 </p:sld>
 </file>
 
-<file path=ppt/slides/slide56.xml><?xml version="1.0" encoding="utf-8"?>
+<file path=ppt/slides/slide58.xml><?xml version="1.0" encoding="utf-8"?>
 <p:sld xmlns:a="http://schemas.openxmlformats.org/drawingml/2006/main" xmlns:r="http://schemas.openxmlformats.org/officeDocument/2006/relationships" xmlns:p="http://schemas.openxmlformats.org/presentationml/2006/main" show="0">
   <p:cSld>
     <p:spTree>
@@ -22166,7 +22514,7 @@
 </p:sld>
 </file>
 
-<file path=ppt/slides/slide57.xml><?xml version="1.0" encoding="utf-8"?>
+<file path=ppt/slides/slide59.xml><?xml version="1.0" encoding="utf-8"?>
 <p:sld xmlns:a="http://schemas.openxmlformats.org/drawingml/2006/main" xmlns:r="http://schemas.openxmlformats.org/officeDocument/2006/relationships" xmlns:p="http://schemas.openxmlformats.org/presentationml/2006/main" show="0">
   <p:cSld>
     <p:spTree>
@@ -22313,352 +22661,6 @@
     <p:extLst>
       <p:ext uri="{BB962C8B-B14F-4D97-AF65-F5344CB8AC3E}">
         <p14:creationId xmlns:p14="http://schemas.microsoft.com/office/powerpoint/2010/main" val="2858020355"/>
-      </p:ext>
-    </p:extLst>
-  </p:cSld>
-  <p:clrMapOvr>
-    <a:masterClrMapping/>
-  </p:clrMapOvr>
-</p:sld>
-</file>
-
-<file path=ppt/slides/slide58.xml><?xml version="1.0" encoding="utf-8"?>
-<p:sld xmlns:a="http://schemas.openxmlformats.org/drawingml/2006/main" xmlns:r="http://schemas.openxmlformats.org/officeDocument/2006/relationships" xmlns:p="http://schemas.openxmlformats.org/presentationml/2006/main" show="0">
-  <p:cSld>
-    <p:spTree>
-      <p:nvGrpSpPr>
-        <p:cNvPr id="1" name=""/>
-        <p:cNvGrpSpPr/>
-        <p:nvPr/>
-      </p:nvGrpSpPr>
-      <p:grpSpPr>
-        <a:xfrm>
-          <a:off x="0" y="0"/>
-          <a:ext cx="0" cy="0"/>
-          <a:chOff x="0" y="0"/>
-          <a:chExt cx="0" cy="0"/>
-        </a:xfrm>
-      </p:grpSpPr>
-      <p:pic>
-        <p:nvPicPr>
-          <p:cNvPr id="9218" name="Picture 2" descr="C:\Users\LMH\Desktop\env파일 예시.png"/>
-          <p:cNvPicPr>
-            <a:picLocks noChangeAspect="1" noChangeArrowheads="1"/>
-          </p:cNvPicPr>
-          <p:nvPr/>
-        </p:nvPicPr>
-        <p:blipFill>
-          <a:blip r:embed="rId2">
-            <a:extLst>
-              <a:ext uri="{28A0092B-C50C-407E-A947-70E740481C1C}">
-                <a14:useLocalDpi xmlns:a14="http://schemas.microsoft.com/office/drawing/2010/main" val="0"/>
-              </a:ext>
-            </a:extLst>
-          </a:blip>
-          <a:srcRect/>
-          <a:stretch>
-            <a:fillRect/>
-          </a:stretch>
-        </p:blipFill>
-        <p:spPr bwMode="auto">
-          <a:xfrm>
-            <a:off x="504825" y="1027113"/>
-            <a:ext cx="11182350" cy="5048250"/>
-          </a:xfrm>
-          <a:prstGeom prst="rect">
-            <a:avLst/>
-          </a:prstGeom>
-          <a:noFill/>
-          <a:extLst>
-            <a:ext uri="{909E8E84-426E-40DD-AFC4-6F175D3DCCD1}">
-              <a14:hiddenFill xmlns:a14="http://schemas.microsoft.com/office/drawing/2010/main">
-                <a:solidFill>
-                  <a:srgbClr val="FFFFFF"/>
-                </a:solidFill>
-              </a14:hiddenFill>
-            </a:ext>
-          </a:extLst>
-        </p:spPr>
-      </p:pic>
-      <p:sp>
-        <p:nvSpPr>
-          <p:cNvPr id="8" name="제목 1">
-            <a:extLst>
-              <a:ext uri="{FF2B5EF4-FFF2-40B4-BE49-F238E27FC236}">
-                <a16:creationId xmlns:a16="http://schemas.microsoft.com/office/drawing/2014/main" id="{6D9F5082-6D2D-1334-803D-26AD15DE1A14}"/>
-              </a:ext>
-            </a:extLst>
-          </p:cNvPr>
-          <p:cNvSpPr>
-            <a:spLocks noGrp="1"/>
-          </p:cNvSpPr>
-          <p:nvPr>
-            <p:ph type="title"/>
-          </p:nvPr>
-        </p:nvSpPr>
-        <p:spPr>
-          <a:xfrm>
-            <a:off x="251788" y="1"/>
-            <a:ext cx="10515600" cy="1145406"/>
-          </a:xfrm>
-        </p:spPr>
-        <p:txBody>
-          <a:bodyPr>
-            <a:normAutofit/>
-          </a:bodyPr>
-          <a:lstStyle/>
-          <a:p>
-            <a:r>
-              <a:rPr lang="en-US" altLang="ko-KR" b="1" dirty="0"/>
-              <a:t>.</a:t>
-            </a:r>
-            <a:r>
-              <a:rPr lang="en-US" altLang="ko-KR" b="1" dirty="0" err="1"/>
-              <a:t>env</a:t>
-            </a:r>
-            <a:r>
-              <a:rPr lang="en-US" altLang="ko-KR" b="1" dirty="0"/>
-              <a:t> </a:t>
-            </a:r>
-            <a:r>
-              <a:rPr lang="ko-KR" altLang="en-US" b="1" dirty="0"/>
-              <a:t>적용</a:t>
-            </a:r>
-            <a:endParaRPr lang="en-US" altLang="ko-KR" b="1" dirty="0"/>
-          </a:p>
-        </p:txBody>
-      </p:sp>
-      <p:sp>
-        <p:nvSpPr>
-          <p:cNvPr id="6" name="내용 개체 틀 2">
-            <a:extLst>
-              <a:ext uri="{FF2B5EF4-FFF2-40B4-BE49-F238E27FC236}">
-                <a16:creationId xmlns:a16="http://schemas.microsoft.com/office/drawing/2014/main" id="{407E1561-0C25-F773-6327-83DD2B85268B}"/>
-              </a:ext>
-            </a:extLst>
-          </p:cNvPr>
-          <p:cNvSpPr>
-            <a:spLocks noGrp="1"/>
-          </p:cNvSpPr>
-          <p:nvPr>
-            <p:ph idx="1"/>
-          </p:nvPr>
-        </p:nvSpPr>
-        <p:spPr>
-          <a:xfrm>
-            <a:off x="1198979" y="1380924"/>
-            <a:ext cx="9470291" cy="729691"/>
-          </a:xfrm>
-        </p:spPr>
-        <p:txBody>
-          <a:bodyPr>
-            <a:noAutofit/>
-          </a:bodyPr>
-          <a:lstStyle/>
-          <a:p>
-            <a:pPr marL="0" indent="0">
-              <a:buNone/>
-            </a:pPr>
-            <a:r>
-              <a:rPr lang="ko-KR" altLang="en-US" dirty="0"/>
-              <a:t>✅ </a:t>
-            </a:r>
-            <a:r>
-              <a:rPr lang="en-US" altLang="ko-KR" dirty="0"/>
-              <a:t>.</a:t>
-            </a:r>
-            <a:r>
-              <a:rPr lang="en-US" altLang="ko-KR" dirty="0" err="1"/>
-              <a:t>env</a:t>
-            </a:r>
-            <a:r>
-              <a:rPr lang="en-US" altLang="ko-KR" dirty="0"/>
-              <a:t> </a:t>
-            </a:r>
-            <a:r>
-              <a:rPr lang="ko-KR" altLang="en-US" dirty="0"/>
-              <a:t>파일 생성</a:t>
-            </a:r>
-          </a:p>
-        </p:txBody>
-      </p:sp>
-    </p:spTree>
-    <p:extLst>
-      <p:ext uri="{BB962C8B-B14F-4D97-AF65-F5344CB8AC3E}">
-        <p14:creationId xmlns:p14="http://schemas.microsoft.com/office/powerpoint/2010/main" val="4186921173"/>
-      </p:ext>
-    </p:extLst>
-  </p:cSld>
-  <p:clrMapOvr>
-    <a:masterClrMapping/>
-  </p:clrMapOvr>
-</p:sld>
-</file>
-
-<file path=ppt/slides/slide59.xml><?xml version="1.0" encoding="utf-8"?>
-<p:sld xmlns:a="http://schemas.openxmlformats.org/drawingml/2006/main" xmlns:r="http://schemas.openxmlformats.org/officeDocument/2006/relationships" xmlns:p="http://schemas.openxmlformats.org/presentationml/2006/main" show="0">
-  <p:cSld>
-    <p:spTree>
-      <p:nvGrpSpPr>
-        <p:cNvPr id="1" name=""/>
-        <p:cNvGrpSpPr/>
-        <p:nvPr/>
-      </p:nvGrpSpPr>
-      <p:grpSpPr>
-        <a:xfrm>
-          <a:off x="0" y="0"/>
-          <a:ext cx="0" cy="0"/>
-          <a:chOff x="0" y="0"/>
-          <a:chExt cx="0" cy="0"/>
-        </a:xfrm>
-      </p:grpSpPr>
-      <p:pic>
-        <p:nvPicPr>
-          <p:cNvPr id="10242" name="Picture 2" descr="C:\Users\LMH\Desktop\env로드.png"/>
-          <p:cNvPicPr>
-            <a:picLocks noChangeAspect="1" noChangeArrowheads="1"/>
-          </p:cNvPicPr>
-          <p:nvPr/>
-        </p:nvPicPr>
-        <p:blipFill>
-          <a:blip r:embed="rId2">
-            <a:extLst>
-              <a:ext uri="{28A0092B-C50C-407E-A947-70E740481C1C}">
-                <a14:useLocalDpi xmlns:a14="http://schemas.microsoft.com/office/drawing/2010/main" val="0"/>
-              </a:ext>
-            </a:extLst>
-          </a:blip>
-          <a:srcRect/>
-          <a:stretch>
-            <a:fillRect/>
-          </a:stretch>
-        </p:blipFill>
-        <p:spPr bwMode="auto">
-          <a:xfrm>
-            <a:off x="731520" y="660698"/>
-            <a:ext cx="10728960" cy="6311154"/>
-          </a:xfrm>
-          <a:prstGeom prst="rect">
-            <a:avLst/>
-          </a:prstGeom>
-          <a:noFill/>
-          <a:extLst>
-            <a:ext uri="{909E8E84-426E-40DD-AFC4-6F175D3DCCD1}">
-              <a14:hiddenFill xmlns:a14="http://schemas.microsoft.com/office/drawing/2010/main">
-                <a:solidFill>
-                  <a:srgbClr val="FFFFFF"/>
-                </a:solidFill>
-              </a14:hiddenFill>
-            </a:ext>
-          </a:extLst>
-        </p:spPr>
-      </p:pic>
-      <p:sp>
-        <p:nvSpPr>
-          <p:cNvPr id="8" name="제목 1">
-            <a:extLst>
-              <a:ext uri="{FF2B5EF4-FFF2-40B4-BE49-F238E27FC236}">
-                <a16:creationId xmlns:a16="http://schemas.microsoft.com/office/drawing/2014/main" id="{6D9F5082-6D2D-1334-803D-26AD15DE1A14}"/>
-              </a:ext>
-            </a:extLst>
-          </p:cNvPr>
-          <p:cNvSpPr>
-            <a:spLocks noGrp="1"/>
-          </p:cNvSpPr>
-          <p:nvPr>
-            <p:ph type="title"/>
-          </p:nvPr>
-        </p:nvSpPr>
-        <p:spPr>
-          <a:xfrm>
-            <a:off x="251788" y="1"/>
-            <a:ext cx="10515600" cy="1145406"/>
-          </a:xfrm>
-        </p:spPr>
-        <p:txBody>
-          <a:bodyPr>
-            <a:normAutofit/>
-          </a:bodyPr>
-          <a:lstStyle/>
-          <a:p>
-            <a:r>
-              <a:rPr lang="en-US" altLang="ko-KR" b="1" dirty="0"/>
-              <a:t>.</a:t>
-            </a:r>
-            <a:r>
-              <a:rPr lang="en-US" altLang="ko-KR" b="1" dirty="0" err="1"/>
-              <a:t>env</a:t>
-            </a:r>
-            <a:r>
-              <a:rPr lang="en-US" altLang="ko-KR" b="1" dirty="0"/>
-              <a:t> </a:t>
-            </a:r>
-            <a:r>
-              <a:rPr lang="ko-KR" altLang="en-US" b="1" dirty="0"/>
-              <a:t>적용</a:t>
-            </a:r>
-            <a:endParaRPr lang="en-US" altLang="ko-KR" b="1" dirty="0"/>
-          </a:p>
-        </p:txBody>
-      </p:sp>
-      <p:sp>
-        <p:nvSpPr>
-          <p:cNvPr id="6" name="내용 개체 틀 2">
-            <a:extLst>
-              <a:ext uri="{FF2B5EF4-FFF2-40B4-BE49-F238E27FC236}">
-                <a16:creationId xmlns:a16="http://schemas.microsoft.com/office/drawing/2014/main" id="{407E1561-0C25-F773-6327-83DD2B85268B}"/>
-              </a:ext>
-            </a:extLst>
-          </p:cNvPr>
-          <p:cNvSpPr>
-            <a:spLocks noGrp="1"/>
-          </p:cNvSpPr>
-          <p:nvPr>
-            <p:ph idx="1"/>
-          </p:nvPr>
-        </p:nvSpPr>
-        <p:spPr>
-          <a:xfrm>
-            <a:off x="1360854" y="940234"/>
-            <a:ext cx="9470291" cy="729691"/>
-          </a:xfrm>
-        </p:spPr>
-        <p:txBody>
-          <a:bodyPr>
-            <a:noAutofit/>
-          </a:bodyPr>
-          <a:lstStyle/>
-          <a:p>
-            <a:pPr marL="0" indent="0">
-              <a:buNone/>
-            </a:pPr>
-            <a:r>
-              <a:rPr lang="ko-KR" altLang="en-US" dirty="0"/>
-              <a:t>✅ </a:t>
-            </a:r>
-            <a:r>
-              <a:rPr lang="en-US" altLang="ko-KR" dirty="0"/>
-              <a:t>.</a:t>
-            </a:r>
-            <a:r>
-              <a:rPr lang="en-US" altLang="ko-KR" dirty="0" err="1"/>
-              <a:t>env</a:t>
-            </a:r>
-            <a:r>
-              <a:rPr lang="en-US" altLang="ko-KR" dirty="0"/>
-              <a:t> </a:t>
-            </a:r>
-            <a:r>
-              <a:rPr lang="ko-KR" altLang="en-US" dirty="0"/>
-              <a:t>환경 변수 사용하기</a:t>
-            </a:r>
-          </a:p>
-        </p:txBody>
-      </p:sp>
-    </p:spTree>
-    <p:extLst>
-      <p:ext uri="{BB962C8B-B14F-4D97-AF65-F5344CB8AC3E}">
-        <p14:creationId xmlns:p14="http://schemas.microsoft.com/office/powerpoint/2010/main" val="3569529574"/>
       </p:ext>
     </p:extLst>
   </p:cSld>
@@ -23102,6 +23104,352 @@
       </p:grpSpPr>
       <p:pic>
         <p:nvPicPr>
+          <p:cNvPr id="9218" name="Picture 2" descr="C:\Users\LMH\Desktop\env파일 예시.png"/>
+          <p:cNvPicPr>
+            <a:picLocks noChangeAspect="1" noChangeArrowheads="1"/>
+          </p:cNvPicPr>
+          <p:nvPr/>
+        </p:nvPicPr>
+        <p:blipFill>
+          <a:blip r:embed="rId2">
+            <a:extLst>
+              <a:ext uri="{28A0092B-C50C-407E-A947-70E740481C1C}">
+                <a14:useLocalDpi xmlns:a14="http://schemas.microsoft.com/office/drawing/2010/main" val="0"/>
+              </a:ext>
+            </a:extLst>
+          </a:blip>
+          <a:srcRect/>
+          <a:stretch>
+            <a:fillRect/>
+          </a:stretch>
+        </p:blipFill>
+        <p:spPr bwMode="auto">
+          <a:xfrm>
+            <a:off x="504825" y="1027113"/>
+            <a:ext cx="11182350" cy="5048250"/>
+          </a:xfrm>
+          <a:prstGeom prst="rect">
+            <a:avLst/>
+          </a:prstGeom>
+          <a:noFill/>
+          <a:extLst>
+            <a:ext uri="{909E8E84-426E-40DD-AFC4-6F175D3DCCD1}">
+              <a14:hiddenFill xmlns:a14="http://schemas.microsoft.com/office/drawing/2010/main">
+                <a:solidFill>
+                  <a:srgbClr val="FFFFFF"/>
+                </a:solidFill>
+              </a14:hiddenFill>
+            </a:ext>
+          </a:extLst>
+        </p:spPr>
+      </p:pic>
+      <p:sp>
+        <p:nvSpPr>
+          <p:cNvPr id="8" name="제목 1">
+            <a:extLst>
+              <a:ext uri="{FF2B5EF4-FFF2-40B4-BE49-F238E27FC236}">
+                <a16:creationId xmlns:a16="http://schemas.microsoft.com/office/drawing/2014/main" id="{6D9F5082-6D2D-1334-803D-26AD15DE1A14}"/>
+              </a:ext>
+            </a:extLst>
+          </p:cNvPr>
+          <p:cNvSpPr>
+            <a:spLocks noGrp="1"/>
+          </p:cNvSpPr>
+          <p:nvPr>
+            <p:ph type="title"/>
+          </p:nvPr>
+        </p:nvSpPr>
+        <p:spPr>
+          <a:xfrm>
+            <a:off x="251788" y="1"/>
+            <a:ext cx="10515600" cy="1145406"/>
+          </a:xfrm>
+        </p:spPr>
+        <p:txBody>
+          <a:bodyPr>
+            <a:normAutofit/>
+          </a:bodyPr>
+          <a:lstStyle/>
+          <a:p>
+            <a:r>
+              <a:rPr lang="en-US" altLang="ko-KR" b="1" dirty="0"/>
+              <a:t>.</a:t>
+            </a:r>
+            <a:r>
+              <a:rPr lang="en-US" altLang="ko-KR" b="1" dirty="0" err="1"/>
+              <a:t>env</a:t>
+            </a:r>
+            <a:r>
+              <a:rPr lang="en-US" altLang="ko-KR" b="1" dirty="0"/>
+              <a:t> </a:t>
+            </a:r>
+            <a:r>
+              <a:rPr lang="ko-KR" altLang="en-US" b="1" dirty="0"/>
+              <a:t>적용</a:t>
+            </a:r>
+            <a:endParaRPr lang="en-US" altLang="ko-KR" b="1" dirty="0"/>
+          </a:p>
+        </p:txBody>
+      </p:sp>
+      <p:sp>
+        <p:nvSpPr>
+          <p:cNvPr id="6" name="내용 개체 틀 2">
+            <a:extLst>
+              <a:ext uri="{FF2B5EF4-FFF2-40B4-BE49-F238E27FC236}">
+                <a16:creationId xmlns:a16="http://schemas.microsoft.com/office/drawing/2014/main" id="{407E1561-0C25-F773-6327-83DD2B85268B}"/>
+              </a:ext>
+            </a:extLst>
+          </p:cNvPr>
+          <p:cNvSpPr>
+            <a:spLocks noGrp="1"/>
+          </p:cNvSpPr>
+          <p:nvPr>
+            <p:ph idx="1"/>
+          </p:nvPr>
+        </p:nvSpPr>
+        <p:spPr>
+          <a:xfrm>
+            <a:off x="1198979" y="1380924"/>
+            <a:ext cx="9470291" cy="729691"/>
+          </a:xfrm>
+        </p:spPr>
+        <p:txBody>
+          <a:bodyPr>
+            <a:noAutofit/>
+          </a:bodyPr>
+          <a:lstStyle/>
+          <a:p>
+            <a:pPr marL="0" indent="0">
+              <a:buNone/>
+            </a:pPr>
+            <a:r>
+              <a:rPr lang="ko-KR" altLang="en-US" dirty="0"/>
+              <a:t>✅ </a:t>
+            </a:r>
+            <a:r>
+              <a:rPr lang="en-US" altLang="ko-KR" dirty="0"/>
+              <a:t>.</a:t>
+            </a:r>
+            <a:r>
+              <a:rPr lang="en-US" altLang="ko-KR" dirty="0" err="1"/>
+              <a:t>env</a:t>
+            </a:r>
+            <a:r>
+              <a:rPr lang="en-US" altLang="ko-KR" dirty="0"/>
+              <a:t> </a:t>
+            </a:r>
+            <a:r>
+              <a:rPr lang="ko-KR" altLang="en-US" dirty="0"/>
+              <a:t>파일 생성</a:t>
+            </a:r>
+          </a:p>
+        </p:txBody>
+      </p:sp>
+    </p:spTree>
+    <p:extLst>
+      <p:ext uri="{BB962C8B-B14F-4D97-AF65-F5344CB8AC3E}">
+        <p14:creationId xmlns:p14="http://schemas.microsoft.com/office/powerpoint/2010/main" val="4186921173"/>
+      </p:ext>
+    </p:extLst>
+  </p:cSld>
+  <p:clrMapOvr>
+    <a:masterClrMapping/>
+  </p:clrMapOvr>
+</p:sld>
+</file>
+
+<file path=ppt/slides/slide61.xml><?xml version="1.0" encoding="utf-8"?>
+<p:sld xmlns:a="http://schemas.openxmlformats.org/drawingml/2006/main" xmlns:r="http://schemas.openxmlformats.org/officeDocument/2006/relationships" xmlns:p="http://schemas.openxmlformats.org/presentationml/2006/main" show="0">
+  <p:cSld>
+    <p:spTree>
+      <p:nvGrpSpPr>
+        <p:cNvPr id="1" name=""/>
+        <p:cNvGrpSpPr/>
+        <p:nvPr/>
+      </p:nvGrpSpPr>
+      <p:grpSpPr>
+        <a:xfrm>
+          <a:off x="0" y="0"/>
+          <a:ext cx="0" cy="0"/>
+          <a:chOff x="0" y="0"/>
+          <a:chExt cx="0" cy="0"/>
+        </a:xfrm>
+      </p:grpSpPr>
+      <p:pic>
+        <p:nvPicPr>
+          <p:cNvPr id="10242" name="Picture 2" descr="C:\Users\LMH\Desktop\env로드.png"/>
+          <p:cNvPicPr>
+            <a:picLocks noChangeAspect="1" noChangeArrowheads="1"/>
+          </p:cNvPicPr>
+          <p:nvPr/>
+        </p:nvPicPr>
+        <p:blipFill>
+          <a:blip r:embed="rId2">
+            <a:extLst>
+              <a:ext uri="{28A0092B-C50C-407E-A947-70E740481C1C}">
+                <a14:useLocalDpi xmlns:a14="http://schemas.microsoft.com/office/drawing/2010/main" val="0"/>
+              </a:ext>
+            </a:extLst>
+          </a:blip>
+          <a:srcRect/>
+          <a:stretch>
+            <a:fillRect/>
+          </a:stretch>
+        </p:blipFill>
+        <p:spPr bwMode="auto">
+          <a:xfrm>
+            <a:off x="731520" y="660698"/>
+            <a:ext cx="10728960" cy="6311154"/>
+          </a:xfrm>
+          <a:prstGeom prst="rect">
+            <a:avLst/>
+          </a:prstGeom>
+          <a:noFill/>
+          <a:extLst>
+            <a:ext uri="{909E8E84-426E-40DD-AFC4-6F175D3DCCD1}">
+              <a14:hiddenFill xmlns:a14="http://schemas.microsoft.com/office/drawing/2010/main">
+                <a:solidFill>
+                  <a:srgbClr val="FFFFFF"/>
+                </a:solidFill>
+              </a14:hiddenFill>
+            </a:ext>
+          </a:extLst>
+        </p:spPr>
+      </p:pic>
+      <p:sp>
+        <p:nvSpPr>
+          <p:cNvPr id="8" name="제목 1">
+            <a:extLst>
+              <a:ext uri="{FF2B5EF4-FFF2-40B4-BE49-F238E27FC236}">
+                <a16:creationId xmlns:a16="http://schemas.microsoft.com/office/drawing/2014/main" id="{6D9F5082-6D2D-1334-803D-26AD15DE1A14}"/>
+              </a:ext>
+            </a:extLst>
+          </p:cNvPr>
+          <p:cNvSpPr>
+            <a:spLocks noGrp="1"/>
+          </p:cNvSpPr>
+          <p:nvPr>
+            <p:ph type="title"/>
+          </p:nvPr>
+        </p:nvSpPr>
+        <p:spPr>
+          <a:xfrm>
+            <a:off x="251788" y="1"/>
+            <a:ext cx="10515600" cy="1145406"/>
+          </a:xfrm>
+        </p:spPr>
+        <p:txBody>
+          <a:bodyPr>
+            <a:normAutofit/>
+          </a:bodyPr>
+          <a:lstStyle/>
+          <a:p>
+            <a:r>
+              <a:rPr lang="en-US" altLang="ko-KR" b="1" dirty="0"/>
+              <a:t>.</a:t>
+            </a:r>
+            <a:r>
+              <a:rPr lang="en-US" altLang="ko-KR" b="1" dirty="0" err="1"/>
+              <a:t>env</a:t>
+            </a:r>
+            <a:r>
+              <a:rPr lang="en-US" altLang="ko-KR" b="1" dirty="0"/>
+              <a:t> </a:t>
+            </a:r>
+            <a:r>
+              <a:rPr lang="ko-KR" altLang="en-US" b="1" dirty="0"/>
+              <a:t>적용</a:t>
+            </a:r>
+            <a:endParaRPr lang="en-US" altLang="ko-KR" b="1" dirty="0"/>
+          </a:p>
+        </p:txBody>
+      </p:sp>
+      <p:sp>
+        <p:nvSpPr>
+          <p:cNvPr id="6" name="내용 개체 틀 2">
+            <a:extLst>
+              <a:ext uri="{FF2B5EF4-FFF2-40B4-BE49-F238E27FC236}">
+                <a16:creationId xmlns:a16="http://schemas.microsoft.com/office/drawing/2014/main" id="{407E1561-0C25-F773-6327-83DD2B85268B}"/>
+              </a:ext>
+            </a:extLst>
+          </p:cNvPr>
+          <p:cNvSpPr>
+            <a:spLocks noGrp="1"/>
+          </p:cNvSpPr>
+          <p:nvPr>
+            <p:ph idx="1"/>
+          </p:nvPr>
+        </p:nvSpPr>
+        <p:spPr>
+          <a:xfrm>
+            <a:off x="1360854" y="940234"/>
+            <a:ext cx="9470291" cy="729691"/>
+          </a:xfrm>
+        </p:spPr>
+        <p:txBody>
+          <a:bodyPr>
+            <a:noAutofit/>
+          </a:bodyPr>
+          <a:lstStyle/>
+          <a:p>
+            <a:pPr marL="0" indent="0">
+              <a:buNone/>
+            </a:pPr>
+            <a:r>
+              <a:rPr lang="ko-KR" altLang="en-US" dirty="0"/>
+              <a:t>✅ </a:t>
+            </a:r>
+            <a:r>
+              <a:rPr lang="en-US" altLang="ko-KR" dirty="0"/>
+              <a:t>.</a:t>
+            </a:r>
+            <a:r>
+              <a:rPr lang="en-US" altLang="ko-KR" dirty="0" err="1"/>
+              <a:t>env</a:t>
+            </a:r>
+            <a:r>
+              <a:rPr lang="en-US" altLang="ko-KR" dirty="0"/>
+              <a:t> </a:t>
+            </a:r>
+            <a:r>
+              <a:rPr lang="ko-KR" altLang="en-US" dirty="0"/>
+              <a:t>환경 변수 사용하기</a:t>
+            </a:r>
+          </a:p>
+        </p:txBody>
+      </p:sp>
+    </p:spTree>
+    <p:extLst>
+      <p:ext uri="{BB962C8B-B14F-4D97-AF65-F5344CB8AC3E}">
+        <p14:creationId xmlns:p14="http://schemas.microsoft.com/office/powerpoint/2010/main" val="3569529574"/>
+      </p:ext>
+    </p:extLst>
+  </p:cSld>
+  <p:clrMapOvr>
+    <a:masterClrMapping/>
+  </p:clrMapOvr>
+</p:sld>
+</file>
+
+<file path=ppt/slides/slide62.xml><?xml version="1.0" encoding="utf-8"?>
+<p:sld xmlns:a="http://schemas.openxmlformats.org/drawingml/2006/main" xmlns:r="http://schemas.openxmlformats.org/officeDocument/2006/relationships" xmlns:p="http://schemas.openxmlformats.org/presentationml/2006/main" show="0">
+  <p:cSld>
+    <p:spTree>
+      <p:nvGrpSpPr>
+        <p:cNvPr id="1" name=""/>
+        <p:cNvGrpSpPr/>
+        <p:nvPr/>
+      </p:nvGrpSpPr>
+      <p:grpSpPr>
+        <a:xfrm>
+          <a:off x="0" y="0"/>
+          <a:ext cx="0" cy="0"/>
+          <a:chOff x="0" y="0"/>
+          <a:chExt cx="0" cy="0"/>
+        </a:xfrm>
+      </p:grpSpPr>
+      <p:pic>
+        <p:nvPicPr>
           <p:cNvPr id="11266" name="Picture 2" descr="C:\Users\LMH\Desktop\gitignore에추가.png"/>
           <p:cNvPicPr>
             <a:picLocks noChangeAspect="1" noChangeArrowheads="1"/>
@@ -23248,7 +23596,7 @@
 </p:sld>
 </file>
 
-<file path=ppt/slides/slide61.xml><?xml version="1.0" encoding="utf-8"?>
+<file path=ppt/slides/slide63.xml><?xml version="1.0" encoding="utf-8"?>
 <p:sld xmlns:a="http://schemas.openxmlformats.org/drawingml/2006/main" xmlns:r="http://schemas.openxmlformats.org/officeDocument/2006/relationships" xmlns:p="http://schemas.openxmlformats.org/presentationml/2006/main">
   <p:cSld>
     <p:spTree>

</xml_diff>